<commit_message>
docs: Day 2 complete
260206-kaggle pandas learn recorded
</commit_message>
<xml_diff>
--- a/Kaggle!.pptx
+++ b/Kaggle!.pptx
@@ -5,7 +5,7 @@
     <p:sldMasterId id="2147483648" r:id="rId1"/>
   </p:sldMasterIdLst>
   <p:notesMasterIdLst>
-    <p:notesMasterId r:id="rId15"/>
+    <p:notesMasterId r:id="rId25"/>
   </p:notesMasterIdLst>
   <p:sldIdLst>
     <p:sldId id="256" r:id="rId2"/>
@@ -21,6 +21,16 @@
     <p:sldId id="266" r:id="rId12"/>
     <p:sldId id="267" r:id="rId13"/>
     <p:sldId id="268" r:id="rId14"/>
+    <p:sldId id="269" r:id="rId15"/>
+    <p:sldId id="272" r:id="rId16"/>
+    <p:sldId id="271" r:id="rId17"/>
+    <p:sldId id="275" r:id="rId18"/>
+    <p:sldId id="276" r:id="rId19"/>
+    <p:sldId id="270" r:id="rId20"/>
+    <p:sldId id="273" r:id="rId21"/>
+    <p:sldId id="277" r:id="rId22"/>
+    <p:sldId id="279" r:id="rId23"/>
+    <p:sldId id="274" r:id="rId24"/>
   </p:sldIdLst>
   <p:sldSz cx="12192000" cy="6858000"/>
   <p:notesSz cx="6858000" cy="9144000"/>
@@ -209,7 +219,7 @@
           <a:p>
             <a:fld id="{696CDF9F-ADA0-4C49-A263-B2AE48107B92}" type="datetimeFigureOut">
               <a:rPr lang="en-US" smtClean="0"/>
-              <a:t>1/30/2026</a:t>
+              <a:t>2/6/2026</a:t>
             </a:fld>
             <a:endParaRPr lang="en-US"/>
           </a:p>
@@ -560,6 +570,90 @@
 </p:notes>
 </file>
 
+<file path=ppt/notesSlides/notesSlide2.xml><?xml version="1.0" encoding="utf-8"?>
+<p:notes xmlns:a="http://schemas.openxmlformats.org/drawingml/2006/main" xmlns:r="http://schemas.openxmlformats.org/officeDocument/2006/relationships" xmlns:p="http://schemas.openxmlformats.org/presentationml/2006/main">
+  <p:cSld>
+    <p:spTree>
+      <p:nvGrpSpPr>
+        <p:cNvPr id="1" name=""/>
+        <p:cNvGrpSpPr/>
+        <p:nvPr/>
+      </p:nvGrpSpPr>
+      <p:grpSpPr>
+        <a:xfrm>
+          <a:off x="0" y="0"/>
+          <a:ext cx="0" cy="0"/>
+          <a:chOff x="0" y="0"/>
+          <a:chExt cx="0" cy="0"/>
+        </a:xfrm>
+      </p:grpSpPr>
+      <p:sp>
+        <p:nvSpPr>
+          <p:cNvPr id="2" name="Slide Image Placeholder 1"/>
+          <p:cNvSpPr>
+            <a:spLocks noGrp="1" noRot="1" noChangeAspect="1"/>
+          </p:cNvSpPr>
+          <p:nvPr>
+            <p:ph type="sldImg"/>
+          </p:nvPr>
+        </p:nvSpPr>
+        <p:spPr/>
+      </p:sp>
+      <p:sp>
+        <p:nvSpPr>
+          <p:cNvPr id="3" name="Notes Placeholder 2"/>
+          <p:cNvSpPr>
+            <a:spLocks noGrp="1"/>
+          </p:cNvSpPr>
+          <p:nvPr>
+            <p:ph type="body" idx="1"/>
+          </p:nvPr>
+        </p:nvSpPr>
+        <p:spPr/>
+        <p:txBody>
+          <a:bodyPr/>
+          <a:lstStyle/>
+          <a:p>
+            <a:endParaRPr lang="en-US"/>
+          </a:p>
+        </p:txBody>
+      </p:sp>
+      <p:sp>
+        <p:nvSpPr>
+          <p:cNvPr id="4" name="Slide Number Placeholder 3"/>
+          <p:cNvSpPr>
+            <a:spLocks noGrp="1"/>
+          </p:cNvSpPr>
+          <p:nvPr>
+            <p:ph type="sldNum" sz="quarter" idx="5"/>
+          </p:nvPr>
+        </p:nvSpPr>
+        <p:spPr/>
+        <p:txBody>
+          <a:bodyPr/>
+          <a:lstStyle/>
+          <a:p>
+            <a:fld id="{8EC11A69-C4DC-406E-8104-7D6732DB19CE}" type="slidenum">
+              <a:rPr lang="en-US" smtClean="0"/>
+              <a:t>15</a:t>
+            </a:fld>
+            <a:endParaRPr lang="en-US"/>
+          </a:p>
+        </p:txBody>
+      </p:sp>
+    </p:spTree>
+    <p:extLst>
+      <p:ext uri="{BB962C8B-B14F-4D97-AF65-F5344CB8AC3E}">
+        <p14:creationId xmlns:p14="http://schemas.microsoft.com/office/powerpoint/2010/main" val="584755174"/>
+      </p:ext>
+    </p:extLst>
+  </p:cSld>
+  <p:clrMapOvr>
+    <a:masterClrMapping/>
+  </p:clrMapOvr>
+</p:notes>
+</file>
+
 <file path=ppt/slideLayouts/slideLayout1.xml><?xml version="1.0" encoding="utf-8"?>
 <p:sldLayout xmlns:a="http://schemas.openxmlformats.org/drawingml/2006/main" xmlns:r="http://schemas.openxmlformats.org/officeDocument/2006/relationships" xmlns:p="http://schemas.openxmlformats.org/presentationml/2006/main" type="title" preserve="1">
   <p:cSld name="Title Slide">
@@ -707,7 +801,7 @@
           <a:p>
             <a:fld id="{8B8BF7D9-AC52-4AC2-BEDB-A5D1257FD4A4}" type="datetimeFigureOut">
               <a:rPr lang="en-US" smtClean="0"/>
-              <a:t>1/30/2026</a:t>
+              <a:t>2/6/2026</a:t>
             </a:fld>
             <a:endParaRPr lang="en-US"/>
           </a:p>
@@ -905,7 +999,7 @@
           <a:p>
             <a:fld id="{8B8BF7D9-AC52-4AC2-BEDB-A5D1257FD4A4}" type="datetimeFigureOut">
               <a:rPr lang="en-US" smtClean="0"/>
-              <a:t>1/30/2026</a:t>
+              <a:t>2/6/2026</a:t>
             </a:fld>
             <a:endParaRPr lang="en-US"/>
           </a:p>
@@ -1113,7 +1207,7 @@
           <a:p>
             <a:fld id="{8B8BF7D9-AC52-4AC2-BEDB-A5D1257FD4A4}" type="datetimeFigureOut">
               <a:rPr lang="en-US" smtClean="0"/>
-              <a:t>1/30/2026</a:t>
+              <a:t>2/6/2026</a:t>
             </a:fld>
             <a:endParaRPr lang="en-US"/>
           </a:p>
@@ -1311,7 +1405,7 @@
           <a:p>
             <a:fld id="{8B8BF7D9-AC52-4AC2-BEDB-A5D1257FD4A4}" type="datetimeFigureOut">
               <a:rPr lang="en-US" smtClean="0"/>
-              <a:t>1/30/2026</a:t>
+              <a:t>2/6/2026</a:t>
             </a:fld>
             <a:endParaRPr lang="en-US"/>
           </a:p>
@@ -1586,7 +1680,7 @@
           <a:p>
             <a:fld id="{8B8BF7D9-AC52-4AC2-BEDB-A5D1257FD4A4}" type="datetimeFigureOut">
               <a:rPr lang="en-US" smtClean="0"/>
-              <a:t>1/30/2026</a:t>
+              <a:t>2/6/2026</a:t>
             </a:fld>
             <a:endParaRPr lang="en-US"/>
           </a:p>
@@ -1851,7 +1945,7 @@
           <a:p>
             <a:fld id="{8B8BF7D9-AC52-4AC2-BEDB-A5D1257FD4A4}" type="datetimeFigureOut">
               <a:rPr lang="en-US" smtClean="0"/>
-              <a:t>1/30/2026</a:t>
+              <a:t>2/6/2026</a:t>
             </a:fld>
             <a:endParaRPr lang="en-US"/>
           </a:p>
@@ -2263,7 +2357,7 @@
           <a:p>
             <a:fld id="{8B8BF7D9-AC52-4AC2-BEDB-A5D1257FD4A4}" type="datetimeFigureOut">
               <a:rPr lang="en-US" smtClean="0"/>
-              <a:t>1/30/2026</a:t>
+              <a:t>2/6/2026</a:t>
             </a:fld>
             <a:endParaRPr lang="en-US"/>
           </a:p>
@@ -2404,7 +2498,7 @@
           <a:p>
             <a:fld id="{8B8BF7D9-AC52-4AC2-BEDB-A5D1257FD4A4}" type="datetimeFigureOut">
               <a:rPr lang="en-US" smtClean="0"/>
-              <a:t>1/30/2026</a:t>
+              <a:t>2/6/2026</a:t>
             </a:fld>
             <a:endParaRPr lang="en-US"/>
           </a:p>
@@ -2517,7 +2611,7 @@
           <a:p>
             <a:fld id="{8B8BF7D9-AC52-4AC2-BEDB-A5D1257FD4A4}" type="datetimeFigureOut">
               <a:rPr lang="en-US" smtClean="0"/>
-              <a:t>1/30/2026</a:t>
+              <a:t>2/6/2026</a:t>
             </a:fld>
             <a:endParaRPr lang="en-US"/>
           </a:p>
@@ -2828,7 +2922,7 @@
           <a:p>
             <a:fld id="{8B8BF7D9-AC52-4AC2-BEDB-A5D1257FD4A4}" type="datetimeFigureOut">
               <a:rPr lang="en-US" smtClean="0"/>
-              <a:t>1/30/2026</a:t>
+              <a:t>2/6/2026</a:t>
             </a:fld>
             <a:endParaRPr lang="en-US"/>
           </a:p>
@@ -3116,7 +3210,7 @@
           <a:p>
             <a:fld id="{8B8BF7D9-AC52-4AC2-BEDB-A5D1257FD4A4}" type="datetimeFigureOut">
               <a:rPr lang="en-US" smtClean="0"/>
-              <a:t>1/30/2026</a:t>
+              <a:t>2/6/2026</a:t>
             </a:fld>
             <a:endParaRPr lang="en-US"/>
           </a:p>
@@ -3357,7 +3451,7 @@
           <a:p>
             <a:fld id="{8B8BF7D9-AC52-4AC2-BEDB-A5D1257FD4A4}" type="datetimeFigureOut">
               <a:rPr lang="en-US" smtClean="0"/>
-              <a:t>1/30/2026</a:t>
+              <a:t>2/6/2026</a:t>
             </a:fld>
             <a:endParaRPr lang="en-US"/>
           </a:p>
@@ -4407,7 +4501,10 @@
           <a:bodyPr/>
           <a:lstStyle/>
           <a:p>
-            <a:endParaRPr lang="en-US"/>
+            <a:r>
+              <a:rPr lang="en-US"/>
+              <a:t>260206 - Kaggle Pandas Course</a:t>
+            </a:r>
           </a:p>
         </p:txBody>
       </p:sp>
@@ -4431,6 +4528,153 @@
         <p:txBody>
           <a:bodyPr/>
           <a:lstStyle/>
+          <a:p>
+            <a:r>
+              <a:rPr lang="en-US"/>
+              <a:t>6</a:t>
+            </a:r>
+            <a:r>
+              <a:rPr lang="ko-KR" altLang="en-US"/>
+              <a:t>개 </a:t>
+            </a:r>
+            <a:r>
+              <a:rPr lang="en-US" altLang="ko-KR"/>
+              <a:t>sub-category</a:t>
+            </a:r>
+            <a:r>
+              <a:rPr lang="ko-KR" altLang="en-US"/>
+              <a:t>가 존재한다</a:t>
+            </a:r>
+            <a:r>
+              <a:rPr lang="en-US" altLang="ko-KR"/>
+              <a:t>.</a:t>
+            </a:r>
+          </a:p>
+          <a:p>
+            <a:pPr marL="914400" lvl="1" indent="-457200">
+              <a:buFont typeface="+mj-lt"/>
+              <a:buAutoNum type="arabicPeriod"/>
+            </a:pPr>
+            <a:r>
+              <a:rPr lang="en-US"/>
+              <a:t>Creating,</a:t>
+            </a:r>
+            <a:r>
+              <a:rPr lang="ko-KR" altLang="en-US"/>
+              <a:t> </a:t>
+            </a:r>
+            <a:r>
+              <a:rPr lang="en-US" altLang="ko-KR"/>
+              <a:t>Reading</a:t>
+            </a:r>
+            <a:r>
+              <a:rPr lang="ko-KR" altLang="en-US"/>
+              <a:t> </a:t>
+            </a:r>
+            <a:r>
+              <a:rPr lang="en-US" altLang="ko-KR"/>
+              <a:t>ad</a:t>
+            </a:r>
+            <a:r>
+              <a:rPr lang="ko-KR" altLang="en-US"/>
+              <a:t> </a:t>
+            </a:r>
+            <a:r>
+              <a:rPr lang="en-US" altLang="ko-KR"/>
+              <a:t>Writing</a:t>
+            </a:r>
+          </a:p>
+          <a:p>
+            <a:pPr marL="914400" lvl="1" indent="-457200">
+              <a:buFont typeface="+mj-lt"/>
+              <a:buAutoNum type="arabicPeriod"/>
+            </a:pPr>
+            <a:r>
+              <a:rPr lang="en-US"/>
+              <a:t>Indexing, Selecting &amp; Assigning</a:t>
+            </a:r>
+          </a:p>
+          <a:p>
+            <a:pPr marL="914400" lvl="1" indent="-457200">
+              <a:buFont typeface="+mj-lt"/>
+              <a:buAutoNum type="arabicPeriod"/>
+            </a:pPr>
+            <a:r>
+              <a:rPr lang="en-US"/>
+              <a:t>Summary Functions and Maps</a:t>
+            </a:r>
+          </a:p>
+          <a:p>
+            <a:pPr marL="914400" lvl="1" indent="-457200">
+              <a:buFont typeface="+mj-lt"/>
+              <a:buAutoNum type="arabicPeriod"/>
+            </a:pPr>
+            <a:r>
+              <a:rPr lang="en-US"/>
+              <a:t>Grouping and Sorting</a:t>
+            </a:r>
+          </a:p>
+          <a:p>
+            <a:pPr marL="914400" lvl="1" indent="-457200">
+              <a:buFont typeface="+mj-lt"/>
+              <a:buAutoNum type="arabicPeriod"/>
+            </a:pPr>
+            <a:r>
+              <a:rPr lang="en-US"/>
+              <a:t>Data Types and Missing Values</a:t>
+            </a:r>
+          </a:p>
+          <a:p>
+            <a:pPr marL="914400" lvl="1" indent="-457200">
+              <a:buFont typeface="+mj-lt"/>
+              <a:buAutoNum type="arabicPeriod"/>
+            </a:pPr>
+            <a:r>
+              <a:rPr lang="en-US"/>
+              <a:t>Renaming and Combining</a:t>
+            </a:r>
+          </a:p>
+          <a:p>
+            <a:r>
+              <a:rPr lang="ko-KR" altLang="en-US"/>
+              <a:t>오전</a:t>
+            </a:r>
+            <a:r>
+              <a:rPr lang="en-US" altLang="ko-KR"/>
+              <a:t>: 1, 2</a:t>
+            </a:r>
+            <a:r>
+              <a:rPr lang="ko-KR" altLang="en-US"/>
+              <a:t>번을 했다</a:t>
+            </a:r>
+            <a:r>
+              <a:rPr lang="en-US" altLang="ko-KR"/>
+              <a:t>.</a:t>
+            </a:r>
+          </a:p>
+          <a:p>
+            <a:r>
+              <a:rPr lang="ko-KR" altLang="en-US"/>
+              <a:t>오후</a:t>
+            </a:r>
+            <a:r>
+              <a:rPr lang="en-US" altLang="ko-KR"/>
+              <a:t>: 3</a:t>
+            </a:r>
+            <a:r>
+              <a:rPr lang="ko-KR" altLang="en-US"/>
+              <a:t>번 겨우 끝내고 </a:t>
+            </a:r>
+            <a:r>
+              <a:rPr lang="en-US" altLang="ko-KR"/>
+              <a:t>4</a:t>
+            </a:r>
+            <a:r>
+              <a:rPr lang="ko-KR" altLang="en-US"/>
+              <a:t>번 시도하다가 못하는거 알고 일단 여기까지함</a:t>
+            </a:r>
+            <a:endParaRPr lang="en-US" altLang="ko-KR"/>
+          </a:p>
           <a:p>
             <a:endParaRPr lang="en-US"/>
           </a:p>
@@ -4440,6 +4684,1599 @@
     <p:extLst>
       <p:ext uri="{BB962C8B-B14F-4D97-AF65-F5344CB8AC3E}">
         <p14:creationId xmlns:p14="http://schemas.microsoft.com/office/powerpoint/2010/main" val="1440839395"/>
+      </p:ext>
+    </p:extLst>
+  </p:cSld>
+  <p:clrMapOvr>
+    <a:masterClrMapping/>
+  </p:clrMapOvr>
+</p:sld>
+</file>
+
+<file path=ppt/slides/slide14.xml><?xml version="1.0" encoding="utf-8"?>
+<p:sld xmlns:a="http://schemas.openxmlformats.org/drawingml/2006/main" xmlns:r="http://schemas.openxmlformats.org/officeDocument/2006/relationships" xmlns:p="http://schemas.openxmlformats.org/presentationml/2006/main">
+  <p:cSld>
+    <p:spTree>
+      <p:nvGrpSpPr>
+        <p:cNvPr id="1" name=""/>
+        <p:cNvGrpSpPr/>
+        <p:nvPr/>
+      </p:nvGrpSpPr>
+      <p:grpSpPr>
+        <a:xfrm>
+          <a:off x="0" y="0"/>
+          <a:ext cx="0" cy="0"/>
+          <a:chOff x="0" y="0"/>
+          <a:chExt cx="0" cy="0"/>
+        </a:xfrm>
+      </p:grpSpPr>
+      <p:sp>
+        <p:nvSpPr>
+          <p:cNvPr id="2" name="Title 1">
+            <a:extLst>
+              <a:ext uri="{FF2B5EF4-FFF2-40B4-BE49-F238E27FC236}">
+                <a16:creationId xmlns:a16="http://schemas.microsoft.com/office/drawing/2014/main" id="{CCAD9A87-388C-78BF-D35F-A4A0089F41F0}"/>
+              </a:ext>
+            </a:extLst>
+          </p:cNvPr>
+          <p:cNvSpPr>
+            <a:spLocks noGrp="1"/>
+          </p:cNvSpPr>
+          <p:nvPr>
+            <p:ph type="title"/>
+          </p:nvPr>
+        </p:nvSpPr>
+        <p:spPr/>
+        <p:txBody>
+          <a:bodyPr>
+            <a:normAutofit fontScale="90000"/>
+          </a:bodyPr>
+          <a:lstStyle/>
+          <a:p>
+            <a:r>
+              <a:rPr lang="ko-KR" altLang="en-US"/>
+              <a:t>인상적이었던 점</a:t>
+            </a:r>
+            <a:br>
+              <a:rPr lang="en-US" altLang="ko-KR"/>
+            </a:br>
+            <a:r>
+              <a:rPr lang="en-US" altLang="ko-KR"/>
+              <a:t>:</a:t>
+            </a:r>
+            <a:r>
+              <a:rPr lang="ko-KR" altLang="en-US"/>
+              <a:t> 문제가 많이 불분명했다</a:t>
+            </a:r>
+            <a:r>
+              <a:rPr lang="en-US" altLang="ko-KR"/>
+              <a:t>. </a:t>
+            </a:r>
+            <a:r>
+              <a:rPr lang="en-US" altLang="ko-KR">
+                <a:sym typeface="Wingdings" panose="05000000000000000000" pitchFamily="2" charset="2"/>
+              </a:rPr>
+              <a:t> </a:t>
+            </a:r>
+            <a:r>
+              <a:rPr lang="ko-KR" altLang="en-US">
+                <a:sym typeface="Wingdings" panose="05000000000000000000" pitchFamily="2" charset="2"/>
+              </a:rPr>
+              <a:t>깊이 파다가 시간 </a:t>
+            </a:r>
+            <a:r>
+              <a:rPr lang="en-US" altLang="ko-KR">
+                <a:sym typeface="Wingdings" panose="05000000000000000000" pitchFamily="2" charset="2"/>
+              </a:rPr>
+              <a:t>+ </a:t>
+            </a:r>
+            <a:r>
+              <a:rPr lang="ko-KR" altLang="en-US">
+                <a:sym typeface="Wingdings" panose="05000000000000000000" pitchFamily="2" charset="2"/>
+              </a:rPr>
+              <a:t>머리 소모됨</a:t>
+            </a:r>
+            <a:endParaRPr lang="en-US"/>
+          </a:p>
+        </p:txBody>
+      </p:sp>
+      <p:sp>
+        <p:nvSpPr>
+          <p:cNvPr id="3" name="Content Placeholder 2">
+            <a:extLst>
+              <a:ext uri="{FF2B5EF4-FFF2-40B4-BE49-F238E27FC236}">
+                <a16:creationId xmlns:a16="http://schemas.microsoft.com/office/drawing/2014/main" id="{6F26F394-6D3D-40B1-06B3-18D96725F980}"/>
+              </a:ext>
+            </a:extLst>
+          </p:cNvPr>
+          <p:cNvSpPr>
+            <a:spLocks noGrp="1"/>
+          </p:cNvSpPr>
+          <p:nvPr>
+            <p:ph idx="1"/>
+          </p:nvPr>
+        </p:nvSpPr>
+        <p:spPr/>
+        <p:txBody>
+          <a:bodyPr/>
+          <a:lstStyle/>
+          <a:p>
+            <a:r>
+              <a:rPr lang="ko-KR" altLang="en-US"/>
+              <a:t>문제가 어려웠다</a:t>
+            </a:r>
+            <a:r>
+              <a:rPr lang="en-US" altLang="ko-KR"/>
+              <a:t>.</a:t>
+            </a:r>
+          </a:p>
+          <a:p>
+            <a:pPr lvl="1"/>
+            <a:r>
+              <a:rPr lang="ko-KR" altLang="en-US"/>
+              <a:t>문제에 필요한 지식을 배운 적이 없는데 그걸로 딸깍 답을 냈음 </a:t>
+            </a:r>
+            <a:r>
+              <a:rPr lang="en-US" altLang="ko-KR"/>
+              <a:t>(</a:t>
+            </a:r>
+            <a:r>
+              <a:rPr lang="ko-KR" altLang="en-US"/>
+              <a:t>나는 혼자서 기존 지식만으로 겨우 해냈지만</a:t>
+            </a:r>
+            <a:r>
+              <a:rPr lang="en-US" altLang="ko-KR"/>
+              <a:t>… </a:t>
+            </a:r>
+            <a:r>
+              <a:rPr lang="ko-KR" altLang="en-US"/>
+              <a:t>ㅇㅇ</a:t>
+            </a:r>
+            <a:r>
+              <a:rPr lang="en-US" altLang="ko-KR"/>
+              <a:t>)</a:t>
+            </a:r>
+          </a:p>
+          <a:p>
+            <a:pPr lvl="2"/>
+            <a:r>
+              <a:rPr lang="en-US" altLang="ko-KR"/>
+              <a:t>E.g. 3</a:t>
+            </a:r>
+            <a:r>
+              <a:rPr lang="ko-KR" altLang="en-US"/>
+              <a:t>강의 </a:t>
+            </a:r>
+            <a:r>
+              <a:rPr lang="en-US" altLang="ko-KR"/>
+              <a:t>5</a:t>
+            </a:r>
+            <a:r>
+              <a:rPr lang="ko-KR" altLang="en-US"/>
+              <a:t>번 문제</a:t>
+            </a:r>
+            <a:endParaRPr lang="en-US" altLang="ko-KR"/>
+          </a:p>
+          <a:p>
+            <a:pPr lvl="1"/>
+            <a:r>
+              <a:rPr lang="ko-KR" altLang="en-US"/>
+              <a:t>문제가 너무 불명확하게 주워졌음</a:t>
+            </a:r>
+            <a:r>
+              <a:rPr lang="en-US" altLang="ko-KR"/>
+              <a:t>. </a:t>
+            </a:r>
+            <a:r>
+              <a:rPr lang="ko-KR" altLang="en-US"/>
+              <a:t>근데 또 할만한 것 같긴 해서 </a:t>
+            </a:r>
+            <a:r>
+              <a:rPr lang="en-US" altLang="ko-KR"/>
+              <a:t>Gemini</a:t>
+            </a:r>
+            <a:r>
+              <a:rPr lang="ko-KR" altLang="en-US"/>
+              <a:t>랑 같이 많이 팠다</a:t>
+            </a:r>
+            <a:r>
+              <a:rPr lang="en-US" altLang="ko-KR"/>
+              <a:t>.</a:t>
+            </a:r>
+          </a:p>
+          <a:p>
+            <a:pPr lvl="1"/>
+            <a:r>
+              <a:rPr lang="ko-KR" altLang="en-US"/>
+              <a:t>도저히 아닌 것 같을 때 </a:t>
+            </a:r>
+            <a:r>
+              <a:rPr lang="en-US" altLang="ko-KR"/>
+              <a:t>Hint + Solution</a:t>
+            </a:r>
+            <a:r>
+              <a:rPr lang="ko-KR" altLang="en-US"/>
+              <a:t>을 보고 나서 원래 넣었어야 했던 말을 드디어 찾았다</a:t>
+            </a:r>
+            <a:r>
+              <a:rPr lang="en-US" altLang="ko-KR"/>
+              <a:t>.</a:t>
+            </a:r>
+          </a:p>
+          <a:p>
+            <a:pPr lvl="2"/>
+            <a:r>
+              <a:rPr lang="en-US"/>
+              <a:t>…</a:t>
+            </a:r>
+            <a:r>
+              <a:rPr lang="ko-KR" altLang="en-US"/>
+              <a:t>말하기도 쉽지 않다</a:t>
+            </a:r>
+            <a:r>
+              <a:rPr lang="en-US" altLang="ko-KR"/>
+              <a:t>. </a:t>
+            </a:r>
+            <a:r>
+              <a:rPr lang="ko-KR" altLang="en-US"/>
+              <a:t>그거 푸느라 </a:t>
+            </a:r>
+            <a:r>
+              <a:rPr lang="en-US" altLang="ko-KR"/>
+              <a:t>1</a:t>
+            </a:r>
+            <a:r>
+              <a:rPr lang="ko-KR" altLang="en-US"/>
+              <a:t>시간걸렸다</a:t>
+            </a:r>
+            <a:r>
+              <a:rPr lang="en-US" altLang="ko-KR"/>
+              <a:t>…</a:t>
+            </a:r>
+            <a:endParaRPr lang="en-US"/>
+          </a:p>
+          <a:p>
+            <a:endParaRPr lang="en-US"/>
+          </a:p>
+        </p:txBody>
+      </p:sp>
+    </p:spTree>
+    <p:extLst>
+      <p:ext uri="{BB962C8B-B14F-4D97-AF65-F5344CB8AC3E}">
+        <p14:creationId xmlns:p14="http://schemas.microsoft.com/office/powerpoint/2010/main" val="1517618491"/>
+      </p:ext>
+    </p:extLst>
+  </p:cSld>
+  <p:clrMapOvr>
+    <a:masterClrMapping/>
+  </p:clrMapOvr>
+</p:sld>
+</file>
+
+<file path=ppt/slides/slide15.xml><?xml version="1.0" encoding="utf-8"?>
+<p:sld xmlns:a="http://schemas.openxmlformats.org/drawingml/2006/main" xmlns:r="http://schemas.openxmlformats.org/officeDocument/2006/relationships" xmlns:p="http://schemas.openxmlformats.org/presentationml/2006/main">
+  <p:cSld>
+    <p:spTree>
+      <p:nvGrpSpPr>
+        <p:cNvPr id="1" name=""/>
+        <p:cNvGrpSpPr/>
+        <p:nvPr/>
+      </p:nvGrpSpPr>
+      <p:grpSpPr>
+        <a:xfrm>
+          <a:off x="0" y="0"/>
+          <a:ext cx="0" cy="0"/>
+          <a:chOff x="0" y="0"/>
+          <a:chExt cx="0" cy="0"/>
+        </a:xfrm>
+      </p:grpSpPr>
+      <p:sp>
+        <p:nvSpPr>
+          <p:cNvPr id="2" name="Title 1">
+            <a:extLst>
+              <a:ext uri="{FF2B5EF4-FFF2-40B4-BE49-F238E27FC236}">
+                <a16:creationId xmlns:a16="http://schemas.microsoft.com/office/drawing/2014/main" id="{262E6946-5B95-3E14-3406-28BE538F33ED}"/>
+              </a:ext>
+            </a:extLst>
+          </p:cNvPr>
+          <p:cNvSpPr>
+            <a:spLocks noGrp="1"/>
+          </p:cNvSpPr>
+          <p:nvPr>
+            <p:ph type="title"/>
+          </p:nvPr>
+        </p:nvSpPr>
+        <p:spPr/>
+        <p:txBody>
+          <a:bodyPr/>
+          <a:lstStyle/>
+          <a:p>
+            <a:r>
+              <a:rPr lang="en-US"/>
+              <a:t>5</a:t>
+            </a:r>
+            <a:r>
+              <a:rPr lang="ko-KR" altLang="en-US"/>
+              <a:t>번문제</a:t>
+            </a:r>
+            <a:endParaRPr lang="en-US"/>
+          </a:p>
+        </p:txBody>
+      </p:sp>
+      <p:sp>
+        <p:nvSpPr>
+          <p:cNvPr id="3" name="Content Placeholder 2">
+            <a:extLst>
+              <a:ext uri="{FF2B5EF4-FFF2-40B4-BE49-F238E27FC236}">
+                <a16:creationId xmlns:a16="http://schemas.microsoft.com/office/drawing/2014/main" id="{109EAF93-44C6-9A85-BA29-BBED97DB9603}"/>
+              </a:ext>
+            </a:extLst>
+          </p:cNvPr>
+          <p:cNvSpPr>
+            <a:spLocks noGrp="1"/>
+          </p:cNvSpPr>
+          <p:nvPr>
+            <p:ph idx="1"/>
+          </p:nvPr>
+        </p:nvSpPr>
+        <p:spPr/>
+        <p:txBody>
+          <a:bodyPr/>
+          <a:lstStyle/>
+          <a:p>
+            <a:r>
+              <a:rPr lang="ko-KR" altLang="en-US"/>
+              <a:t>어렵게 해결함</a:t>
+            </a:r>
+            <a:endParaRPr lang="en-US" altLang="ko-KR"/>
+          </a:p>
+          <a:p>
+            <a:endParaRPr lang="en-US"/>
+          </a:p>
+          <a:p>
+            <a:r>
+              <a:rPr lang="ko-KR" altLang="en-US"/>
+              <a:t>힌트</a:t>
+            </a:r>
+            <a:r>
+              <a:rPr lang="en-US" altLang="ko-KR"/>
+              <a:t>/</a:t>
+            </a:r>
+            <a:r>
+              <a:rPr lang="ko-KR" altLang="en-US"/>
+              <a:t>답 보고 나니 이게 한줄코드네</a:t>
+            </a:r>
+            <a:r>
+              <a:rPr lang="en-US" altLang="ko-KR"/>
+              <a:t>? </a:t>
+            </a:r>
+            <a:r>
+              <a:rPr lang="ko-KR" altLang="en-US"/>
+              <a:t>싶어서 좀 어이없었음</a:t>
+            </a:r>
+            <a:r>
+              <a:rPr lang="en-US" altLang="ko-KR"/>
+              <a:t>.</a:t>
+            </a:r>
+          </a:p>
+          <a:p>
+            <a:endParaRPr lang="en-US"/>
+          </a:p>
+        </p:txBody>
+      </p:sp>
+    </p:spTree>
+    <p:extLst>
+      <p:ext uri="{BB962C8B-B14F-4D97-AF65-F5344CB8AC3E}">
+        <p14:creationId xmlns:p14="http://schemas.microsoft.com/office/powerpoint/2010/main" val="4115076551"/>
+      </p:ext>
+    </p:extLst>
+  </p:cSld>
+  <p:clrMapOvr>
+    <a:masterClrMapping/>
+  </p:clrMapOvr>
+</p:sld>
+</file>
+
+<file path=ppt/slides/slide16.xml><?xml version="1.0" encoding="utf-8"?>
+<p:sld xmlns:a="http://schemas.openxmlformats.org/drawingml/2006/main" xmlns:r="http://schemas.openxmlformats.org/officeDocument/2006/relationships" xmlns:p="http://schemas.openxmlformats.org/presentationml/2006/main">
+  <p:cSld>
+    <p:spTree>
+      <p:nvGrpSpPr>
+        <p:cNvPr id="1" name=""/>
+        <p:cNvGrpSpPr/>
+        <p:nvPr/>
+      </p:nvGrpSpPr>
+      <p:grpSpPr>
+        <a:xfrm>
+          <a:off x="0" y="0"/>
+          <a:ext cx="0" cy="0"/>
+          <a:chOff x="0" y="0"/>
+          <a:chExt cx="0" cy="0"/>
+        </a:xfrm>
+      </p:grpSpPr>
+      <p:sp>
+        <p:nvSpPr>
+          <p:cNvPr id="2" name="Title 1">
+            <a:extLst>
+              <a:ext uri="{FF2B5EF4-FFF2-40B4-BE49-F238E27FC236}">
+                <a16:creationId xmlns:a16="http://schemas.microsoft.com/office/drawing/2014/main" id="{7AEDCD98-8575-241E-0A49-25CF271B23FD}"/>
+              </a:ext>
+            </a:extLst>
+          </p:cNvPr>
+          <p:cNvSpPr>
+            <a:spLocks noGrp="1"/>
+          </p:cNvSpPr>
+          <p:nvPr>
+            <p:ph type="title"/>
+          </p:nvPr>
+        </p:nvSpPr>
+        <p:spPr/>
+        <p:txBody>
+          <a:bodyPr/>
+          <a:lstStyle/>
+          <a:p>
+            <a:r>
+              <a:rPr lang="ko-KR" altLang="en-US"/>
+              <a:t>악랄한 </a:t>
+            </a:r>
+            <a:r>
+              <a:rPr lang="en-US" altLang="ko-KR"/>
+              <a:t>6</a:t>
+            </a:r>
+            <a:r>
+              <a:rPr lang="ko-KR" altLang="en-US"/>
+              <a:t>번 문제</a:t>
+            </a:r>
+            <a:endParaRPr lang="en-US"/>
+          </a:p>
+        </p:txBody>
+      </p:sp>
+      <p:sp>
+        <p:nvSpPr>
+          <p:cNvPr id="6" name="Text Placeholder 5">
+            <a:extLst>
+              <a:ext uri="{FF2B5EF4-FFF2-40B4-BE49-F238E27FC236}">
+                <a16:creationId xmlns:a16="http://schemas.microsoft.com/office/drawing/2014/main" id="{A17F2A28-075B-7952-0167-611381A94C31}"/>
+              </a:ext>
+            </a:extLst>
+          </p:cNvPr>
+          <p:cNvSpPr>
+            <a:spLocks noGrp="1"/>
+          </p:cNvSpPr>
+          <p:nvPr>
+            <p:ph type="body" idx="1"/>
+          </p:nvPr>
+        </p:nvSpPr>
+        <p:spPr/>
+        <p:txBody>
+          <a:bodyPr>
+            <a:normAutofit lnSpcReduction="10000"/>
+          </a:bodyPr>
+          <a:lstStyle/>
+          <a:p>
+            <a:r>
+              <a:rPr lang="ko-KR" altLang="en-US"/>
+              <a:t>원래 문제 내용</a:t>
+            </a:r>
+            <a:endParaRPr lang="en-US"/>
+          </a:p>
+        </p:txBody>
+      </p:sp>
+      <p:sp>
+        <p:nvSpPr>
+          <p:cNvPr id="4" name="Content Placeholder 3">
+            <a:extLst>
+              <a:ext uri="{FF2B5EF4-FFF2-40B4-BE49-F238E27FC236}">
+                <a16:creationId xmlns:a16="http://schemas.microsoft.com/office/drawing/2014/main" id="{A0C29ECE-00AA-76BC-E989-2842B7A3D8CC}"/>
+              </a:ext>
+            </a:extLst>
+          </p:cNvPr>
+          <p:cNvSpPr>
+            <a:spLocks noGrp="1"/>
+          </p:cNvSpPr>
+          <p:nvPr>
+            <p:ph sz="half" idx="2"/>
+          </p:nvPr>
+        </p:nvSpPr>
+        <p:spPr/>
+        <p:txBody>
+          <a:bodyPr>
+            <a:normAutofit/>
+          </a:bodyPr>
+          <a:lstStyle/>
+          <a:p>
+            <a:pPr marL="0" indent="0">
+              <a:buNone/>
+            </a:pPr>
+            <a:r>
+              <a:rPr lang="en-US"/>
+              <a:t>Create a Series `descriptor_counts` counting how many times each of these two words appears in the `description` column in the dataset. (For simplicity, let's ignore the capitalized versions of these words.)</a:t>
+            </a:r>
+          </a:p>
+        </p:txBody>
+      </p:sp>
+      <p:sp>
+        <p:nvSpPr>
+          <p:cNvPr id="7" name="Text Placeholder 6">
+            <a:extLst>
+              <a:ext uri="{FF2B5EF4-FFF2-40B4-BE49-F238E27FC236}">
+                <a16:creationId xmlns:a16="http://schemas.microsoft.com/office/drawing/2014/main" id="{9EB2F0F2-0FC7-0EB5-4EB3-D859F43BE91B}"/>
+              </a:ext>
+            </a:extLst>
+          </p:cNvPr>
+          <p:cNvSpPr>
+            <a:spLocks noGrp="1"/>
+          </p:cNvSpPr>
+          <p:nvPr>
+            <p:ph type="body" sz="quarter" idx="3"/>
+          </p:nvPr>
+        </p:nvSpPr>
+        <p:spPr/>
+        <p:txBody>
+          <a:bodyPr>
+            <a:normAutofit lnSpcReduction="10000"/>
+          </a:bodyPr>
+          <a:lstStyle/>
+          <a:p>
+            <a:r>
+              <a:rPr lang="ko-KR" altLang="en-US"/>
+              <a:t>실제 요구한 내용</a:t>
+            </a:r>
+            <a:endParaRPr lang="en-US"/>
+          </a:p>
+          <a:p>
+            <a:r>
+              <a:rPr lang="en-US"/>
+              <a:t>Hint + solution + gemini3</a:t>
+            </a:r>
+          </a:p>
+        </p:txBody>
+      </p:sp>
+      <p:sp>
+        <p:nvSpPr>
+          <p:cNvPr id="8" name="Content Placeholder 7">
+            <a:extLst>
+              <a:ext uri="{FF2B5EF4-FFF2-40B4-BE49-F238E27FC236}">
+                <a16:creationId xmlns:a16="http://schemas.microsoft.com/office/drawing/2014/main" id="{03E0053A-3FA6-171C-7D69-5733B1A9581A}"/>
+              </a:ext>
+            </a:extLst>
+          </p:cNvPr>
+          <p:cNvSpPr>
+            <a:spLocks noGrp="1"/>
+          </p:cNvSpPr>
+          <p:nvPr>
+            <p:ph sz="quarter" idx="4"/>
+          </p:nvPr>
+        </p:nvSpPr>
+        <p:spPr/>
+        <p:txBody>
+          <a:bodyPr>
+            <a:normAutofit/>
+          </a:bodyPr>
+          <a:lstStyle/>
+          <a:p>
+            <a:pPr marL="0" indent="0">
+              <a:buNone/>
+            </a:pPr>
+            <a:r>
+              <a:rPr lang="en-US"/>
+              <a:t>"Create a Series `descriptor_counts` where each value is the number of rows containing the words 'tropical' or 'fruity' (at least once) in the `description` column. (Ignore case, and ignore multiple occurrences within a single row.)"</a:t>
+            </a:r>
+          </a:p>
+        </p:txBody>
+      </p:sp>
+      <p:sp>
+        <p:nvSpPr>
+          <p:cNvPr id="10" name="TextBox 9">
+            <a:extLst>
+              <a:ext uri="{FF2B5EF4-FFF2-40B4-BE49-F238E27FC236}">
+                <a16:creationId xmlns:a16="http://schemas.microsoft.com/office/drawing/2014/main" id="{1AF25F5A-E2C4-404E-09F2-7E72422DA21B}"/>
+              </a:ext>
+            </a:extLst>
+          </p:cNvPr>
+          <p:cNvSpPr txBox="1"/>
+          <p:nvPr/>
+        </p:nvSpPr>
+        <p:spPr>
+          <a:xfrm>
+            <a:off x="5256212" y="104576"/>
+            <a:ext cx="6096000" cy="923330"/>
+          </a:xfrm>
+          <a:prstGeom prst="rect">
+            <a:avLst/>
+          </a:prstGeom>
+          <a:noFill/>
+        </p:spPr>
+        <p:txBody>
+          <a:bodyPr wrap="square">
+            <a:spAutoFit/>
+          </a:bodyPr>
+          <a:lstStyle/>
+          <a:p>
+            <a:r>
+              <a:rPr lang="en-US"/>
+              <a:t>There are only so many words you can use when describing a bottle of wine. Is a wine more likely to be "tropical" or "fruity"? </a:t>
+            </a:r>
+          </a:p>
+        </p:txBody>
+      </p:sp>
+    </p:spTree>
+    <p:extLst>
+      <p:ext uri="{BB962C8B-B14F-4D97-AF65-F5344CB8AC3E}">
+        <p14:creationId xmlns:p14="http://schemas.microsoft.com/office/powerpoint/2010/main" val="1946703940"/>
+      </p:ext>
+    </p:extLst>
+  </p:cSld>
+  <p:clrMapOvr>
+    <a:masterClrMapping/>
+  </p:clrMapOvr>
+</p:sld>
+</file>
+
+<file path=ppt/slides/slide17.xml><?xml version="1.0" encoding="utf-8"?>
+<p:sld xmlns:a="http://schemas.openxmlformats.org/drawingml/2006/main" xmlns:r="http://schemas.openxmlformats.org/officeDocument/2006/relationships" xmlns:p="http://schemas.openxmlformats.org/presentationml/2006/main">
+  <p:cSld>
+    <p:spTree>
+      <p:nvGrpSpPr>
+        <p:cNvPr id="1" name="">
+          <a:extLst>
+            <a:ext uri="{FF2B5EF4-FFF2-40B4-BE49-F238E27FC236}">
+              <a16:creationId xmlns:a16="http://schemas.microsoft.com/office/drawing/2014/main" id="{8FEABEDA-8CEE-A35C-89AF-DA67D1BC6B95}"/>
+            </a:ext>
+          </a:extLst>
+        </p:cNvPr>
+        <p:cNvGrpSpPr/>
+        <p:nvPr/>
+      </p:nvGrpSpPr>
+      <p:grpSpPr>
+        <a:xfrm>
+          <a:off x="0" y="0"/>
+          <a:ext cx="0" cy="0"/>
+          <a:chOff x="0" y="0"/>
+          <a:chExt cx="0" cy="0"/>
+        </a:xfrm>
+      </p:grpSpPr>
+      <p:sp>
+        <p:nvSpPr>
+          <p:cNvPr id="2" name="Title 1">
+            <a:extLst>
+              <a:ext uri="{FF2B5EF4-FFF2-40B4-BE49-F238E27FC236}">
+                <a16:creationId xmlns:a16="http://schemas.microsoft.com/office/drawing/2014/main" id="{E13F921B-C9E4-A4A4-386B-B02728CE5F11}"/>
+              </a:ext>
+            </a:extLst>
+          </p:cNvPr>
+          <p:cNvSpPr>
+            <a:spLocks noGrp="1"/>
+          </p:cNvSpPr>
+          <p:nvPr>
+            <p:ph type="title"/>
+          </p:nvPr>
+        </p:nvSpPr>
+        <p:spPr/>
+        <p:txBody>
+          <a:bodyPr/>
+          <a:lstStyle/>
+          <a:p>
+            <a:r>
+              <a:rPr lang="ko-KR" altLang="en-US"/>
+              <a:t>악랄한 </a:t>
+            </a:r>
+            <a:r>
+              <a:rPr lang="en-US" altLang="ko-KR"/>
+              <a:t>6</a:t>
+            </a:r>
+            <a:r>
+              <a:rPr lang="ko-KR" altLang="en-US"/>
+              <a:t>번 문제</a:t>
+            </a:r>
+            <a:endParaRPr lang="en-US"/>
+          </a:p>
+        </p:txBody>
+      </p:sp>
+      <p:sp>
+        <p:nvSpPr>
+          <p:cNvPr id="6" name="Text Placeholder 5">
+            <a:extLst>
+              <a:ext uri="{FF2B5EF4-FFF2-40B4-BE49-F238E27FC236}">
+                <a16:creationId xmlns:a16="http://schemas.microsoft.com/office/drawing/2014/main" id="{E35FD7B0-EFF0-1889-AFD3-D9627E99EB78}"/>
+              </a:ext>
+            </a:extLst>
+          </p:cNvPr>
+          <p:cNvSpPr>
+            <a:spLocks noGrp="1"/>
+          </p:cNvSpPr>
+          <p:nvPr>
+            <p:ph type="body" idx="1"/>
+          </p:nvPr>
+        </p:nvSpPr>
+        <p:spPr/>
+        <p:txBody>
+          <a:bodyPr>
+            <a:normAutofit/>
+          </a:bodyPr>
+          <a:lstStyle/>
+          <a:p>
+            <a:r>
+              <a:rPr lang="ko-KR" altLang="en-US"/>
+              <a:t>원래 문제 내용</a:t>
+            </a:r>
+            <a:endParaRPr lang="en-US"/>
+          </a:p>
+        </p:txBody>
+      </p:sp>
+      <p:sp>
+        <p:nvSpPr>
+          <p:cNvPr id="4" name="Content Placeholder 3">
+            <a:extLst>
+              <a:ext uri="{FF2B5EF4-FFF2-40B4-BE49-F238E27FC236}">
+                <a16:creationId xmlns:a16="http://schemas.microsoft.com/office/drawing/2014/main" id="{F0118274-048F-9394-4BCF-3B7E4A6C9EB3}"/>
+              </a:ext>
+            </a:extLst>
+          </p:cNvPr>
+          <p:cNvSpPr>
+            <a:spLocks noGrp="1"/>
+          </p:cNvSpPr>
+          <p:nvPr>
+            <p:ph sz="half" idx="2"/>
+          </p:nvPr>
+        </p:nvSpPr>
+        <p:spPr/>
+        <p:txBody>
+          <a:bodyPr>
+            <a:normAutofit fontScale="92500"/>
+          </a:bodyPr>
+          <a:lstStyle/>
+          <a:p>
+            <a:pPr marL="0" indent="0">
+              <a:buNone/>
+            </a:pPr>
+            <a:r>
+              <a:rPr lang="en-US"/>
+              <a:t>Create a Series `descriptor_counts` counting how many times each of these two words appears in the `description` column in the dataset. (For simplicity, let's ignore the capitalized versions of these words.)</a:t>
+            </a:r>
+          </a:p>
+        </p:txBody>
+      </p:sp>
+      <p:sp>
+        <p:nvSpPr>
+          <p:cNvPr id="7" name="Text Placeholder 6">
+            <a:extLst>
+              <a:ext uri="{FF2B5EF4-FFF2-40B4-BE49-F238E27FC236}">
+                <a16:creationId xmlns:a16="http://schemas.microsoft.com/office/drawing/2014/main" id="{92781BBE-0C0F-1C54-34F2-CB654034942F}"/>
+              </a:ext>
+            </a:extLst>
+          </p:cNvPr>
+          <p:cNvSpPr>
+            <a:spLocks noGrp="1"/>
+          </p:cNvSpPr>
+          <p:nvPr>
+            <p:ph type="body" sz="quarter" idx="3"/>
+          </p:nvPr>
+        </p:nvSpPr>
+        <p:spPr/>
+        <p:txBody>
+          <a:bodyPr>
+            <a:normAutofit/>
+          </a:bodyPr>
+          <a:lstStyle/>
+          <a:p>
+            <a:r>
+              <a:rPr lang="ko-KR" altLang="en-US"/>
+              <a:t>내가 했던 생각</a:t>
+            </a:r>
+            <a:endParaRPr lang="en-US"/>
+          </a:p>
+        </p:txBody>
+      </p:sp>
+      <p:sp>
+        <p:nvSpPr>
+          <p:cNvPr id="8" name="Content Placeholder 7">
+            <a:extLst>
+              <a:ext uri="{FF2B5EF4-FFF2-40B4-BE49-F238E27FC236}">
+                <a16:creationId xmlns:a16="http://schemas.microsoft.com/office/drawing/2014/main" id="{6A42501F-D946-692C-99DB-8E50AD399933}"/>
+              </a:ext>
+            </a:extLst>
+          </p:cNvPr>
+          <p:cNvSpPr>
+            <a:spLocks noGrp="1"/>
+          </p:cNvSpPr>
+          <p:nvPr>
+            <p:ph sz="quarter" idx="4"/>
+          </p:nvPr>
+        </p:nvSpPr>
+        <p:spPr/>
+        <p:txBody>
+          <a:bodyPr>
+            <a:normAutofit fontScale="92500"/>
+          </a:bodyPr>
+          <a:lstStyle/>
+          <a:p>
+            <a:r>
+              <a:rPr lang="ko-KR" altLang="en-US"/>
+              <a:t>오호</a:t>
+            </a:r>
+            <a:r>
+              <a:rPr lang="en-US" altLang="ko-KR"/>
+              <a:t>. </a:t>
+            </a:r>
+            <a:r>
+              <a:rPr lang="ko-KR" altLang="en-US"/>
+              <a:t>그럼 </a:t>
+            </a:r>
+            <a:r>
+              <a:rPr lang="en-US" altLang="ko-KR"/>
+              <a:t>'tropicalfruitytropical' </a:t>
+            </a:r>
+            <a:r>
+              <a:rPr lang="ko-KR" altLang="en-US"/>
+              <a:t>이라는 설명</a:t>
+            </a:r>
+            <a:r>
+              <a:rPr lang="en-US" altLang="ko-KR"/>
+              <a:t>(description)</a:t>
+            </a:r>
+            <a:r>
+              <a:rPr lang="ko-KR" altLang="en-US"/>
+              <a:t>에서는 </a:t>
+            </a:r>
+            <a:r>
+              <a:rPr lang="en-US" altLang="ko-KR"/>
+              <a:t>2</a:t>
+            </a:r>
+            <a:r>
+              <a:rPr lang="ko-KR" altLang="en-US"/>
+              <a:t>개</a:t>
+            </a:r>
+            <a:r>
+              <a:rPr lang="en-US" altLang="ko-KR"/>
+              <a:t>,1</a:t>
+            </a:r>
+            <a:r>
+              <a:rPr lang="ko-KR" altLang="en-US"/>
+              <a:t>개 각각을 세야하는것</a:t>
+            </a:r>
+            <a:r>
+              <a:rPr lang="en-US" altLang="ko-KR"/>
+              <a:t>?</a:t>
+            </a:r>
+          </a:p>
+          <a:p>
+            <a:r>
+              <a:rPr lang="ko-KR" altLang="en-US"/>
+              <a:t>와인별로 세는건가</a:t>
+            </a:r>
+            <a:r>
+              <a:rPr lang="en-US" altLang="ko-KR"/>
+              <a:t>, </a:t>
+            </a:r>
+            <a:r>
+              <a:rPr lang="ko-KR" altLang="en-US"/>
+              <a:t>단어별로 세는건가</a:t>
+            </a:r>
+            <a:r>
+              <a:rPr lang="en-US" altLang="ko-KR"/>
+              <a:t>?</a:t>
+            </a:r>
+          </a:p>
+          <a:p>
+            <a:pPr lvl="1"/>
+            <a:r>
+              <a:rPr lang="ko-KR" altLang="en-US"/>
+              <a:t>와인별로 세는것만 해도 음</a:t>
+            </a:r>
+            <a:r>
+              <a:rPr lang="en-US" altLang="ko-KR"/>
+              <a:t>.. KMP</a:t>
+            </a:r>
+            <a:r>
+              <a:rPr lang="ko-KR" altLang="en-US"/>
+              <a:t>를 활용할 수 있겠고 와인별로 센 것의 합을 구하라고하면 그 </a:t>
+            </a:r>
+            <a:r>
+              <a:rPr lang="en-US" altLang="ko-KR"/>
+              <a:t>table</a:t>
+            </a:r>
+            <a:r>
+              <a:rPr lang="ko-KR" altLang="en-US"/>
+              <a:t>을 걍 합치면 되겠군</a:t>
+            </a:r>
+            <a:endParaRPr lang="en-US" altLang="ko-KR"/>
+          </a:p>
+          <a:p>
+            <a:pPr lvl="1"/>
+            <a:r>
+              <a:rPr lang="en-US" altLang="ko-KR"/>
+              <a:t>... </a:t>
+            </a:r>
+            <a:r>
+              <a:rPr lang="ko-KR" altLang="en-US"/>
+              <a:t>이거 맞아</a:t>
+            </a:r>
+            <a:r>
+              <a:rPr lang="en-US" altLang="ko-KR"/>
+              <a:t>???</a:t>
+            </a:r>
+          </a:p>
+        </p:txBody>
+      </p:sp>
+      <p:sp>
+        <p:nvSpPr>
+          <p:cNvPr id="10" name="TextBox 9">
+            <a:extLst>
+              <a:ext uri="{FF2B5EF4-FFF2-40B4-BE49-F238E27FC236}">
+                <a16:creationId xmlns:a16="http://schemas.microsoft.com/office/drawing/2014/main" id="{ACD73065-0A68-6EE7-1F85-AD7B0AD217D5}"/>
+              </a:ext>
+            </a:extLst>
+          </p:cNvPr>
+          <p:cNvSpPr txBox="1"/>
+          <p:nvPr/>
+        </p:nvSpPr>
+        <p:spPr>
+          <a:xfrm>
+            <a:off x="5256212" y="104576"/>
+            <a:ext cx="6096000" cy="923330"/>
+          </a:xfrm>
+          <a:prstGeom prst="rect">
+            <a:avLst/>
+          </a:prstGeom>
+          <a:noFill/>
+        </p:spPr>
+        <p:txBody>
+          <a:bodyPr wrap="square">
+            <a:spAutoFit/>
+          </a:bodyPr>
+          <a:lstStyle/>
+          <a:p>
+            <a:r>
+              <a:rPr lang="en-US"/>
+              <a:t>There are only so many words you can use when describing a bottle of wine. Is a wine more likely to be "tropical" or "fruity"? </a:t>
+            </a:r>
+          </a:p>
+        </p:txBody>
+      </p:sp>
+      <p:sp>
+        <p:nvSpPr>
+          <p:cNvPr id="5" name="TextBox 4">
+            <a:extLst>
+              <a:ext uri="{FF2B5EF4-FFF2-40B4-BE49-F238E27FC236}">
+                <a16:creationId xmlns:a16="http://schemas.microsoft.com/office/drawing/2014/main" id="{CCBBF7D6-2A25-5A23-E4A5-6754A1C6B462}"/>
+              </a:ext>
+            </a:extLst>
+          </p:cNvPr>
+          <p:cNvSpPr txBox="1"/>
+          <p:nvPr/>
+        </p:nvSpPr>
+        <p:spPr>
+          <a:xfrm>
+            <a:off x="76200" y="6488668"/>
+            <a:ext cx="6096000" cy="369332"/>
+          </a:xfrm>
+          <a:prstGeom prst="rect">
+            <a:avLst/>
+          </a:prstGeom>
+          <a:noFill/>
+        </p:spPr>
+        <p:txBody>
+          <a:bodyPr wrap="square">
+            <a:spAutoFit/>
+          </a:bodyPr>
+          <a:lstStyle/>
+          <a:p>
+            <a:r>
+              <a:rPr lang="en-US"/>
+              <a:t>https://gemini.google.com/share/18a93bbfb060</a:t>
+            </a:r>
+          </a:p>
+        </p:txBody>
+      </p:sp>
+    </p:spTree>
+    <p:extLst>
+      <p:ext uri="{BB962C8B-B14F-4D97-AF65-F5344CB8AC3E}">
+        <p14:creationId xmlns:p14="http://schemas.microsoft.com/office/powerpoint/2010/main" val="1290481643"/>
+      </p:ext>
+    </p:extLst>
+  </p:cSld>
+  <p:clrMapOvr>
+    <a:masterClrMapping/>
+  </p:clrMapOvr>
+</p:sld>
+</file>
+
+<file path=ppt/slides/slide18.xml><?xml version="1.0" encoding="utf-8"?>
+<p:sld xmlns:a="http://schemas.openxmlformats.org/drawingml/2006/main" xmlns:r="http://schemas.openxmlformats.org/officeDocument/2006/relationships" xmlns:p="http://schemas.openxmlformats.org/presentationml/2006/main">
+  <p:cSld>
+    <p:spTree>
+      <p:nvGrpSpPr>
+        <p:cNvPr id="1" name="">
+          <a:extLst>
+            <a:ext uri="{FF2B5EF4-FFF2-40B4-BE49-F238E27FC236}">
+              <a16:creationId xmlns:a16="http://schemas.microsoft.com/office/drawing/2014/main" id="{4B8E9A1B-0CC1-A278-C707-784207168FE9}"/>
+            </a:ext>
+          </a:extLst>
+        </p:cNvPr>
+        <p:cNvGrpSpPr/>
+        <p:nvPr/>
+      </p:nvGrpSpPr>
+      <p:grpSpPr>
+        <a:xfrm>
+          <a:off x="0" y="0"/>
+          <a:ext cx="0" cy="0"/>
+          <a:chOff x="0" y="0"/>
+          <a:chExt cx="0" cy="0"/>
+        </a:xfrm>
+      </p:grpSpPr>
+      <p:sp>
+        <p:nvSpPr>
+          <p:cNvPr id="2" name="Title 1">
+            <a:extLst>
+              <a:ext uri="{FF2B5EF4-FFF2-40B4-BE49-F238E27FC236}">
+                <a16:creationId xmlns:a16="http://schemas.microsoft.com/office/drawing/2014/main" id="{A6E0D153-484B-6EE3-E7DE-7A26F1D02937}"/>
+              </a:ext>
+            </a:extLst>
+          </p:cNvPr>
+          <p:cNvSpPr>
+            <a:spLocks noGrp="1"/>
+          </p:cNvSpPr>
+          <p:nvPr>
+            <p:ph type="title"/>
+          </p:nvPr>
+        </p:nvSpPr>
+        <p:spPr/>
+        <p:txBody>
+          <a:bodyPr/>
+          <a:lstStyle/>
+          <a:p>
+            <a:r>
+              <a:rPr lang="ko-KR" altLang="en-US"/>
+              <a:t>악랄한 </a:t>
+            </a:r>
+            <a:r>
+              <a:rPr lang="en-US" altLang="ko-KR"/>
+              <a:t>6</a:t>
+            </a:r>
+            <a:r>
+              <a:rPr lang="ko-KR" altLang="en-US"/>
+              <a:t>번 문제</a:t>
+            </a:r>
+            <a:endParaRPr lang="en-US"/>
+          </a:p>
+        </p:txBody>
+      </p:sp>
+      <p:sp>
+        <p:nvSpPr>
+          <p:cNvPr id="6" name="Text Placeholder 5">
+            <a:extLst>
+              <a:ext uri="{FF2B5EF4-FFF2-40B4-BE49-F238E27FC236}">
+                <a16:creationId xmlns:a16="http://schemas.microsoft.com/office/drawing/2014/main" id="{62B31B96-4BCC-D6ED-AEC8-60FC6A8B8438}"/>
+              </a:ext>
+            </a:extLst>
+          </p:cNvPr>
+          <p:cNvSpPr>
+            <a:spLocks noGrp="1"/>
+          </p:cNvSpPr>
+          <p:nvPr>
+            <p:ph type="body" idx="1"/>
+          </p:nvPr>
+        </p:nvSpPr>
+        <p:spPr/>
+        <p:txBody>
+          <a:bodyPr>
+            <a:normAutofit/>
+          </a:bodyPr>
+          <a:lstStyle/>
+          <a:p>
+            <a:r>
+              <a:rPr lang="ko-KR" altLang="en-US"/>
+              <a:t>원래 문제 내용</a:t>
+            </a:r>
+            <a:endParaRPr lang="en-US"/>
+          </a:p>
+        </p:txBody>
+      </p:sp>
+      <p:sp>
+        <p:nvSpPr>
+          <p:cNvPr id="4" name="Content Placeholder 3">
+            <a:extLst>
+              <a:ext uri="{FF2B5EF4-FFF2-40B4-BE49-F238E27FC236}">
+                <a16:creationId xmlns:a16="http://schemas.microsoft.com/office/drawing/2014/main" id="{05D52FD1-A359-3754-29BE-BD102DAF4136}"/>
+              </a:ext>
+            </a:extLst>
+          </p:cNvPr>
+          <p:cNvSpPr>
+            <a:spLocks noGrp="1"/>
+          </p:cNvSpPr>
+          <p:nvPr>
+            <p:ph sz="half" idx="2"/>
+          </p:nvPr>
+        </p:nvSpPr>
+        <p:spPr/>
+        <p:txBody>
+          <a:bodyPr>
+            <a:normAutofit fontScale="70000" lnSpcReduction="20000"/>
+          </a:bodyPr>
+          <a:lstStyle/>
+          <a:p>
+            <a:pPr marL="0" indent="0">
+              <a:buNone/>
+            </a:pPr>
+            <a:r>
+              <a:rPr lang="en-US"/>
+              <a:t>Create a Series `descriptor_counts` counting how many times each of these two words appears in the `description` column in the dataset. (For simplicity, let's ignore the capitalized versions of these words.)</a:t>
+            </a:r>
+          </a:p>
+        </p:txBody>
+      </p:sp>
+      <p:sp>
+        <p:nvSpPr>
+          <p:cNvPr id="7" name="Text Placeholder 6">
+            <a:extLst>
+              <a:ext uri="{FF2B5EF4-FFF2-40B4-BE49-F238E27FC236}">
+                <a16:creationId xmlns:a16="http://schemas.microsoft.com/office/drawing/2014/main" id="{E4C0979E-5BA1-245A-587D-854989284B88}"/>
+              </a:ext>
+            </a:extLst>
+          </p:cNvPr>
+          <p:cNvSpPr>
+            <a:spLocks noGrp="1"/>
+          </p:cNvSpPr>
+          <p:nvPr>
+            <p:ph type="body" sz="quarter" idx="3"/>
+          </p:nvPr>
+        </p:nvSpPr>
+        <p:spPr/>
+        <p:txBody>
+          <a:bodyPr>
+            <a:normAutofit/>
+          </a:bodyPr>
+          <a:lstStyle/>
+          <a:p>
+            <a:r>
+              <a:rPr lang="ko-KR" altLang="en-US"/>
+              <a:t>내가 했던 생각</a:t>
+            </a:r>
+            <a:endParaRPr lang="en-US"/>
+          </a:p>
+        </p:txBody>
+      </p:sp>
+      <p:sp>
+        <p:nvSpPr>
+          <p:cNvPr id="8" name="Content Placeholder 7">
+            <a:extLst>
+              <a:ext uri="{FF2B5EF4-FFF2-40B4-BE49-F238E27FC236}">
+                <a16:creationId xmlns:a16="http://schemas.microsoft.com/office/drawing/2014/main" id="{B36F4863-EF56-916B-B6DC-D4D4674C90D3}"/>
+              </a:ext>
+            </a:extLst>
+          </p:cNvPr>
+          <p:cNvSpPr>
+            <a:spLocks noGrp="1"/>
+          </p:cNvSpPr>
+          <p:nvPr>
+            <p:ph sz="quarter" idx="4"/>
+          </p:nvPr>
+        </p:nvSpPr>
+        <p:spPr/>
+        <p:txBody>
+          <a:bodyPr>
+            <a:normAutofit fontScale="70000" lnSpcReduction="20000"/>
+          </a:bodyPr>
+          <a:lstStyle/>
+          <a:p>
+            <a:r>
+              <a:rPr lang="ko-KR" altLang="en-US"/>
+              <a:t>했던 생각</a:t>
+            </a:r>
+            <a:endParaRPr lang="en-US" altLang="ko-KR"/>
+          </a:p>
+          <a:p>
+            <a:pPr lvl="1"/>
+            <a:r>
+              <a:rPr lang="ko-KR" altLang="en-US"/>
+              <a:t>와인별로 세는것만 해도 음</a:t>
+            </a:r>
+            <a:r>
+              <a:rPr lang="en-US" altLang="ko-KR"/>
+              <a:t>.. KMP</a:t>
+            </a:r>
+            <a:r>
+              <a:rPr lang="ko-KR" altLang="en-US"/>
+              <a:t>를 활용할 수 있겠고 와인별로 센 것의 합을 구하라고하면 그 </a:t>
+            </a:r>
+            <a:r>
+              <a:rPr lang="en-US" altLang="ko-KR"/>
+              <a:t>table</a:t>
+            </a:r>
+            <a:r>
+              <a:rPr lang="ko-KR" altLang="en-US"/>
+              <a:t>을 걍 합치면 되겠군</a:t>
+            </a:r>
+            <a:endParaRPr lang="en-US" altLang="ko-KR"/>
+          </a:p>
+          <a:p>
+            <a:pPr lvl="1"/>
+            <a:r>
+              <a:rPr lang="en-US" altLang="ko-KR"/>
+              <a:t>... </a:t>
+            </a:r>
+            <a:r>
+              <a:rPr lang="ko-KR" altLang="en-US"/>
+              <a:t>이거 맞아</a:t>
+            </a:r>
+            <a:r>
+              <a:rPr lang="en-US" altLang="ko-KR"/>
+              <a:t>???</a:t>
+            </a:r>
+          </a:p>
+          <a:p>
+            <a:r>
+              <a:rPr lang="ko-KR" altLang="en-US"/>
+              <a:t>의문점</a:t>
+            </a:r>
+            <a:endParaRPr lang="en-US" altLang="ko-KR"/>
+          </a:p>
+          <a:p>
+            <a:pPr lvl="1"/>
+            <a:r>
+              <a:rPr lang="en-US" altLang="ko-KR"/>
+              <a:t>Q1.</a:t>
+            </a:r>
+            <a:r>
+              <a:rPr lang="ko-KR" altLang="en-US"/>
+              <a:t> 오호</a:t>
+            </a:r>
+            <a:r>
+              <a:rPr lang="en-US" altLang="ko-KR"/>
+              <a:t>. </a:t>
+            </a:r>
+            <a:r>
+              <a:rPr lang="ko-KR" altLang="en-US"/>
+              <a:t>그럼 </a:t>
+            </a:r>
+            <a:r>
+              <a:rPr lang="en-US" altLang="ko-KR"/>
+              <a:t>'tropicalfruitytropical' </a:t>
+            </a:r>
+            <a:r>
+              <a:rPr lang="ko-KR" altLang="en-US"/>
+              <a:t>이라는 설명</a:t>
+            </a:r>
+            <a:r>
+              <a:rPr lang="en-US" altLang="ko-KR"/>
+              <a:t>(description)</a:t>
+            </a:r>
+            <a:r>
+              <a:rPr lang="ko-KR" altLang="en-US"/>
+              <a:t>에서는 </a:t>
+            </a:r>
+            <a:r>
+              <a:rPr lang="en-US" altLang="ko-KR"/>
+              <a:t>2</a:t>
+            </a:r>
+            <a:r>
+              <a:rPr lang="ko-KR" altLang="en-US"/>
+              <a:t>개</a:t>
+            </a:r>
+            <a:r>
+              <a:rPr lang="en-US" altLang="ko-KR"/>
+              <a:t>,1</a:t>
+            </a:r>
+            <a:r>
+              <a:rPr lang="ko-KR" altLang="en-US"/>
+              <a:t>개 각각을 세야하는것</a:t>
+            </a:r>
+            <a:r>
+              <a:rPr lang="en-US" altLang="ko-KR"/>
+              <a:t>?</a:t>
+            </a:r>
+          </a:p>
+          <a:p>
+            <a:pPr lvl="1"/>
+            <a:r>
+              <a:rPr lang="en-US" altLang="ko-KR"/>
+              <a:t>Q2. </a:t>
+            </a:r>
+            <a:r>
+              <a:rPr lang="ko-KR" altLang="en-US"/>
+              <a:t>와인별로 세는건가</a:t>
+            </a:r>
+            <a:r>
+              <a:rPr lang="en-US" altLang="ko-KR"/>
+              <a:t>, </a:t>
+            </a:r>
+            <a:r>
+              <a:rPr lang="ko-KR" altLang="en-US"/>
+              <a:t>단어별로 세는건가</a:t>
+            </a:r>
+            <a:r>
+              <a:rPr lang="en-US" altLang="ko-KR"/>
+              <a:t>?</a:t>
+            </a:r>
+          </a:p>
+          <a:p>
+            <a:r>
+              <a:rPr lang="en-US" altLang="ko-KR"/>
+              <a:t>Q1</a:t>
+            </a:r>
+            <a:r>
+              <a:rPr lang="ko-KR" altLang="en-US"/>
+              <a:t>에 대한 가정</a:t>
+            </a:r>
+            <a:endParaRPr lang="en-US" altLang="ko-KR"/>
+          </a:p>
+          <a:p>
+            <a:pPr lvl="1"/>
+            <a:r>
+              <a:rPr lang="ko-KR" altLang="en-US"/>
+              <a:t>아마 그렇게 등장하진 않을 것 같음</a:t>
+            </a:r>
+            <a:r>
+              <a:rPr lang="en-US" altLang="ko-KR"/>
+              <a:t>! (</a:t>
+            </a:r>
+            <a:r>
+              <a:rPr lang="ko-KR" altLang="en-US"/>
+              <a:t>즉</a:t>
+            </a:r>
+            <a:r>
+              <a:rPr lang="en-US" altLang="ko-KR"/>
+              <a:t>, </a:t>
+            </a:r>
+            <a:r>
+              <a:rPr lang="ko-KR" altLang="en-US"/>
+              <a:t>둘 중 한 단어만 최대 </a:t>
+            </a:r>
+            <a:r>
+              <a:rPr lang="en-US" altLang="ko-KR"/>
+              <a:t>1</a:t>
+            </a:r>
+            <a:r>
+              <a:rPr lang="ko-KR" altLang="en-US"/>
+              <a:t>번까지만 나올 것 같음</a:t>
+            </a:r>
+            <a:r>
+              <a:rPr lang="en-US" altLang="ko-KR"/>
+              <a:t>!)</a:t>
+            </a:r>
+          </a:p>
+        </p:txBody>
+      </p:sp>
+      <p:sp>
+        <p:nvSpPr>
+          <p:cNvPr id="10" name="TextBox 9">
+            <a:extLst>
+              <a:ext uri="{FF2B5EF4-FFF2-40B4-BE49-F238E27FC236}">
+                <a16:creationId xmlns:a16="http://schemas.microsoft.com/office/drawing/2014/main" id="{DB6B8CCD-B6E6-0EA0-3757-45E97F5139C6}"/>
+              </a:ext>
+            </a:extLst>
+          </p:cNvPr>
+          <p:cNvSpPr txBox="1"/>
+          <p:nvPr/>
+        </p:nvSpPr>
+        <p:spPr>
+          <a:xfrm>
+            <a:off x="5256212" y="104576"/>
+            <a:ext cx="6096000" cy="923330"/>
+          </a:xfrm>
+          <a:prstGeom prst="rect">
+            <a:avLst/>
+          </a:prstGeom>
+          <a:noFill/>
+        </p:spPr>
+        <p:txBody>
+          <a:bodyPr wrap="square">
+            <a:spAutoFit/>
+          </a:bodyPr>
+          <a:lstStyle/>
+          <a:p>
+            <a:r>
+              <a:rPr lang="en-US"/>
+              <a:t>There are only so many words you can use when describing a bottle of wine. Is a wine more likely to be "tropical" or "fruity"? </a:t>
+            </a:r>
+          </a:p>
+        </p:txBody>
+      </p:sp>
+      <p:sp>
+        <p:nvSpPr>
+          <p:cNvPr id="5" name="TextBox 4">
+            <a:extLst>
+              <a:ext uri="{FF2B5EF4-FFF2-40B4-BE49-F238E27FC236}">
+                <a16:creationId xmlns:a16="http://schemas.microsoft.com/office/drawing/2014/main" id="{90BD47EC-1AB2-F193-24BA-ABDA22565D12}"/>
+              </a:ext>
+            </a:extLst>
+          </p:cNvPr>
+          <p:cNvSpPr txBox="1"/>
+          <p:nvPr/>
+        </p:nvSpPr>
+        <p:spPr>
+          <a:xfrm>
+            <a:off x="76200" y="6488668"/>
+            <a:ext cx="6096000" cy="369332"/>
+          </a:xfrm>
+          <a:prstGeom prst="rect">
+            <a:avLst/>
+          </a:prstGeom>
+          <a:noFill/>
+        </p:spPr>
+        <p:txBody>
+          <a:bodyPr wrap="square">
+            <a:spAutoFit/>
+          </a:bodyPr>
+          <a:lstStyle/>
+          <a:p>
+            <a:r>
+              <a:rPr lang="en-US"/>
+              <a:t>https://gemini.google.com/share/18a93bbfb060</a:t>
+            </a:r>
+          </a:p>
+        </p:txBody>
+      </p:sp>
+    </p:spTree>
+    <p:extLst>
+      <p:ext uri="{BB962C8B-B14F-4D97-AF65-F5344CB8AC3E}">
+        <p14:creationId xmlns:p14="http://schemas.microsoft.com/office/powerpoint/2010/main" val="2046731435"/>
+      </p:ext>
+    </p:extLst>
+  </p:cSld>
+  <p:clrMapOvr>
+    <a:masterClrMapping/>
+  </p:clrMapOvr>
+</p:sld>
+</file>
+
+<file path=ppt/slides/slide19.xml><?xml version="1.0" encoding="utf-8"?>
+<p:sld xmlns:a="http://schemas.openxmlformats.org/drawingml/2006/main" xmlns:r="http://schemas.openxmlformats.org/officeDocument/2006/relationships" xmlns:p="http://schemas.openxmlformats.org/presentationml/2006/main">
+  <p:cSld>
+    <p:spTree>
+      <p:nvGrpSpPr>
+        <p:cNvPr id="1" name=""/>
+        <p:cNvGrpSpPr/>
+        <p:nvPr/>
+      </p:nvGrpSpPr>
+      <p:grpSpPr>
+        <a:xfrm>
+          <a:off x="0" y="0"/>
+          <a:ext cx="0" cy="0"/>
+          <a:chOff x="0" y="0"/>
+          <a:chExt cx="0" cy="0"/>
+        </a:xfrm>
+      </p:grpSpPr>
+      <p:sp>
+        <p:nvSpPr>
+          <p:cNvPr id="4" name="Title 3">
+            <a:extLst>
+              <a:ext uri="{FF2B5EF4-FFF2-40B4-BE49-F238E27FC236}">
+                <a16:creationId xmlns:a16="http://schemas.microsoft.com/office/drawing/2014/main" id="{3E8188C4-473F-5F4E-8352-32178D54622C}"/>
+              </a:ext>
+            </a:extLst>
+          </p:cNvPr>
+          <p:cNvSpPr>
+            <a:spLocks noGrp="1"/>
+          </p:cNvSpPr>
+          <p:nvPr>
+            <p:ph type="title"/>
+          </p:nvPr>
+        </p:nvSpPr>
+        <p:spPr/>
+        <p:txBody>
+          <a:bodyPr/>
+          <a:lstStyle/>
+          <a:p>
+            <a:r>
+              <a:rPr lang="ko-KR" altLang="en-US"/>
+              <a:t>실제 문장을 보고 더욱 기겁함 </a:t>
+            </a:r>
+            <a:r>
+              <a:rPr lang="en-US" altLang="ko-KR"/>
+              <a:t>(2</a:t>
+            </a:r>
+            <a:r>
+              <a:rPr lang="ko-KR" altLang="en-US"/>
+              <a:t>차기겁</a:t>
+            </a:r>
+            <a:r>
+              <a:rPr lang="en-US" altLang="ko-KR"/>
+              <a:t>)</a:t>
+            </a:r>
+            <a:endParaRPr lang="en-US"/>
+          </a:p>
+        </p:txBody>
+      </p:sp>
+      <p:pic>
+        <p:nvPicPr>
+          <p:cNvPr id="11" name="Content Placeholder 10">
+            <a:extLst>
+              <a:ext uri="{FF2B5EF4-FFF2-40B4-BE49-F238E27FC236}">
+                <a16:creationId xmlns:a16="http://schemas.microsoft.com/office/drawing/2014/main" id="{EF0F654C-3B3E-C81D-3560-36A1E32BEE5A}"/>
+              </a:ext>
+            </a:extLst>
+          </p:cNvPr>
+          <p:cNvPicPr>
+            <a:picLocks noGrp="1" noChangeAspect="1"/>
+          </p:cNvPicPr>
+          <p:nvPr>
+            <p:ph sz="half" idx="1"/>
+          </p:nvPr>
+        </p:nvPicPr>
+        <p:blipFill>
+          <a:blip r:embed="rId2"/>
+          <a:stretch>
+            <a:fillRect/>
+          </a:stretch>
+        </p:blipFill>
+        <p:spPr>
+          <a:xfrm>
+            <a:off x="838200" y="3954418"/>
+            <a:ext cx="5181600" cy="2069414"/>
+          </a:xfrm>
+          <a:prstGeom prst="rect">
+            <a:avLst/>
+          </a:prstGeom>
+        </p:spPr>
+      </p:pic>
+      <p:pic>
+        <p:nvPicPr>
+          <p:cNvPr id="14" name="Content Placeholder 13">
+            <a:extLst>
+              <a:ext uri="{FF2B5EF4-FFF2-40B4-BE49-F238E27FC236}">
+                <a16:creationId xmlns:a16="http://schemas.microsoft.com/office/drawing/2014/main" id="{4A42CC49-D3D5-844E-E753-CFB76F7FD1AE}"/>
+              </a:ext>
+            </a:extLst>
+          </p:cNvPr>
+          <p:cNvPicPr>
+            <a:picLocks noGrp="1" noChangeAspect="1"/>
+          </p:cNvPicPr>
+          <p:nvPr>
+            <p:ph sz="half" idx="2"/>
+          </p:nvPr>
+        </p:nvPicPr>
+        <p:blipFill>
+          <a:blip r:embed="rId3"/>
+          <a:stretch>
+            <a:fillRect/>
+          </a:stretch>
+        </p:blipFill>
+        <p:spPr>
+          <a:xfrm>
+            <a:off x="6172200" y="3485374"/>
+            <a:ext cx="5181600" cy="3007501"/>
+          </a:xfrm>
+          <a:prstGeom prst="rect">
+            <a:avLst/>
+          </a:prstGeom>
+        </p:spPr>
+      </p:pic>
+      <p:pic>
+        <p:nvPicPr>
+          <p:cNvPr id="16" name="Picture 15">
+            <a:extLst>
+              <a:ext uri="{FF2B5EF4-FFF2-40B4-BE49-F238E27FC236}">
+                <a16:creationId xmlns:a16="http://schemas.microsoft.com/office/drawing/2014/main" id="{87B4772E-7791-B134-D60A-07E07846D7A6}"/>
+              </a:ext>
+            </a:extLst>
+          </p:cNvPr>
+          <p:cNvPicPr>
+            <a:picLocks noChangeAspect="1"/>
+          </p:cNvPicPr>
+          <p:nvPr/>
+        </p:nvPicPr>
+        <p:blipFill>
+          <a:blip r:embed="rId4"/>
+          <a:stretch>
+            <a:fillRect/>
+          </a:stretch>
+        </p:blipFill>
+        <p:spPr>
+          <a:xfrm>
+            <a:off x="838200" y="1396113"/>
+            <a:ext cx="7506748" cy="1914792"/>
+          </a:xfrm>
+          <a:prstGeom prst="rect">
+            <a:avLst/>
+          </a:prstGeom>
+        </p:spPr>
+      </p:pic>
+    </p:spTree>
+    <p:extLst>
+      <p:ext uri="{BB962C8B-B14F-4D97-AF65-F5344CB8AC3E}">
+        <p14:creationId xmlns:p14="http://schemas.microsoft.com/office/powerpoint/2010/main" val="3107316515"/>
       </p:ext>
     </p:extLst>
   </p:cSld>
@@ -4535,6 +6372,819 @@
     <p:extLst>
       <p:ext uri="{BB962C8B-B14F-4D97-AF65-F5344CB8AC3E}">
         <p14:creationId xmlns:p14="http://schemas.microsoft.com/office/powerpoint/2010/main" val="3591352158"/>
+      </p:ext>
+    </p:extLst>
+  </p:cSld>
+  <p:clrMapOvr>
+    <a:masterClrMapping/>
+  </p:clrMapOvr>
+</p:sld>
+</file>
+
+<file path=ppt/slides/slide20.xml><?xml version="1.0" encoding="utf-8"?>
+<p:sld xmlns:a="http://schemas.openxmlformats.org/drawingml/2006/main" xmlns:r="http://schemas.openxmlformats.org/officeDocument/2006/relationships" xmlns:p="http://schemas.openxmlformats.org/presentationml/2006/main">
+  <p:cSld>
+    <p:spTree>
+      <p:nvGrpSpPr>
+        <p:cNvPr id="1" name=""/>
+        <p:cNvGrpSpPr/>
+        <p:nvPr/>
+      </p:nvGrpSpPr>
+      <p:grpSpPr>
+        <a:xfrm>
+          <a:off x="0" y="0"/>
+          <a:ext cx="0" cy="0"/>
+          <a:chOff x="0" y="0"/>
+          <a:chExt cx="0" cy="0"/>
+        </a:xfrm>
+      </p:grpSpPr>
+      <p:sp>
+        <p:nvSpPr>
+          <p:cNvPr id="2" name="Title 1">
+            <a:extLst>
+              <a:ext uri="{FF2B5EF4-FFF2-40B4-BE49-F238E27FC236}">
+                <a16:creationId xmlns:a16="http://schemas.microsoft.com/office/drawing/2014/main" id="{7EE3EC1B-B4E9-2327-F1C7-6858FB89543B}"/>
+              </a:ext>
+            </a:extLst>
+          </p:cNvPr>
+          <p:cNvSpPr>
+            <a:spLocks noGrp="1"/>
+          </p:cNvSpPr>
+          <p:nvPr>
+            <p:ph type="title"/>
+          </p:nvPr>
+        </p:nvSpPr>
+        <p:spPr/>
+        <p:txBody>
+          <a:bodyPr/>
+          <a:lstStyle/>
+          <a:p>
+            <a:r>
+              <a:rPr lang="ko-KR" altLang="en-US"/>
+              <a:t>힌트 보고 </a:t>
+            </a:r>
+            <a:r>
+              <a:rPr lang="en-US" altLang="ko-KR"/>
+              <a:t>3</a:t>
+            </a:r>
+            <a:r>
+              <a:rPr lang="ko-KR" altLang="en-US"/>
+              <a:t>차기겁</a:t>
+            </a:r>
+            <a:endParaRPr lang="en-US"/>
+          </a:p>
+        </p:txBody>
+      </p:sp>
+      <p:sp>
+        <p:nvSpPr>
+          <p:cNvPr id="3" name="Content Placeholder 2">
+            <a:extLst>
+              <a:ext uri="{FF2B5EF4-FFF2-40B4-BE49-F238E27FC236}">
+                <a16:creationId xmlns:a16="http://schemas.microsoft.com/office/drawing/2014/main" id="{17F17111-535E-285F-3745-F847092FEB38}"/>
+              </a:ext>
+            </a:extLst>
+          </p:cNvPr>
+          <p:cNvSpPr>
+            <a:spLocks noGrp="1"/>
+          </p:cNvSpPr>
+          <p:nvPr>
+            <p:ph idx="1"/>
+          </p:nvPr>
+        </p:nvSpPr>
+        <p:spPr/>
+        <p:txBody>
+          <a:bodyPr/>
+          <a:lstStyle/>
+          <a:p>
+            <a:r>
+              <a:rPr lang="en-US"/>
+              <a:t>Hint: Use a map to check each description for the string tropical, then count up the number of times this is True. Repeat this for fruity. Finally, create a Series combining the two values.</a:t>
+            </a:r>
+          </a:p>
+          <a:p>
+            <a:endParaRPr lang="en-US"/>
+          </a:p>
+        </p:txBody>
+      </p:sp>
+      <p:pic>
+        <p:nvPicPr>
+          <p:cNvPr id="5" name="Picture 4">
+            <a:extLst>
+              <a:ext uri="{FF2B5EF4-FFF2-40B4-BE49-F238E27FC236}">
+                <a16:creationId xmlns:a16="http://schemas.microsoft.com/office/drawing/2014/main" id="{9FB9AFC2-CADB-0200-8F20-236AE9166567}"/>
+              </a:ext>
+            </a:extLst>
+          </p:cNvPr>
+          <p:cNvPicPr>
+            <a:picLocks noChangeAspect="1"/>
+          </p:cNvPicPr>
+          <p:nvPr/>
+        </p:nvPicPr>
+        <p:blipFill>
+          <a:blip r:embed="rId2"/>
+          <a:stretch>
+            <a:fillRect/>
+          </a:stretch>
+        </p:blipFill>
+        <p:spPr>
+          <a:xfrm>
+            <a:off x="1518598" y="3237995"/>
+            <a:ext cx="9154803" cy="3620005"/>
+          </a:xfrm>
+          <a:prstGeom prst="rect">
+            <a:avLst/>
+          </a:prstGeom>
+        </p:spPr>
+      </p:pic>
+    </p:spTree>
+    <p:extLst>
+      <p:ext uri="{BB962C8B-B14F-4D97-AF65-F5344CB8AC3E}">
+        <p14:creationId xmlns:p14="http://schemas.microsoft.com/office/powerpoint/2010/main" val="4076337555"/>
+      </p:ext>
+    </p:extLst>
+  </p:cSld>
+  <p:clrMapOvr>
+    <a:masterClrMapping/>
+  </p:clrMapOvr>
+</p:sld>
+</file>
+
+<file path=ppt/slides/slide21.xml><?xml version="1.0" encoding="utf-8"?>
+<p:sld xmlns:a="http://schemas.openxmlformats.org/drawingml/2006/main" xmlns:r="http://schemas.openxmlformats.org/officeDocument/2006/relationships" xmlns:p="http://schemas.openxmlformats.org/presentationml/2006/main">
+  <p:cSld>
+    <p:spTree>
+      <p:nvGrpSpPr>
+        <p:cNvPr id="1" name=""/>
+        <p:cNvGrpSpPr/>
+        <p:nvPr/>
+      </p:nvGrpSpPr>
+      <p:grpSpPr>
+        <a:xfrm>
+          <a:off x="0" y="0"/>
+          <a:ext cx="0" cy="0"/>
+          <a:chOff x="0" y="0"/>
+          <a:chExt cx="0" cy="0"/>
+        </a:xfrm>
+      </p:grpSpPr>
+      <p:sp>
+        <p:nvSpPr>
+          <p:cNvPr id="2" name="Title 1">
+            <a:extLst>
+              <a:ext uri="{FF2B5EF4-FFF2-40B4-BE49-F238E27FC236}">
+                <a16:creationId xmlns:a16="http://schemas.microsoft.com/office/drawing/2014/main" id="{308F8D5F-B6B7-308D-322B-8292FA1458F2}"/>
+              </a:ext>
+            </a:extLst>
+          </p:cNvPr>
+          <p:cNvSpPr>
+            <a:spLocks noGrp="1"/>
+          </p:cNvSpPr>
+          <p:nvPr>
+            <p:ph type="title"/>
+          </p:nvPr>
+        </p:nvSpPr>
+        <p:spPr/>
+        <p:txBody>
+          <a:bodyPr/>
+          <a:lstStyle/>
+          <a:p>
+            <a:r>
+              <a:rPr lang="ko-KR" altLang="en-US"/>
+              <a:t>답 틀린 에러 메시지 보고 </a:t>
+            </a:r>
+            <a:r>
+              <a:rPr lang="en-US" altLang="ko-KR"/>
+              <a:t>4</a:t>
+            </a:r>
+            <a:r>
+              <a:rPr lang="ko-KR" altLang="en-US"/>
+              <a:t>차기겁 </a:t>
+            </a:r>
+            <a:r>
+              <a:rPr lang="en-US" altLang="ko-KR"/>
+              <a:t>(Q2.</a:t>
+            </a:r>
+            <a:r>
+              <a:rPr lang="ko-KR" altLang="en-US"/>
+              <a:t>이슈</a:t>
+            </a:r>
+            <a:r>
+              <a:rPr lang="en-US" altLang="ko-KR"/>
+              <a:t>)</a:t>
+            </a:r>
+            <a:endParaRPr lang="en-US"/>
+          </a:p>
+        </p:txBody>
+      </p:sp>
+      <p:sp>
+        <p:nvSpPr>
+          <p:cNvPr id="3" name="Content Placeholder 2">
+            <a:extLst>
+              <a:ext uri="{FF2B5EF4-FFF2-40B4-BE49-F238E27FC236}">
+                <a16:creationId xmlns:a16="http://schemas.microsoft.com/office/drawing/2014/main" id="{F0999DEA-EFD1-569D-01B3-EB8D4FE171FC}"/>
+              </a:ext>
+            </a:extLst>
+          </p:cNvPr>
+          <p:cNvSpPr>
+            <a:spLocks noGrp="1"/>
+          </p:cNvSpPr>
+          <p:nvPr>
+            <p:ph idx="1"/>
+          </p:nvPr>
+        </p:nvSpPr>
+        <p:spPr/>
+        <p:txBody>
+          <a:bodyPr/>
+          <a:lstStyle/>
+          <a:p>
+            <a:r>
+              <a:rPr lang="ko-KR" altLang="en-US"/>
+              <a:t>의문점</a:t>
+            </a:r>
+            <a:endParaRPr lang="en-US" altLang="ko-KR"/>
+          </a:p>
+          <a:p>
+            <a:pPr lvl="1"/>
+            <a:r>
+              <a:rPr lang="en-US" altLang="ko-KR"/>
+              <a:t>Q1.</a:t>
+            </a:r>
+            <a:r>
+              <a:rPr lang="ko-KR" altLang="en-US"/>
+              <a:t> 오호</a:t>
+            </a:r>
+            <a:r>
+              <a:rPr lang="en-US" altLang="ko-KR"/>
+              <a:t>. </a:t>
+            </a:r>
+            <a:r>
+              <a:rPr lang="ko-KR" altLang="en-US"/>
+              <a:t>그럼 </a:t>
+            </a:r>
+            <a:r>
+              <a:rPr lang="en-US" altLang="ko-KR"/>
+              <a:t>'tropicalfruitytropical' </a:t>
+            </a:r>
+            <a:r>
+              <a:rPr lang="ko-KR" altLang="en-US"/>
+              <a:t>이라는 설명</a:t>
+            </a:r>
+            <a:r>
+              <a:rPr lang="en-US" altLang="ko-KR"/>
+              <a:t>(description)</a:t>
+            </a:r>
+            <a:r>
+              <a:rPr lang="ko-KR" altLang="en-US"/>
+              <a:t>에서는 </a:t>
+            </a:r>
+            <a:r>
+              <a:rPr lang="en-US" altLang="ko-KR"/>
+              <a:t>2</a:t>
+            </a:r>
+            <a:r>
+              <a:rPr lang="ko-KR" altLang="en-US"/>
+              <a:t>개</a:t>
+            </a:r>
+            <a:r>
+              <a:rPr lang="en-US" altLang="ko-KR"/>
+              <a:t>,1</a:t>
+            </a:r>
+            <a:r>
+              <a:rPr lang="ko-KR" altLang="en-US"/>
+              <a:t>개 각각을 세야하는것</a:t>
+            </a:r>
+            <a:r>
+              <a:rPr lang="en-US" altLang="ko-KR"/>
+              <a:t>?</a:t>
+            </a:r>
+          </a:p>
+          <a:p>
+            <a:pPr lvl="1"/>
+            <a:r>
+              <a:rPr lang="en-US" altLang="ko-KR"/>
+              <a:t>Q2. </a:t>
+            </a:r>
+            <a:r>
+              <a:rPr lang="ko-KR" altLang="en-US"/>
+              <a:t>와인별로 세는건가</a:t>
+            </a:r>
+            <a:r>
+              <a:rPr lang="en-US" altLang="ko-KR"/>
+              <a:t>, </a:t>
+            </a:r>
+            <a:r>
+              <a:rPr lang="ko-KR" altLang="en-US"/>
+              <a:t>단어별로 세는건가</a:t>
+            </a:r>
+            <a:r>
+              <a:rPr lang="en-US" altLang="ko-KR"/>
+              <a:t>?</a:t>
+            </a:r>
+          </a:p>
+          <a:p>
+            <a:r>
+              <a:rPr lang="ko-KR" altLang="en-US"/>
+              <a:t>와인별로 세어버렸음</a:t>
+            </a:r>
+            <a:r>
+              <a:rPr lang="en-US" altLang="ko-KR"/>
+              <a:t>. </a:t>
+            </a:r>
+            <a:r>
+              <a:rPr lang="ko-KR" altLang="en-US"/>
+              <a:t>단어별로 세도록 고치기만 하면 되기는 한데</a:t>
+            </a:r>
+            <a:r>
+              <a:rPr lang="en-US" altLang="ko-KR"/>
+              <a:t>… </a:t>
+            </a:r>
+            <a:r>
+              <a:rPr lang="ko-KR" altLang="en-US"/>
+              <a:t>이미 </a:t>
+            </a:r>
+            <a:r>
+              <a:rPr lang="en-US" altLang="ko-KR"/>
+              <a:t>3</a:t>
+            </a:r>
+            <a:r>
+              <a:rPr lang="ko-KR" altLang="en-US"/>
+              <a:t>차기겁한 시점에서 통과가 안되었고 이것도 불명확했다는 점에서 멘붕이 온 것 같음</a:t>
+            </a:r>
+            <a:r>
+              <a:rPr lang="en-US" altLang="ko-KR"/>
+              <a:t>.</a:t>
+            </a:r>
+            <a:endParaRPr lang="en-US"/>
+          </a:p>
+        </p:txBody>
+      </p:sp>
+    </p:spTree>
+    <p:extLst>
+      <p:ext uri="{BB962C8B-B14F-4D97-AF65-F5344CB8AC3E}">
+        <p14:creationId xmlns:p14="http://schemas.microsoft.com/office/powerpoint/2010/main" val="8036563"/>
+      </p:ext>
+    </p:extLst>
+  </p:cSld>
+  <p:clrMapOvr>
+    <a:masterClrMapping/>
+  </p:clrMapOvr>
+</p:sld>
+</file>
+
+<file path=ppt/slides/slide22.xml><?xml version="1.0" encoding="utf-8"?>
+<p:sld xmlns:a="http://schemas.openxmlformats.org/drawingml/2006/main" xmlns:r="http://schemas.openxmlformats.org/officeDocument/2006/relationships" xmlns:p="http://schemas.openxmlformats.org/presentationml/2006/main">
+  <p:cSld>
+    <p:spTree>
+      <p:nvGrpSpPr>
+        <p:cNvPr id="1" name="">
+          <a:extLst>
+            <a:ext uri="{FF2B5EF4-FFF2-40B4-BE49-F238E27FC236}">
+              <a16:creationId xmlns:a16="http://schemas.microsoft.com/office/drawing/2014/main" id="{5A04BED7-2319-0347-E164-E08FBDFC7875}"/>
+            </a:ext>
+          </a:extLst>
+        </p:cNvPr>
+        <p:cNvGrpSpPr/>
+        <p:nvPr/>
+      </p:nvGrpSpPr>
+      <p:grpSpPr>
+        <a:xfrm>
+          <a:off x="0" y="0"/>
+          <a:ext cx="0" cy="0"/>
+          <a:chOff x="0" y="0"/>
+          <a:chExt cx="0" cy="0"/>
+        </a:xfrm>
+      </p:grpSpPr>
+      <p:sp>
+        <p:nvSpPr>
+          <p:cNvPr id="2" name="Title 1">
+            <a:extLst>
+              <a:ext uri="{FF2B5EF4-FFF2-40B4-BE49-F238E27FC236}">
+                <a16:creationId xmlns:a16="http://schemas.microsoft.com/office/drawing/2014/main" id="{E9697116-47A9-F98D-6F5A-E2ADBD138B2C}"/>
+              </a:ext>
+            </a:extLst>
+          </p:cNvPr>
+          <p:cNvSpPr>
+            <a:spLocks noGrp="1"/>
+          </p:cNvSpPr>
+          <p:nvPr>
+            <p:ph type="title"/>
+          </p:nvPr>
+        </p:nvSpPr>
+        <p:spPr/>
+        <p:txBody>
+          <a:bodyPr/>
+          <a:lstStyle/>
+          <a:p>
+            <a:r>
+              <a:rPr lang="ko-KR" altLang="en-US"/>
+              <a:t>악랄한 </a:t>
+            </a:r>
+            <a:r>
+              <a:rPr lang="en-US" altLang="ko-KR"/>
+              <a:t>6</a:t>
+            </a:r>
+            <a:r>
+              <a:rPr lang="ko-KR" altLang="en-US"/>
+              <a:t>번 문제</a:t>
+            </a:r>
+            <a:endParaRPr lang="en-US"/>
+          </a:p>
+        </p:txBody>
+      </p:sp>
+      <p:sp>
+        <p:nvSpPr>
+          <p:cNvPr id="6" name="Text Placeholder 5">
+            <a:extLst>
+              <a:ext uri="{FF2B5EF4-FFF2-40B4-BE49-F238E27FC236}">
+                <a16:creationId xmlns:a16="http://schemas.microsoft.com/office/drawing/2014/main" id="{7871F3D4-32A8-A455-EE94-699DC6AD2194}"/>
+              </a:ext>
+            </a:extLst>
+          </p:cNvPr>
+          <p:cNvSpPr>
+            <a:spLocks noGrp="1"/>
+          </p:cNvSpPr>
+          <p:nvPr>
+            <p:ph type="body" idx="1"/>
+          </p:nvPr>
+        </p:nvSpPr>
+        <p:spPr/>
+        <p:txBody>
+          <a:bodyPr>
+            <a:normAutofit lnSpcReduction="10000"/>
+          </a:bodyPr>
+          <a:lstStyle/>
+          <a:p>
+            <a:r>
+              <a:rPr lang="ko-KR" altLang="en-US"/>
+              <a:t>원래 문제 내용</a:t>
+            </a:r>
+            <a:endParaRPr lang="en-US"/>
+          </a:p>
+        </p:txBody>
+      </p:sp>
+      <p:sp>
+        <p:nvSpPr>
+          <p:cNvPr id="4" name="Content Placeholder 3">
+            <a:extLst>
+              <a:ext uri="{FF2B5EF4-FFF2-40B4-BE49-F238E27FC236}">
+                <a16:creationId xmlns:a16="http://schemas.microsoft.com/office/drawing/2014/main" id="{8897FA4A-1E86-B15B-8E83-ADDE07E78008}"/>
+              </a:ext>
+            </a:extLst>
+          </p:cNvPr>
+          <p:cNvSpPr>
+            <a:spLocks noGrp="1"/>
+          </p:cNvSpPr>
+          <p:nvPr>
+            <p:ph sz="half" idx="2"/>
+          </p:nvPr>
+        </p:nvSpPr>
+        <p:spPr/>
+        <p:txBody>
+          <a:bodyPr>
+            <a:normAutofit/>
+          </a:bodyPr>
+          <a:lstStyle/>
+          <a:p>
+            <a:pPr marL="0" indent="0">
+              <a:buNone/>
+            </a:pPr>
+            <a:r>
+              <a:rPr lang="en-US"/>
+              <a:t>Create a Series `descriptor_counts` counting how many times each of these two words appears in the `description` column in the dataset. (For simplicity, let's ignore the capitalized versions of these words.)</a:t>
+            </a:r>
+          </a:p>
+        </p:txBody>
+      </p:sp>
+      <p:sp>
+        <p:nvSpPr>
+          <p:cNvPr id="7" name="Text Placeholder 6">
+            <a:extLst>
+              <a:ext uri="{FF2B5EF4-FFF2-40B4-BE49-F238E27FC236}">
+                <a16:creationId xmlns:a16="http://schemas.microsoft.com/office/drawing/2014/main" id="{BF7DD38A-8960-2E01-7804-E31FD35A2B17}"/>
+              </a:ext>
+            </a:extLst>
+          </p:cNvPr>
+          <p:cNvSpPr>
+            <a:spLocks noGrp="1"/>
+          </p:cNvSpPr>
+          <p:nvPr>
+            <p:ph type="body" sz="quarter" idx="3"/>
+          </p:nvPr>
+        </p:nvSpPr>
+        <p:spPr/>
+        <p:txBody>
+          <a:bodyPr>
+            <a:normAutofit lnSpcReduction="10000"/>
+          </a:bodyPr>
+          <a:lstStyle/>
+          <a:p>
+            <a:r>
+              <a:rPr lang="ko-KR" altLang="en-US"/>
+              <a:t>실제 요구한 내용</a:t>
+            </a:r>
+            <a:endParaRPr lang="en-US"/>
+          </a:p>
+          <a:p>
+            <a:r>
+              <a:rPr lang="en-US"/>
+              <a:t>Hint + solution + gemini3</a:t>
+            </a:r>
+          </a:p>
+        </p:txBody>
+      </p:sp>
+      <p:sp>
+        <p:nvSpPr>
+          <p:cNvPr id="8" name="Content Placeholder 7">
+            <a:extLst>
+              <a:ext uri="{FF2B5EF4-FFF2-40B4-BE49-F238E27FC236}">
+                <a16:creationId xmlns:a16="http://schemas.microsoft.com/office/drawing/2014/main" id="{77004BCE-4ED0-89CD-04B4-DE3089F90032}"/>
+              </a:ext>
+            </a:extLst>
+          </p:cNvPr>
+          <p:cNvSpPr>
+            <a:spLocks noGrp="1"/>
+          </p:cNvSpPr>
+          <p:nvPr>
+            <p:ph sz="quarter" idx="4"/>
+          </p:nvPr>
+        </p:nvSpPr>
+        <p:spPr/>
+        <p:txBody>
+          <a:bodyPr>
+            <a:normAutofit/>
+          </a:bodyPr>
+          <a:lstStyle/>
+          <a:p>
+            <a:pPr marL="0" indent="0">
+              <a:buNone/>
+            </a:pPr>
+            <a:r>
+              <a:rPr lang="en-US"/>
+              <a:t>"Create a Series `descriptor_counts` where each value is </a:t>
+            </a:r>
+            <a:r>
+              <a:rPr lang="en-US" b="1"/>
+              <a:t>the number of rows</a:t>
+            </a:r>
+            <a:r>
+              <a:rPr lang="en-US"/>
+              <a:t> containing the words 'tropical' or 'fruity' (at least once) in the `description` column. (Ignore case, and ignore multiple occurrences within a single row.)"</a:t>
+            </a:r>
+          </a:p>
+        </p:txBody>
+      </p:sp>
+      <p:sp>
+        <p:nvSpPr>
+          <p:cNvPr id="10" name="TextBox 9">
+            <a:extLst>
+              <a:ext uri="{FF2B5EF4-FFF2-40B4-BE49-F238E27FC236}">
+                <a16:creationId xmlns:a16="http://schemas.microsoft.com/office/drawing/2014/main" id="{517226E1-28C2-3577-0C70-43E85BA6DD2E}"/>
+              </a:ext>
+            </a:extLst>
+          </p:cNvPr>
+          <p:cNvSpPr txBox="1"/>
+          <p:nvPr/>
+        </p:nvSpPr>
+        <p:spPr>
+          <a:xfrm>
+            <a:off x="5256212" y="104576"/>
+            <a:ext cx="6096000" cy="923330"/>
+          </a:xfrm>
+          <a:prstGeom prst="rect">
+            <a:avLst/>
+          </a:prstGeom>
+          <a:noFill/>
+        </p:spPr>
+        <p:txBody>
+          <a:bodyPr wrap="square">
+            <a:spAutoFit/>
+          </a:bodyPr>
+          <a:lstStyle/>
+          <a:p>
+            <a:r>
+              <a:rPr lang="en-US"/>
+              <a:t>There are only so many words you can use when describing a bottle of wine. Is a wine more likely to be "tropical" or "fruity"? </a:t>
+            </a:r>
+          </a:p>
+        </p:txBody>
+      </p:sp>
+      <p:sp>
+        <p:nvSpPr>
+          <p:cNvPr id="5" name="TextBox 4">
+            <a:extLst>
+              <a:ext uri="{FF2B5EF4-FFF2-40B4-BE49-F238E27FC236}">
+                <a16:creationId xmlns:a16="http://schemas.microsoft.com/office/drawing/2014/main" id="{112EC602-2F66-E97E-DC69-93B724DDB8D8}"/>
+              </a:ext>
+            </a:extLst>
+          </p:cNvPr>
+          <p:cNvSpPr txBox="1"/>
+          <p:nvPr/>
+        </p:nvSpPr>
+        <p:spPr>
+          <a:xfrm>
+            <a:off x="98427" y="5657671"/>
+            <a:ext cx="6096000" cy="954107"/>
+          </a:xfrm>
+          <a:prstGeom prst="rect">
+            <a:avLst/>
+          </a:prstGeom>
+          <a:noFill/>
+        </p:spPr>
+        <p:txBody>
+          <a:bodyPr wrap="square">
+            <a:spAutoFit/>
+          </a:bodyPr>
+          <a:lstStyle/>
+          <a:p>
+            <a:r>
+              <a:rPr lang="ko-KR" altLang="en-US" sz="1400"/>
+              <a:t>의문점</a:t>
+            </a:r>
+            <a:endParaRPr lang="en-US" altLang="ko-KR" sz="1400"/>
+          </a:p>
+          <a:p>
+            <a:pPr lvl="1"/>
+            <a:r>
+              <a:rPr lang="en-US" altLang="ko-KR" sz="1400"/>
+              <a:t>Q1.</a:t>
+            </a:r>
+            <a:r>
+              <a:rPr lang="ko-KR" altLang="en-US" sz="1400"/>
+              <a:t> 오호</a:t>
+            </a:r>
+            <a:r>
+              <a:rPr lang="en-US" altLang="ko-KR" sz="1400"/>
+              <a:t>. </a:t>
+            </a:r>
+            <a:r>
+              <a:rPr lang="ko-KR" altLang="en-US" sz="1400"/>
+              <a:t>그럼 </a:t>
+            </a:r>
+            <a:r>
+              <a:rPr lang="en-US" altLang="ko-KR" sz="1400"/>
+              <a:t>'tropicalfruitytropical' </a:t>
+            </a:r>
+            <a:r>
+              <a:rPr lang="ko-KR" altLang="en-US" sz="1400"/>
+              <a:t>이라는 설명</a:t>
+            </a:r>
+            <a:r>
+              <a:rPr lang="en-US" altLang="ko-KR" sz="1400"/>
+              <a:t>(description)</a:t>
+            </a:r>
+            <a:r>
+              <a:rPr lang="ko-KR" altLang="en-US" sz="1400"/>
+              <a:t>에서는 </a:t>
+            </a:r>
+            <a:r>
+              <a:rPr lang="en-US" altLang="ko-KR" sz="1400"/>
+              <a:t>2</a:t>
+            </a:r>
+            <a:r>
+              <a:rPr lang="ko-KR" altLang="en-US" sz="1400"/>
+              <a:t>개</a:t>
+            </a:r>
+            <a:r>
+              <a:rPr lang="en-US" altLang="ko-KR" sz="1400"/>
+              <a:t>,1</a:t>
+            </a:r>
+            <a:r>
+              <a:rPr lang="ko-KR" altLang="en-US" sz="1400"/>
+              <a:t>개 각각을 세야하는것</a:t>
+            </a:r>
+            <a:r>
+              <a:rPr lang="en-US" altLang="ko-KR" sz="1400"/>
+              <a:t>? </a:t>
+            </a:r>
+            <a:r>
+              <a:rPr lang="en-US" altLang="ko-KR" sz="1400" b="1"/>
+              <a:t>1</a:t>
+            </a:r>
+            <a:r>
+              <a:rPr lang="ko-KR" altLang="en-US" sz="1400" b="1"/>
+              <a:t>번씩만 </a:t>
+            </a:r>
+            <a:r>
+              <a:rPr lang="en-US" altLang="ko-KR" sz="1400" b="1"/>
+              <a:t>!</a:t>
+            </a:r>
+          </a:p>
+          <a:p>
+            <a:pPr lvl="1"/>
+            <a:r>
+              <a:rPr lang="en-US" altLang="ko-KR" sz="1400"/>
+              <a:t>Q2. </a:t>
+            </a:r>
+            <a:r>
+              <a:rPr lang="ko-KR" altLang="en-US" sz="1400"/>
+              <a:t>와인별로 세는건가</a:t>
+            </a:r>
+            <a:r>
+              <a:rPr lang="en-US" altLang="ko-KR" sz="1400"/>
+              <a:t>, </a:t>
+            </a:r>
+            <a:r>
+              <a:rPr lang="ko-KR" altLang="en-US" sz="1400"/>
+              <a:t>단어별로 세는건가</a:t>
+            </a:r>
+            <a:r>
+              <a:rPr lang="en-US" altLang="ko-KR" sz="1400"/>
+              <a:t>? </a:t>
+            </a:r>
+            <a:r>
+              <a:rPr lang="ko-KR" altLang="en-US" sz="1400" b="1"/>
+              <a:t>단어별</a:t>
+            </a:r>
+            <a:r>
+              <a:rPr lang="en-US" altLang="ko-KR" sz="1400" b="1"/>
+              <a:t>!</a:t>
+            </a:r>
+          </a:p>
+        </p:txBody>
+      </p:sp>
+    </p:spTree>
+    <p:extLst>
+      <p:ext uri="{BB962C8B-B14F-4D97-AF65-F5344CB8AC3E}">
+        <p14:creationId xmlns:p14="http://schemas.microsoft.com/office/powerpoint/2010/main" val="2150086178"/>
+      </p:ext>
+    </p:extLst>
+  </p:cSld>
+  <p:clrMapOvr>
+    <a:masterClrMapping/>
+  </p:clrMapOvr>
+</p:sld>
+</file>
+
+<file path=ppt/slides/slide23.xml><?xml version="1.0" encoding="utf-8"?>
+<p:sld xmlns:a="http://schemas.openxmlformats.org/drawingml/2006/main" xmlns:r="http://schemas.openxmlformats.org/officeDocument/2006/relationships" xmlns:p="http://schemas.openxmlformats.org/presentationml/2006/main">
+  <p:cSld>
+    <p:spTree>
+      <p:nvGrpSpPr>
+        <p:cNvPr id="1" name=""/>
+        <p:cNvGrpSpPr/>
+        <p:nvPr/>
+      </p:nvGrpSpPr>
+      <p:grpSpPr>
+        <a:xfrm>
+          <a:off x="0" y="0"/>
+          <a:ext cx="0" cy="0"/>
+          <a:chOff x="0" y="0"/>
+          <a:chExt cx="0" cy="0"/>
+        </a:xfrm>
+      </p:grpSpPr>
+      <p:sp>
+        <p:nvSpPr>
+          <p:cNvPr id="2" name="Title 1">
+            <a:extLst>
+              <a:ext uri="{FF2B5EF4-FFF2-40B4-BE49-F238E27FC236}">
+                <a16:creationId xmlns:a16="http://schemas.microsoft.com/office/drawing/2014/main" id="{9602D8C2-827C-BD30-1B1C-D1FF2FAB9BC1}"/>
+              </a:ext>
+            </a:extLst>
+          </p:cNvPr>
+          <p:cNvSpPr>
+            <a:spLocks noGrp="1"/>
+          </p:cNvSpPr>
+          <p:nvPr>
+            <p:ph type="title"/>
+          </p:nvPr>
+        </p:nvSpPr>
+        <p:spPr/>
+        <p:txBody>
+          <a:bodyPr/>
+          <a:lstStyle/>
+          <a:p>
+            <a:endParaRPr lang="en-US"/>
+          </a:p>
+        </p:txBody>
+      </p:sp>
+      <p:sp>
+        <p:nvSpPr>
+          <p:cNvPr id="3" name="Content Placeholder 2">
+            <a:extLst>
+              <a:ext uri="{FF2B5EF4-FFF2-40B4-BE49-F238E27FC236}">
+                <a16:creationId xmlns:a16="http://schemas.microsoft.com/office/drawing/2014/main" id="{8EEC2F18-FEEF-BF25-FB42-4CC1D3028B46}"/>
+              </a:ext>
+            </a:extLst>
+          </p:cNvPr>
+          <p:cNvSpPr>
+            <a:spLocks noGrp="1"/>
+          </p:cNvSpPr>
+          <p:nvPr>
+            <p:ph idx="1"/>
+          </p:nvPr>
+        </p:nvSpPr>
+        <p:spPr/>
+        <p:txBody>
+          <a:bodyPr/>
+          <a:lstStyle/>
+          <a:p>
+            <a:endParaRPr lang="en-US"/>
+          </a:p>
+        </p:txBody>
+      </p:sp>
+    </p:spTree>
+    <p:extLst>
+      <p:ext uri="{BB962C8B-B14F-4D97-AF65-F5344CB8AC3E}">
+        <p14:creationId xmlns:p14="http://schemas.microsoft.com/office/powerpoint/2010/main" val="2791698948"/>
       </p:ext>
     </p:extLst>
   </p:cSld>

</xml_diff>

<commit_message>
Day 4 complete (Pandas finished, Intermediate ML starting (3/7 kinda done))
</commit_message>
<xml_diff>
--- a/Kaggle!.pptx
+++ b/Kaggle!.pptx
@@ -5,7 +5,7 @@
     <p:sldMasterId id="2147483648" r:id="rId1"/>
   </p:sldMasterIdLst>
   <p:notesMasterIdLst>
-    <p:notesMasterId r:id="rId25"/>
+    <p:notesMasterId r:id="rId29"/>
   </p:notesMasterIdLst>
   <p:sldIdLst>
     <p:sldId id="256" r:id="rId2"/>
@@ -31,6 +31,10 @@
     <p:sldId id="277" r:id="rId22"/>
     <p:sldId id="279" r:id="rId23"/>
     <p:sldId id="274" r:id="rId24"/>
+    <p:sldId id="280" r:id="rId25"/>
+    <p:sldId id="283" r:id="rId26"/>
+    <p:sldId id="281" r:id="rId27"/>
+    <p:sldId id="282" r:id="rId28"/>
   </p:sldIdLst>
   <p:sldSz cx="12192000" cy="6858000"/>
   <p:notesSz cx="6858000" cy="9144000"/>
@@ -219,7 +223,7 @@
           <a:p>
             <a:fld id="{696CDF9F-ADA0-4C49-A263-B2AE48107B92}" type="datetimeFigureOut">
               <a:rPr lang="en-US" smtClean="0"/>
-              <a:t>2/6/2026</a:t>
+              <a:t>2/20/2026</a:t>
             </a:fld>
             <a:endParaRPr lang="en-US"/>
           </a:p>
@@ -801,7 +805,7 @@
           <a:p>
             <a:fld id="{8B8BF7D9-AC52-4AC2-BEDB-A5D1257FD4A4}" type="datetimeFigureOut">
               <a:rPr lang="en-US" smtClean="0"/>
-              <a:t>2/6/2026</a:t>
+              <a:t>2/20/2026</a:t>
             </a:fld>
             <a:endParaRPr lang="en-US"/>
           </a:p>
@@ -999,7 +1003,7 @@
           <a:p>
             <a:fld id="{8B8BF7D9-AC52-4AC2-BEDB-A5D1257FD4A4}" type="datetimeFigureOut">
               <a:rPr lang="en-US" smtClean="0"/>
-              <a:t>2/6/2026</a:t>
+              <a:t>2/20/2026</a:t>
             </a:fld>
             <a:endParaRPr lang="en-US"/>
           </a:p>
@@ -1207,7 +1211,7 @@
           <a:p>
             <a:fld id="{8B8BF7D9-AC52-4AC2-BEDB-A5D1257FD4A4}" type="datetimeFigureOut">
               <a:rPr lang="en-US" smtClean="0"/>
-              <a:t>2/6/2026</a:t>
+              <a:t>2/20/2026</a:t>
             </a:fld>
             <a:endParaRPr lang="en-US"/>
           </a:p>
@@ -1405,7 +1409,7 @@
           <a:p>
             <a:fld id="{8B8BF7D9-AC52-4AC2-BEDB-A5D1257FD4A4}" type="datetimeFigureOut">
               <a:rPr lang="en-US" smtClean="0"/>
-              <a:t>2/6/2026</a:t>
+              <a:t>2/20/2026</a:t>
             </a:fld>
             <a:endParaRPr lang="en-US"/>
           </a:p>
@@ -1680,7 +1684,7 @@
           <a:p>
             <a:fld id="{8B8BF7D9-AC52-4AC2-BEDB-A5D1257FD4A4}" type="datetimeFigureOut">
               <a:rPr lang="en-US" smtClean="0"/>
-              <a:t>2/6/2026</a:t>
+              <a:t>2/20/2026</a:t>
             </a:fld>
             <a:endParaRPr lang="en-US"/>
           </a:p>
@@ -1945,7 +1949,7 @@
           <a:p>
             <a:fld id="{8B8BF7D9-AC52-4AC2-BEDB-A5D1257FD4A4}" type="datetimeFigureOut">
               <a:rPr lang="en-US" smtClean="0"/>
-              <a:t>2/6/2026</a:t>
+              <a:t>2/20/2026</a:t>
             </a:fld>
             <a:endParaRPr lang="en-US"/>
           </a:p>
@@ -2357,7 +2361,7 @@
           <a:p>
             <a:fld id="{8B8BF7D9-AC52-4AC2-BEDB-A5D1257FD4A4}" type="datetimeFigureOut">
               <a:rPr lang="en-US" smtClean="0"/>
-              <a:t>2/6/2026</a:t>
+              <a:t>2/20/2026</a:t>
             </a:fld>
             <a:endParaRPr lang="en-US"/>
           </a:p>
@@ -2498,7 +2502,7 @@
           <a:p>
             <a:fld id="{8B8BF7D9-AC52-4AC2-BEDB-A5D1257FD4A4}" type="datetimeFigureOut">
               <a:rPr lang="en-US" smtClean="0"/>
-              <a:t>2/6/2026</a:t>
+              <a:t>2/20/2026</a:t>
             </a:fld>
             <a:endParaRPr lang="en-US"/>
           </a:p>
@@ -2611,7 +2615,7 @@
           <a:p>
             <a:fld id="{8B8BF7D9-AC52-4AC2-BEDB-A5D1257FD4A4}" type="datetimeFigureOut">
               <a:rPr lang="en-US" smtClean="0"/>
-              <a:t>2/6/2026</a:t>
+              <a:t>2/20/2026</a:t>
             </a:fld>
             <a:endParaRPr lang="en-US"/>
           </a:p>
@@ -2922,7 +2926,7 @@
           <a:p>
             <a:fld id="{8B8BF7D9-AC52-4AC2-BEDB-A5D1257FD4A4}" type="datetimeFigureOut">
               <a:rPr lang="en-US" smtClean="0"/>
-              <a:t>2/6/2026</a:t>
+              <a:t>2/20/2026</a:t>
             </a:fld>
             <a:endParaRPr lang="en-US"/>
           </a:p>
@@ -3210,7 +3214,7 @@
           <a:p>
             <a:fld id="{8B8BF7D9-AC52-4AC2-BEDB-A5D1257FD4A4}" type="datetimeFigureOut">
               <a:rPr lang="en-US" smtClean="0"/>
-              <a:t>2/6/2026</a:t>
+              <a:t>2/20/2026</a:t>
             </a:fld>
             <a:endParaRPr lang="en-US"/>
           </a:p>
@@ -3451,7 +3455,7 @@
           <a:p>
             <a:fld id="{8B8BF7D9-AC52-4AC2-BEDB-A5D1257FD4A4}" type="datetimeFigureOut">
               <a:rPr lang="en-US" smtClean="0"/>
-              <a:t>2/6/2026</a:t>
+              <a:t>2/20/2026</a:t>
             </a:fld>
             <a:endParaRPr lang="en-US"/>
           </a:p>
@@ -7152,32 +7156,431 @@
           <a:bodyPr/>
           <a:lstStyle/>
           <a:p>
+            <a:r>
+              <a:rPr lang="en-US"/>
+              <a:t>4-260220 - Kaggle Intermediate ML Course</a:t>
+            </a:r>
+          </a:p>
+        </p:txBody>
+      </p:sp>
+      <p:sp>
+        <p:nvSpPr>
+          <p:cNvPr id="3" name="Content Placeholder 2">
+            <a:extLst>
+              <a:ext uri="{FF2B5EF4-FFF2-40B4-BE49-F238E27FC236}">
+                <a16:creationId xmlns:a16="http://schemas.microsoft.com/office/drawing/2014/main" id="{8EEC2F18-FEEF-BF25-FB42-4CC1D3028B46}"/>
+              </a:ext>
+            </a:extLst>
+          </p:cNvPr>
+          <p:cNvSpPr>
+            <a:spLocks noGrp="1"/>
+          </p:cNvSpPr>
+          <p:nvPr>
+            <p:ph idx="1"/>
+          </p:nvPr>
+        </p:nvSpPr>
+        <p:spPr/>
+        <p:txBody>
+          <a:bodyPr>
+            <a:normAutofit fontScale="55000" lnSpcReduction="20000"/>
+          </a:bodyPr>
+          <a:lstStyle/>
+          <a:p>
+            <a:r>
+              <a:rPr lang="en-US"/>
+              <a:t>Pandas</a:t>
+            </a:r>
+            <a:r>
+              <a:rPr lang="ko-KR" altLang="en-US"/>
+              <a:t> </a:t>
+            </a:r>
+            <a:r>
+              <a:rPr lang="en-US" altLang="ko-KR"/>
+              <a:t>6</a:t>
+            </a:r>
+            <a:r>
+              <a:rPr lang="ko-KR" altLang="en-US"/>
+              <a:t>째 </a:t>
+            </a:r>
+            <a:r>
+              <a:rPr lang="en-US" altLang="ko-KR"/>
+              <a:t>Exercise </a:t>
+            </a:r>
+            <a:r>
+              <a:rPr lang="ko-KR" altLang="en-US"/>
+              <a:t>마저 끝냄</a:t>
+            </a:r>
             <a:endParaRPr lang="en-US"/>
           </a:p>
-        </p:txBody>
-      </p:sp>
-      <p:sp>
-        <p:nvSpPr>
-          <p:cNvPr id="3" name="Content Placeholder 2">
-            <a:extLst>
-              <a:ext uri="{FF2B5EF4-FFF2-40B4-BE49-F238E27FC236}">
-                <a16:creationId xmlns:a16="http://schemas.microsoft.com/office/drawing/2014/main" id="{8EEC2F18-FEEF-BF25-FB42-4CC1D3028B46}"/>
-              </a:ext>
-            </a:extLst>
-          </p:cNvPr>
-          <p:cNvSpPr>
-            <a:spLocks noGrp="1"/>
-          </p:cNvSpPr>
-          <p:nvPr>
-            <p:ph idx="1"/>
-          </p:nvPr>
-        </p:nvSpPr>
-        <p:spPr/>
-        <p:txBody>
-          <a:bodyPr/>
-          <a:lstStyle/>
-          <a:p>
+          <a:p>
+            <a:r>
+              <a:rPr lang="en-US"/>
+              <a:t>Intermediate ML</a:t>
+            </a:r>
+            <a:r>
+              <a:rPr lang="ko-KR" altLang="en-US"/>
+              <a:t>의 첫 두 강 수강 완료</a:t>
+            </a:r>
+            <a:r>
+              <a:rPr lang="en-US" altLang="ko-KR"/>
+              <a:t>, </a:t>
+            </a:r>
+            <a:r>
+              <a:rPr lang="ko-KR" altLang="en-US"/>
+              <a:t>셋째 강의 </a:t>
+            </a:r>
+            <a:r>
+              <a:rPr lang="en-US" altLang="ko-KR"/>
+              <a:t>exercise </a:t>
+            </a:r>
+            <a:r>
+              <a:rPr lang="ko-KR" altLang="en-US"/>
+              <a:t>중간까지 함</a:t>
+            </a:r>
+            <a:r>
+              <a:rPr lang="en-US" altLang="ko-KR"/>
+              <a:t>.</a:t>
+            </a:r>
+          </a:p>
+          <a:p>
+            <a:pPr lvl="1"/>
+            <a:r>
+              <a:rPr lang="ko-KR" altLang="en-US"/>
+              <a:t>복습</a:t>
+            </a:r>
+            <a:r>
+              <a:rPr lang="en-US" altLang="ko-KR"/>
+              <a:t>: </a:t>
+            </a:r>
+            <a:r>
+              <a:rPr lang="ko-KR" altLang="en-US"/>
+              <a:t>모델 만들어서 제출하기</a:t>
+            </a:r>
+            <a:endParaRPr lang="en-US" altLang="ko-KR"/>
+          </a:p>
+          <a:p>
+            <a:pPr lvl="1"/>
+            <a:r>
+              <a:rPr lang="en-US" altLang="ko-KR"/>
+              <a:t>Missing</a:t>
+            </a:r>
+            <a:r>
+              <a:rPr lang="ko-KR" altLang="en-US"/>
+              <a:t> </a:t>
+            </a:r>
+            <a:r>
+              <a:rPr lang="en-US" altLang="ko-KR"/>
+              <a:t>Value</a:t>
+            </a:r>
+            <a:r>
+              <a:rPr lang="ko-KR" altLang="en-US"/>
+              <a:t> </a:t>
+            </a:r>
+            <a:r>
+              <a:rPr lang="en-US" altLang="ko-KR"/>
+              <a:t>Handling</a:t>
+            </a:r>
+          </a:p>
+          <a:p>
+            <a:pPr lvl="1"/>
+            <a:r>
+              <a:rPr lang="en-US"/>
+              <a:t>Categorical</a:t>
+            </a:r>
+            <a:r>
+              <a:rPr lang="ko-KR" altLang="en-US"/>
+              <a:t> </a:t>
+            </a:r>
+            <a:r>
+              <a:rPr lang="en-US" altLang="ko-KR"/>
+              <a:t>Value</a:t>
+            </a:r>
+            <a:r>
+              <a:rPr lang="ko-KR" altLang="en-US"/>
+              <a:t> </a:t>
+            </a:r>
+            <a:r>
+              <a:rPr lang="en-US" altLang="ko-KR"/>
+              <a:t>Handling</a:t>
+            </a:r>
+            <a:r>
+              <a:rPr lang="ko-KR" altLang="en-US"/>
+              <a:t> </a:t>
+            </a:r>
+            <a:r>
+              <a:rPr lang="en-US" altLang="ko-KR"/>
+              <a:t>(ordinal - ordinal encoding, nomial values - one-hot-encoding)</a:t>
+            </a:r>
             <a:endParaRPr lang="en-US"/>
+          </a:p>
+          <a:p>
+            <a:r>
+              <a:rPr lang="en-US"/>
+              <a:t>+ </a:t>
+            </a:r>
+            <a:r>
+              <a:rPr lang="ko-KR" altLang="en-US"/>
+              <a:t>이후에 </a:t>
+            </a:r>
+            <a:r>
+              <a:rPr lang="en-US" altLang="ko-KR"/>
+              <a:t>“feature engineering” </a:t>
+            </a:r>
+            <a:r>
+              <a:rPr lang="ko-KR" altLang="en-US"/>
+              <a:t>을 다룰 수 있다고 한다</a:t>
+            </a:r>
+            <a:r>
+              <a:rPr lang="en-US" altLang="ko-KR"/>
+              <a:t>.</a:t>
+            </a:r>
+          </a:p>
+          <a:p>
+            <a:pPr lvl="1"/>
+            <a:r>
+              <a:rPr lang="en-US">
+                <a:sym typeface="Wingdings" panose="05000000000000000000" pitchFamily="2" charset="2"/>
+              </a:rPr>
+              <a:t> </a:t>
+            </a:r>
+            <a:r>
+              <a:rPr lang="ko-KR" altLang="en-US">
+                <a:sym typeface="Wingdings" panose="05000000000000000000" pitchFamily="2" charset="2"/>
+              </a:rPr>
+              <a:t>그거까지 끝내면 좋을듯</a:t>
+            </a:r>
+            <a:r>
+              <a:rPr lang="en-US" altLang="ko-KR">
+                <a:sym typeface="Wingdings" panose="05000000000000000000" pitchFamily="2" charset="2"/>
+              </a:rPr>
+              <a:t>!</a:t>
+            </a:r>
+          </a:p>
+          <a:p>
+            <a:r>
+              <a:rPr lang="en-US"/>
+              <a:t>+ exercise</a:t>
+            </a:r>
+            <a:r>
+              <a:rPr lang="ko-KR" altLang="en-US"/>
+              <a:t> 를 통해 실제 제출을 여러 번 해보다보니</a:t>
+            </a:r>
+            <a:r>
+              <a:rPr lang="en-US" altLang="ko-KR"/>
+              <a:t>..</a:t>
+            </a:r>
+          </a:p>
+          <a:p>
+            <a:pPr lvl="1"/>
+            <a:r>
+              <a:rPr lang="en-US" altLang="ko-KR"/>
+              <a:t>MAE(Mean Absolute Error)</a:t>
+            </a:r>
+            <a:r>
+              <a:rPr lang="ko-KR" altLang="en-US"/>
+              <a:t>를 기존 </a:t>
+            </a:r>
+            <a:r>
+              <a:rPr lang="en-US" altLang="ko-KR"/>
+              <a:t>21000 </a:t>
+            </a:r>
+            <a:r>
+              <a:rPr lang="en-US" altLang="ko-KR">
+                <a:sym typeface="Wingdings" panose="05000000000000000000" pitchFamily="2" charset="2"/>
+              </a:rPr>
+              <a:t> 20000  16000 (Intermediate 2/7</a:t>
+            </a:r>
+            <a:r>
+              <a:rPr lang="ko-KR" altLang="en-US">
+                <a:sym typeface="Wingdings" panose="05000000000000000000" pitchFamily="2" charset="2"/>
+              </a:rPr>
+              <a:t>째강의</a:t>
+            </a:r>
+            <a:r>
+              <a:rPr lang="en-US" altLang="ko-KR">
+                <a:sym typeface="Wingdings" panose="05000000000000000000" pitchFamily="2" charset="2"/>
+              </a:rPr>
+              <a:t>) </a:t>
+            </a:r>
+            <a:r>
+              <a:rPr lang="ko-KR" altLang="en-US">
+                <a:sym typeface="Wingdings" panose="05000000000000000000" pitchFamily="2" charset="2"/>
+              </a:rPr>
+              <a:t>으로 개선</a:t>
+            </a:r>
+            <a:r>
+              <a:rPr lang="en-US" altLang="ko-KR">
+                <a:sym typeface="Wingdings" panose="05000000000000000000" pitchFamily="2" charset="2"/>
+              </a:rPr>
+              <a:t>!</a:t>
+            </a:r>
+          </a:p>
+          <a:p>
+            <a:pPr lvl="1"/>
+            <a:r>
+              <a:rPr lang="en-US">
+                <a:sym typeface="Wingdings" panose="05000000000000000000" pitchFamily="2" charset="2"/>
+              </a:rPr>
+              <a:t> </a:t>
+            </a:r>
+            <a:r>
+              <a:rPr lang="ko-KR" altLang="en-US">
+                <a:sym typeface="Wingdings" panose="05000000000000000000" pitchFamily="2" charset="2"/>
+              </a:rPr>
+              <a:t>배운 것을 토대로 실제로 집값 예측을 더 잘 할 수 있게 되었다</a:t>
+            </a:r>
+            <a:r>
+              <a:rPr lang="en-US" altLang="ko-KR">
+                <a:sym typeface="Wingdings" panose="05000000000000000000" pitchFamily="2" charset="2"/>
+              </a:rPr>
+              <a:t>.</a:t>
+            </a:r>
+          </a:p>
+          <a:p>
+            <a:pPr lvl="1"/>
+            <a:r>
+              <a:rPr lang="ko-KR" altLang="en-US">
+                <a:sym typeface="Wingdings" panose="05000000000000000000" pitchFamily="2" charset="2"/>
+              </a:rPr>
+              <a:t>나중에 </a:t>
+            </a:r>
+            <a:r>
+              <a:rPr lang="en-US" altLang="ko-KR">
+                <a:sym typeface="Wingdings" panose="05000000000000000000" pitchFamily="2" charset="2"/>
+              </a:rPr>
+              <a:t>Pipelines, Cross-Validation, XGBoost </a:t>
+            </a:r>
+            <a:r>
+              <a:rPr lang="ko-KR" altLang="en-US">
+                <a:sym typeface="Wingdings" panose="05000000000000000000" pitchFamily="2" charset="2"/>
+              </a:rPr>
+              <a:t>를 배우고</a:t>
+            </a:r>
+            <a:endParaRPr lang="en-US" altLang="ko-KR">
+              <a:sym typeface="Wingdings" panose="05000000000000000000" pitchFamily="2" charset="2"/>
+            </a:endParaRPr>
+          </a:p>
+          <a:p>
+            <a:pPr lvl="1"/>
+            <a:r>
+              <a:rPr lang="en-US">
+                <a:sym typeface="Wingdings" panose="05000000000000000000" pitchFamily="2" charset="2"/>
+              </a:rPr>
+              <a:t>Feature Engineering</a:t>
+            </a:r>
+            <a:r>
+              <a:rPr lang="ko-KR" altLang="en-US">
+                <a:sym typeface="Wingdings" panose="05000000000000000000" pitchFamily="2" charset="2"/>
+              </a:rPr>
+              <a:t>에서 </a:t>
+            </a:r>
+            <a:r>
+              <a:rPr lang="en-US" altLang="ko-KR">
+                <a:sym typeface="Wingdings" panose="05000000000000000000" pitchFamily="2" charset="2"/>
+              </a:rPr>
+              <a:t>Mutual Information, K-Means clustering, PCA, Target Encoding </a:t>
+            </a:r>
+            <a:r>
+              <a:rPr lang="ko-KR" altLang="en-US">
+                <a:sym typeface="Wingdings" panose="05000000000000000000" pitchFamily="2" charset="2"/>
+              </a:rPr>
+              <a:t>등 이론적으로만 배웠던 것을 실전으로 적용 </a:t>
+            </a:r>
+            <a:r>
+              <a:rPr lang="en-US" altLang="ko-KR">
+                <a:sym typeface="Wingdings" panose="05000000000000000000" pitchFamily="2" charset="2"/>
+              </a:rPr>
+              <a:t>+ </a:t>
+            </a:r>
+            <a:r>
+              <a:rPr lang="ko-KR" altLang="en-US">
+                <a:sym typeface="Wingdings" panose="05000000000000000000" pitchFamily="2" charset="2"/>
+              </a:rPr>
+              <a:t>내 스킬로 만들고</a:t>
+            </a:r>
+            <a:endParaRPr lang="en-US" altLang="ko-KR">
+              <a:sym typeface="Wingdings" panose="05000000000000000000" pitchFamily="2" charset="2"/>
+            </a:endParaRPr>
+          </a:p>
+          <a:p>
+            <a:pPr lvl="1"/>
+            <a:r>
+              <a:rPr lang="en-US"/>
+              <a:t>Machine Learning Explainability </a:t>
+            </a:r>
+            <a:r>
+              <a:rPr lang="ko-KR" altLang="en-US"/>
+              <a:t>에서 </a:t>
+            </a:r>
+            <a:r>
+              <a:rPr lang="en-US" altLang="ko-KR"/>
+              <a:t>model insights </a:t>
+            </a:r>
+            <a:r>
+              <a:rPr lang="ko-KR" altLang="en-US"/>
+              <a:t>를 알아내는 방법을 배우고 배운 </a:t>
+            </a:r>
+            <a:r>
+              <a:rPr lang="en-US" altLang="ko-KR"/>
+              <a:t>ML </a:t>
+            </a:r>
+            <a:r>
+              <a:rPr lang="ko-KR" altLang="en-US"/>
+              <a:t>만드는 방법에 대한 </a:t>
+            </a:r>
+            <a:r>
+              <a:rPr lang="en-US" altLang="ko-KR"/>
+              <a:t>insights</a:t>
+            </a:r>
+            <a:r>
+              <a:rPr lang="ko-KR" altLang="en-US"/>
+              <a:t>를 정리하는 방법을 배우면</a:t>
+            </a:r>
+            <a:endParaRPr lang="en-US" altLang="ko-KR"/>
+          </a:p>
+          <a:p>
+            <a:r>
+              <a:rPr lang="ko-KR" altLang="en-US"/>
+              <a:t>모두의 데이터 분석 능력 </a:t>
+            </a:r>
+            <a:r>
+              <a:rPr lang="en-US" altLang="ko-KR"/>
+              <a:t>/ insight</a:t>
+            </a:r>
+            <a:r>
+              <a:rPr lang="ko-KR" altLang="en-US"/>
+              <a:t>를 증진시킬 수 있을 것으로 보인다</a:t>
+            </a:r>
+            <a:r>
+              <a:rPr lang="en-US" altLang="ko-KR"/>
+              <a:t>.</a:t>
+            </a:r>
+          </a:p>
+          <a:p>
+            <a:r>
+              <a:rPr lang="ko-KR" altLang="en-US"/>
+              <a:t>이것이 너무 공유되는 이득이 작다고 한다면</a:t>
+            </a:r>
+            <a:r>
+              <a:rPr lang="en-US" altLang="ko-KR"/>
+              <a:t>… XGBoost</a:t>
+            </a:r>
+            <a:r>
+              <a:rPr lang="ko-KR" altLang="en-US"/>
+              <a:t>정도까지 하고 배운 것을 어느 정도 정리 </a:t>
+            </a:r>
+            <a:r>
+              <a:rPr lang="en-US" altLang="ko-KR"/>
+              <a:t>&amp; </a:t>
+            </a:r>
+            <a:r>
+              <a:rPr lang="ko-KR" altLang="en-US"/>
+              <a:t>전달할 수 있도록 다듬는 시간을 먼저 가진 뒤에 저걸 마저 해보도록 하자</a:t>
+            </a:r>
+            <a:r>
+              <a:rPr lang="en-US" altLang="ko-KR"/>
+              <a:t>.</a:t>
+            </a:r>
           </a:p>
         </p:txBody>
       </p:sp>
@@ -7185,6 +7588,326 @@
     <p:extLst>
       <p:ext uri="{BB962C8B-B14F-4D97-AF65-F5344CB8AC3E}">
         <p14:creationId xmlns:p14="http://schemas.microsoft.com/office/powerpoint/2010/main" val="2791698948"/>
+      </p:ext>
+    </p:extLst>
+  </p:cSld>
+  <p:clrMapOvr>
+    <a:masterClrMapping/>
+  </p:clrMapOvr>
+</p:sld>
+</file>
+
+<file path=ppt/slides/slide24.xml><?xml version="1.0" encoding="utf-8"?>
+<p:sld xmlns:a="http://schemas.openxmlformats.org/drawingml/2006/main" xmlns:r="http://schemas.openxmlformats.org/officeDocument/2006/relationships" xmlns:p="http://schemas.openxmlformats.org/presentationml/2006/main">
+  <p:cSld>
+    <p:spTree>
+      <p:nvGrpSpPr>
+        <p:cNvPr id="1" name=""/>
+        <p:cNvGrpSpPr/>
+        <p:nvPr/>
+      </p:nvGrpSpPr>
+      <p:grpSpPr>
+        <a:xfrm>
+          <a:off x="0" y="0"/>
+          <a:ext cx="0" cy="0"/>
+          <a:chOff x="0" y="0"/>
+          <a:chExt cx="0" cy="0"/>
+        </a:xfrm>
+      </p:grpSpPr>
+      <p:sp>
+        <p:nvSpPr>
+          <p:cNvPr id="2" name="Title 1">
+            <a:extLst>
+              <a:ext uri="{FF2B5EF4-FFF2-40B4-BE49-F238E27FC236}">
+                <a16:creationId xmlns:a16="http://schemas.microsoft.com/office/drawing/2014/main" id="{20B90F21-4971-A4DF-4133-6201ABBE6274}"/>
+              </a:ext>
+            </a:extLst>
+          </p:cNvPr>
+          <p:cNvSpPr>
+            <a:spLocks noGrp="1"/>
+          </p:cNvSpPr>
+          <p:nvPr>
+            <p:ph type="title"/>
+          </p:nvPr>
+        </p:nvSpPr>
+        <p:spPr/>
+        <p:txBody>
+          <a:bodyPr/>
+          <a:lstStyle/>
+          <a:p>
+            <a:endParaRPr lang="en-US"/>
+          </a:p>
+        </p:txBody>
+      </p:sp>
+      <p:sp>
+        <p:nvSpPr>
+          <p:cNvPr id="3" name="Content Placeholder 2">
+            <a:extLst>
+              <a:ext uri="{FF2B5EF4-FFF2-40B4-BE49-F238E27FC236}">
+                <a16:creationId xmlns:a16="http://schemas.microsoft.com/office/drawing/2014/main" id="{E31AE387-B473-B95A-3B24-BDD25049364D}"/>
+              </a:ext>
+            </a:extLst>
+          </p:cNvPr>
+          <p:cNvSpPr>
+            <a:spLocks noGrp="1"/>
+          </p:cNvSpPr>
+          <p:nvPr>
+            <p:ph idx="1"/>
+          </p:nvPr>
+        </p:nvSpPr>
+        <p:spPr/>
+        <p:txBody>
+          <a:bodyPr/>
+          <a:lstStyle/>
+          <a:p>
+            <a:endParaRPr lang="en-US"/>
+          </a:p>
+        </p:txBody>
+      </p:sp>
+    </p:spTree>
+    <p:extLst>
+      <p:ext uri="{BB962C8B-B14F-4D97-AF65-F5344CB8AC3E}">
+        <p14:creationId xmlns:p14="http://schemas.microsoft.com/office/powerpoint/2010/main" val="4274900055"/>
+      </p:ext>
+    </p:extLst>
+  </p:cSld>
+  <p:clrMapOvr>
+    <a:masterClrMapping/>
+  </p:clrMapOvr>
+</p:sld>
+</file>
+
+<file path=ppt/slides/slide25.xml><?xml version="1.0" encoding="utf-8"?>
+<p:sld xmlns:a="http://schemas.openxmlformats.org/drawingml/2006/main" xmlns:r="http://schemas.openxmlformats.org/officeDocument/2006/relationships" xmlns:p="http://schemas.openxmlformats.org/presentationml/2006/main">
+  <p:cSld>
+    <p:spTree>
+      <p:nvGrpSpPr>
+        <p:cNvPr id="1" name=""/>
+        <p:cNvGrpSpPr/>
+        <p:nvPr/>
+      </p:nvGrpSpPr>
+      <p:grpSpPr>
+        <a:xfrm>
+          <a:off x="0" y="0"/>
+          <a:ext cx="0" cy="0"/>
+          <a:chOff x="0" y="0"/>
+          <a:chExt cx="0" cy="0"/>
+        </a:xfrm>
+      </p:grpSpPr>
+      <p:sp>
+        <p:nvSpPr>
+          <p:cNvPr id="2" name="Title 1">
+            <a:extLst>
+              <a:ext uri="{FF2B5EF4-FFF2-40B4-BE49-F238E27FC236}">
+                <a16:creationId xmlns:a16="http://schemas.microsoft.com/office/drawing/2014/main" id="{745DC343-6E20-8B48-FF4A-F3A740588CB8}"/>
+              </a:ext>
+            </a:extLst>
+          </p:cNvPr>
+          <p:cNvSpPr>
+            <a:spLocks noGrp="1"/>
+          </p:cNvSpPr>
+          <p:nvPr>
+            <p:ph type="title"/>
+          </p:nvPr>
+        </p:nvSpPr>
+        <p:spPr/>
+        <p:txBody>
+          <a:bodyPr/>
+          <a:lstStyle/>
+          <a:p>
+            <a:endParaRPr lang="en-US"/>
+          </a:p>
+        </p:txBody>
+      </p:sp>
+      <p:sp>
+        <p:nvSpPr>
+          <p:cNvPr id="3" name="Content Placeholder 2">
+            <a:extLst>
+              <a:ext uri="{FF2B5EF4-FFF2-40B4-BE49-F238E27FC236}">
+                <a16:creationId xmlns:a16="http://schemas.microsoft.com/office/drawing/2014/main" id="{EB2B34D8-B209-17DC-3041-B83A6BE66876}"/>
+              </a:ext>
+            </a:extLst>
+          </p:cNvPr>
+          <p:cNvSpPr>
+            <a:spLocks noGrp="1"/>
+          </p:cNvSpPr>
+          <p:nvPr>
+            <p:ph idx="1"/>
+          </p:nvPr>
+        </p:nvSpPr>
+        <p:spPr/>
+        <p:txBody>
+          <a:bodyPr/>
+          <a:lstStyle/>
+          <a:p>
+            <a:endParaRPr lang="en-US"/>
+          </a:p>
+        </p:txBody>
+      </p:sp>
+    </p:spTree>
+    <p:extLst>
+      <p:ext uri="{BB962C8B-B14F-4D97-AF65-F5344CB8AC3E}">
+        <p14:creationId xmlns:p14="http://schemas.microsoft.com/office/powerpoint/2010/main" val="2891634649"/>
+      </p:ext>
+    </p:extLst>
+  </p:cSld>
+  <p:clrMapOvr>
+    <a:masterClrMapping/>
+  </p:clrMapOvr>
+</p:sld>
+</file>
+
+<file path=ppt/slides/slide26.xml><?xml version="1.0" encoding="utf-8"?>
+<p:sld xmlns:a="http://schemas.openxmlformats.org/drawingml/2006/main" xmlns:r="http://schemas.openxmlformats.org/officeDocument/2006/relationships" xmlns:p="http://schemas.openxmlformats.org/presentationml/2006/main">
+  <p:cSld>
+    <p:spTree>
+      <p:nvGrpSpPr>
+        <p:cNvPr id="1" name=""/>
+        <p:cNvGrpSpPr/>
+        <p:nvPr/>
+      </p:nvGrpSpPr>
+      <p:grpSpPr>
+        <a:xfrm>
+          <a:off x="0" y="0"/>
+          <a:ext cx="0" cy="0"/>
+          <a:chOff x="0" y="0"/>
+          <a:chExt cx="0" cy="0"/>
+        </a:xfrm>
+      </p:grpSpPr>
+      <p:sp>
+        <p:nvSpPr>
+          <p:cNvPr id="2" name="Title 1">
+            <a:extLst>
+              <a:ext uri="{FF2B5EF4-FFF2-40B4-BE49-F238E27FC236}">
+                <a16:creationId xmlns:a16="http://schemas.microsoft.com/office/drawing/2014/main" id="{97AB947F-5543-C04A-7C00-FC25D49E9DE0}"/>
+              </a:ext>
+            </a:extLst>
+          </p:cNvPr>
+          <p:cNvSpPr>
+            <a:spLocks noGrp="1"/>
+          </p:cNvSpPr>
+          <p:nvPr>
+            <p:ph type="title"/>
+          </p:nvPr>
+        </p:nvSpPr>
+        <p:spPr/>
+        <p:txBody>
+          <a:bodyPr/>
+          <a:lstStyle/>
+          <a:p>
+            <a:endParaRPr lang="en-US"/>
+          </a:p>
+        </p:txBody>
+      </p:sp>
+      <p:sp>
+        <p:nvSpPr>
+          <p:cNvPr id="3" name="Content Placeholder 2">
+            <a:extLst>
+              <a:ext uri="{FF2B5EF4-FFF2-40B4-BE49-F238E27FC236}">
+                <a16:creationId xmlns:a16="http://schemas.microsoft.com/office/drawing/2014/main" id="{73573243-78C8-2FC1-8F83-6B1F9C67007F}"/>
+              </a:ext>
+            </a:extLst>
+          </p:cNvPr>
+          <p:cNvSpPr>
+            <a:spLocks noGrp="1"/>
+          </p:cNvSpPr>
+          <p:nvPr>
+            <p:ph idx="1"/>
+          </p:nvPr>
+        </p:nvSpPr>
+        <p:spPr/>
+        <p:txBody>
+          <a:bodyPr/>
+          <a:lstStyle/>
+          <a:p>
+            <a:endParaRPr lang="en-US"/>
+          </a:p>
+        </p:txBody>
+      </p:sp>
+    </p:spTree>
+    <p:extLst>
+      <p:ext uri="{BB962C8B-B14F-4D97-AF65-F5344CB8AC3E}">
+        <p14:creationId xmlns:p14="http://schemas.microsoft.com/office/powerpoint/2010/main" val="690160612"/>
+      </p:ext>
+    </p:extLst>
+  </p:cSld>
+  <p:clrMapOvr>
+    <a:masterClrMapping/>
+  </p:clrMapOvr>
+</p:sld>
+</file>
+
+<file path=ppt/slides/slide27.xml><?xml version="1.0" encoding="utf-8"?>
+<p:sld xmlns:a="http://schemas.openxmlformats.org/drawingml/2006/main" xmlns:r="http://schemas.openxmlformats.org/officeDocument/2006/relationships" xmlns:p="http://schemas.openxmlformats.org/presentationml/2006/main">
+  <p:cSld>
+    <p:spTree>
+      <p:nvGrpSpPr>
+        <p:cNvPr id="1" name=""/>
+        <p:cNvGrpSpPr/>
+        <p:nvPr/>
+      </p:nvGrpSpPr>
+      <p:grpSpPr>
+        <a:xfrm>
+          <a:off x="0" y="0"/>
+          <a:ext cx="0" cy="0"/>
+          <a:chOff x="0" y="0"/>
+          <a:chExt cx="0" cy="0"/>
+        </a:xfrm>
+      </p:grpSpPr>
+      <p:sp>
+        <p:nvSpPr>
+          <p:cNvPr id="2" name="Title 1">
+            <a:extLst>
+              <a:ext uri="{FF2B5EF4-FFF2-40B4-BE49-F238E27FC236}">
+                <a16:creationId xmlns:a16="http://schemas.microsoft.com/office/drawing/2014/main" id="{93925CE7-F44D-5AAD-C878-271881C0E583}"/>
+              </a:ext>
+            </a:extLst>
+          </p:cNvPr>
+          <p:cNvSpPr>
+            <a:spLocks noGrp="1"/>
+          </p:cNvSpPr>
+          <p:nvPr>
+            <p:ph type="title"/>
+          </p:nvPr>
+        </p:nvSpPr>
+        <p:spPr/>
+        <p:txBody>
+          <a:bodyPr/>
+          <a:lstStyle/>
+          <a:p>
+            <a:endParaRPr lang="en-US"/>
+          </a:p>
+        </p:txBody>
+      </p:sp>
+      <p:sp>
+        <p:nvSpPr>
+          <p:cNvPr id="3" name="Content Placeholder 2">
+            <a:extLst>
+              <a:ext uri="{FF2B5EF4-FFF2-40B4-BE49-F238E27FC236}">
+                <a16:creationId xmlns:a16="http://schemas.microsoft.com/office/drawing/2014/main" id="{BA235F0B-1291-6C8D-11B8-AC4597E9E140}"/>
+              </a:ext>
+            </a:extLst>
+          </p:cNvPr>
+          <p:cNvSpPr>
+            <a:spLocks noGrp="1"/>
+          </p:cNvSpPr>
+          <p:nvPr>
+            <p:ph idx="1"/>
+          </p:nvPr>
+        </p:nvSpPr>
+        <p:spPr/>
+        <p:txBody>
+          <a:bodyPr/>
+          <a:lstStyle/>
+          <a:p>
+            <a:endParaRPr lang="en-US"/>
+          </a:p>
+        </p:txBody>
+      </p:sp>
+    </p:spTree>
+    <p:extLst>
+      <p:ext uri="{BB962C8B-B14F-4D97-AF65-F5344CB8AC3E}">
+        <p14:creationId xmlns:p14="http://schemas.microsoft.com/office/powerpoint/2010/main" val="3427583918"/>
       </p:ext>
     </p:extLst>
   </p:cSld>

</xml_diff>

<commit_message>
Day 5 complete - ponder future plan as a mid-check
learn by some insights I had from ML course working
ponder future plan (not yet complete. Willing to complete on the next
week)

note: the work #3571 (침해지표 개발) was too tight so that I could not
fully devote today to this project.
</commit_message>
<xml_diff>
--- a/Kaggle!.pptx
+++ b/Kaggle!.pptx
@@ -223,7 +223,7 @@
           <a:p>
             <a:fld id="{696CDF9F-ADA0-4C49-A263-B2AE48107B92}" type="datetimeFigureOut">
               <a:rPr lang="en-US" smtClean="0"/>
-              <a:t>2/20/2026</a:t>
+              <a:t>2/27/2026</a:t>
             </a:fld>
             <a:endParaRPr lang="en-US"/>
           </a:p>
@@ -805,7 +805,7 @@
           <a:p>
             <a:fld id="{8B8BF7D9-AC52-4AC2-BEDB-A5D1257FD4A4}" type="datetimeFigureOut">
               <a:rPr lang="en-US" smtClean="0"/>
-              <a:t>2/20/2026</a:t>
+              <a:t>2/27/2026</a:t>
             </a:fld>
             <a:endParaRPr lang="en-US"/>
           </a:p>
@@ -1003,7 +1003,7 @@
           <a:p>
             <a:fld id="{8B8BF7D9-AC52-4AC2-BEDB-A5D1257FD4A4}" type="datetimeFigureOut">
               <a:rPr lang="en-US" smtClean="0"/>
-              <a:t>2/20/2026</a:t>
+              <a:t>2/27/2026</a:t>
             </a:fld>
             <a:endParaRPr lang="en-US"/>
           </a:p>
@@ -1211,7 +1211,7 @@
           <a:p>
             <a:fld id="{8B8BF7D9-AC52-4AC2-BEDB-A5D1257FD4A4}" type="datetimeFigureOut">
               <a:rPr lang="en-US" smtClean="0"/>
-              <a:t>2/20/2026</a:t>
+              <a:t>2/27/2026</a:t>
             </a:fld>
             <a:endParaRPr lang="en-US"/>
           </a:p>
@@ -1409,7 +1409,7 @@
           <a:p>
             <a:fld id="{8B8BF7D9-AC52-4AC2-BEDB-A5D1257FD4A4}" type="datetimeFigureOut">
               <a:rPr lang="en-US" smtClean="0"/>
-              <a:t>2/20/2026</a:t>
+              <a:t>2/27/2026</a:t>
             </a:fld>
             <a:endParaRPr lang="en-US"/>
           </a:p>
@@ -1684,7 +1684,7 @@
           <a:p>
             <a:fld id="{8B8BF7D9-AC52-4AC2-BEDB-A5D1257FD4A4}" type="datetimeFigureOut">
               <a:rPr lang="en-US" smtClean="0"/>
-              <a:t>2/20/2026</a:t>
+              <a:t>2/27/2026</a:t>
             </a:fld>
             <a:endParaRPr lang="en-US"/>
           </a:p>
@@ -1949,7 +1949,7 @@
           <a:p>
             <a:fld id="{8B8BF7D9-AC52-4AC2-BEDB-A5D1257FD4A4}" type="datetimeFigureOut">
               <a:rPr lang="en-US" smtClean="0"/>
-              <a:t>2/20/2026</a:t>
+              <a:t>2/27/2026</a:t>
             </a:fld>
             <a:endParaRPr lang="en-US"/>
           </a:p>
@@ -2361,7 +2361,7 @@
           <a:p>
             <a:fld id="{8B8BF7D9-AC52-4AC2-BEDB-A5D1257FD4A4}" type="datetimeFigureOut">
               <a:rPr lang="en-US" smtClean="0"/>
-              <a:t>2/20/2026</a:t>
+              <a:t>2/27/2026</a:t>
             </a:fld>
             <a:endParaRPr lang="en-US"/>
           </a:p>
@@ -2502,7 +2502,7 @@
           <a:p>
             <a:fld id="{8B8BF7D9-AC52-4AC2-BEDB-A5D1257FD4A4}" type="datetimeFigureOut">
               <a:rPr lang="en-US" smtClean="0"/>
-              <a:t>2/20/2026</a:t>
+              <a:t>2/27/2026</a:t>
             </a:fld>
             <a:endParaRPr lang="en-US"/>
           </a:p>
@@ -2615,7 +2615,7 @@
           <a:p>
             <a:fld id="{8B8BF7D9-AC52-4AC2-BEDB-A5D1257FD4A4}" type="datetimeFigureOut">
               <a:rPr lang="en-US" smtClean="0"/>
-              <a:t>2/20/2026</a:t>
+              <a:t>2/27/2026</a:t>
             </a:fld>
             <a:endParaRPr lang="en-US"/>
           </a:p>
@@ -2926,7 +2926,7 @@
           <a:p>
             <a:fld id="{8B8BF7D9-AC52-4AC2-BEDB-A5D1257FD4A4}" type="datetimeFigureOut">
               <a:rPr lang="en-US" smtClean="0"/>
-              <a:t>2/20/2026</a:t>
+              <a:t>2/27/2026</a:t>
             </a:fld>
             <a:endParaRPr lang="en-US"/>
           </a:p>
@@ -3214,7 +3214,7 @@
           <a:p>
             <a:fld id="{8B8BF7D9-AC52-4AC2-BEDB-A5D1257FD4A4}" type="datetimeFigureOut">
               <a:rPr lang="en-US" smtClean="0"/>
-              <a:t>2/20/2026</a:t>
+              <a:t>2/27/2026</a:t>
             </a:fld>
             <a:endParaRPr lang="en-US"/>
           </a:p>
@@ -3455,7 +3455,7 @@
           <a:p>
             <a:fld id="{8B8BF7D9-AC52-4AC2-BEDB-A5D1257FD4A4}" type="datetimeFigureOut">
               <a:rPr lang="en-US" smtClean="0"/>
-              <a:t>2/20/2026</a:t>
+              <a:t>2/27/2026</a:t>
             </a:fld>
             <a:endParaRPr lang="en-US"/>
           </a:p>
@@ -7616,10 +7616,575 @@
       </p:grpSpPr>
       <p:sp>
         <p:nvSpPr>
-          <p:cNvPr id="2" name="Title 1">
-            <a:extLst>
-              <a:ext uri="{FF2B5EF4-FFF2-40B4-BE49-F238E27FC236}">
-                <a16:creationId xmlns:a16="http://schemas.microsoft.com/office/drawing/2014/main" id="{20B90F21-4971-A4DF-4133-6201ABBE6274}"/>
+          <p:cNvPr id="5" name="TextBox 4">
+            <a:extLst>
+              <a:ext uri="{FF2B5EF4-FFF2-40B4-BE49-F238E27FC236}">
+                <a16:creationId xmlns:a16="http://schemas.microsoft.com/office/drawing/2014/main" id="{DE3A1A59-51EC-54ED-572D-1BA0F653F277}"/>
+              </a:ext>
+            </a:extLst>
+          </p:cNvPr>
+          <p:cNvSpPr txBox="1"/>
+          <p:nvPr/>
+        </p:nvSpPr>
+        <p:spPr>
+          <a:xfrm>
+            <a:off x="2103120" y="2154064"/>
+            <a:ext cx="6096000" cy="3647152"/>
+          </a:xfrm>
+          <a:prstGeom prst="rect">
+            <a:avLst/>
+          </a:prstGeom>
+          <a:noFill/>
+        </p:spPr>
+        <p:txBody>
+          <a:bodyPr wrap="square">
+            <a:spAutoFit/>
+          </a:bodyPr>
+          <a:lstStyle/>
+          <a:p>
+            <a:pPr>
+              <a:buNone/>
+            </a:pPr>
+            <a:r>
+              <a:rPr lang="ko-KR" altLang="en-US" sz="1100"/>
+              <a:t>단 한두번 </a:t>
+            </a:r>
+            <a:r>
+              <a:rPr lang="en-US" altLang="ko-KR" sz="1100"/>
+              <a:t>kaggle competition</a:t>
+            </a:r>
+            <a:r>
+              <a:rPr lang="ko-KR" altLang="en-US" sz="1100"/>
+              <a:t>에 낼 노트북을 만들어보면서는 일단 이런걸 알게 되었어</a:t>
+            </a:r>
+            <a:r>
+              <a:rPr lang="en-US" altLang="ko-KR" sz="1100"/>
+              <a:t>.</a:t>
+            </a:r>
+          </a:p>
+          <a:p>
+            <a:pPr>
+              <a:buNone/>
+            </a:pPr>
+            <a:r>
+              <a:rPr lang="en-US" altLang="ko-KR" sz="1100"/>
+              <a:t>1. </a:t>
+            </a:r>
+            <a:r>
+              <a:rPr lang="ko-KR" altLang="en-US" sz="1100"/>
+              <a:t>데이터가 </a:t>
+            </a:r>
+            <a:r>
+              <a:rPr lang="en-US" altLang="ko-KR" sz="1100"/>
+              <a:t>20% </a:t>
+            </a:r>
+            <a:r>
+              <a:rPr lang="ko-KR" altLang="en-US" sz="1100"/>
+              <a:t>이하로 </a:t>
+            </a:r>
+            <a:r>
+              <a:rPr lang="en-US" altLang="ko-KR" sz="1100"/>
+              <a:t>null</a:t>
+            </a:r>
+            <a:r>
+              <a:rPr lang="ko-KR" altLang="en-US" sz="1100"/>
+              <a:t>이면 </a:t>
+            </a:r>
+            <a:r>
+              <a:rPr lang="en-US" altLang="ko-KR" sz="1100"/>
+              <a:t>feature </a:t>
+            </a:r>
+            <a:r>
+              <a:rPr lang="ko-KR" altLang="en-US" sz="1100"/>
+              <a:t>선별 시 </a:t>
+            </a:r>
+            <a:r>
+              <a:rPr lang="en-US" altLang="ko-KR" sz="1100"/>
+              <a:t>null </a:t>
+            </a:r>
+            <a:r>
+              <a:rPr lang="ko-KR" altLang="en-US" sz="1100"/>
+              <a:t>비중을 크게 안 봐도 될 것 같다</a:t>
+            </a:r>
+            <a:r>
+              <a:rPr lang="en-US" altLang="ko-KR" sz="1100"/>
+              <a:t>.</a:t>
+            </a:r>
+          </a:p>
+          <a:p>
+            <a:pPr>
+              <a:buNone/>
+            </a:pPr>
+            <a:r>
+              <a:rPr lang="en-US" altLang="ko-KR" sz="1100"/>
+              <a:t>- table </a:t>
+            </a:r>
+            <a:r>
+              <a:rPr lang="ko-KR" altLang="en-US" sz="1100"/>
+              <a:t>행 갯수에 비해 </a:t>
+            </a:r>
+            <a:r>
+              <a:rPr lang="en-US" altLang="ko-KR" sz="1100"/>
+              <a:t>null </a:t>
+            </a:r>
+            <a:r>
+              <a:rPr lang="ko-KR" altLang="en-US" sz="1100"/>
+              <a:t>비중이 </a:t>
+            </a:r>
+            <a:r>
+              <a:rPr lang="en-US" altLang="ko-KR" sz="1100"/>
+              <a:t>20%</a:t>
+            </a:r>
+            <a:r>
+              <a:rPr lang="ko-KR" altLang="en-US" sz="1100"/>
+              <a:t>정도나 되더라도 </a:t>
+            </a:r>
+            <a:r>
+              <a:rPr lang="en-US" altLang="ko-KR" sz="1100"/>
+              <a:t>input data</a:t>
+            </a:r>
+            <a:r>
+              <a:rPr lang="ko-KR" altLang="en-US" sz="1100"/>
+              <a:t>가 어떻게 어우러지면 </a:t>
+            </a:r>
+            <a:r>
+              <a:rPr lang="en-US" altLang="ko-KR" sz="1100"/>
+              <a:t>output</a:t>
+            </a:r>
+            <a:r>
+              <a:rPr lang="ko-KR" altLang="en-US" sz="1100"/>
+              <a:t>과 연동되겠다 싶은 </a:t>
+            </a:r>
+            <a:r>
+              <a:rPr lang="en-US" altLang="ko-KR" sz="1100"/>
+              <a:t>column</a:t>
+            </a:r>
+            <a:r>
+              <a:rPr lang="ko-KR" altLang="en-US" sz="1100"/>
+              <a:t>이 있을 때 그것을 근거로 해당 </a:t>
+            </a:r>
+            <a:r>
+              <a:rPr lang="en-US" altLang="ko-KR" sz="1100"/>
+              <a:t>column</a:t>
+            </a:r>
+            <a:r>
+              <a:rPr lang="ko-KR" altLang="en-US" sz="1100"/>
+              <a:t>을 </a:t>
+            </a:r>
+            <a:r>
+              <a:rPr lang="en-US" altLang="ko-KR" sz="1100"/>
+              <a:t>feature</a:t>
+            </a:r>
+            <a:r>
+              <a:rPr lang="ko-KR" altLang="en-US" sz="1100"/>
+              <a:t>로 잡을 수 있고 </a:t>
+            </a:r>
+            <a:r>
+              <a:rPr lang="en-US" altLang="ko-KR" sz="1100"/>
+              <a:t>(lotfrontage?? - </a:t>
+            </a:r>
+            <a:r>
+              <a:rPr lang="ko-KR" altLang="en-US" sz="1100"/>
+              <a:t>집값</a:t>
+            </a:r>
+            <a:r>
+              <a:rPr lang="en-US" altLang="ko-KR" sz="1100"/>
+              <a:t>)</a:t>
+            </a:r>
+          </a:p>
+          <a:p>
+            <a:pPr>
+              <a:buNone/>
+            </a:pPr>
+            <a:r>
+              <a:rPr lang="en-US" altLang="ko-KR" sz="1100"/>
+              <a:t>- </a:t>
+            </a:r>
+            <a:r>
+              <a:rPr lang="ko-KR" altLang="en-US" sz="1100"/>
+              <a:t>거의 </a:t>
+            </a:r>
+            <a:r>
+              <a:rPr lang="en-US" altLang="ko-KR" sz="1100"/>
+              <a:t>1100</a:t>
+            </a:r>
+            <a:r>
+              <a:rPr lang="ko-KR" altLang="en-US" sz="1100"/>
+              <a:t>개 중 </a:t>
+            </a:r>
+            <a:r>
+              <a:rPr lang="en-US" altLang="ko-KR" sz="1100"/>
+              <a:t>70</a:t>
+            </a:r>
+            <a:r>
+              <a:rPr lang="ko-KR" altLang="en-US" sz="1100"/>
+              <a:t>개 이하만 </a:t>
+            </a:r>
+            <a:r>
+              <a:rPr lang="en-US" altLang="ko-KR" sz="1100"/>
+              <a:t>null</a:t>
+            </a:r>
+            <a:r>
+              <a:rPr lang="ko-KR" altLang="en-US" sz="1100"/>
+              <a:t>인 데이터라고 해도 </a:t>
+            </a:r>
+            <a:r>
+              <a:rPr lang="en-US" altLang="ko-KR" sz="1100"/>
+              <a:t>output</a:t>
+            </a:r>
+            <a:r>
+              <a:rPr lang="ko-KR" altLang="en-US" sz="1100"/>
+              <a:t>과의 큰 </a:t>
+            </a:r>
+            <a:r>
+              <a:rPr lang="en-US" altLang="ko-KR" sz="1100"/>
+              <a:t>'</a:t>
+            </a:r>
+            <a:r>
+              <a:rPr lang="ko-KR" altLang="en-US" sz="1100"/>
+              <a:t>상관관계</a:t>
+            </a:r>
+            <a:r>
+              <a:rPr lang="en-US" altLang="ko-KR" sz="1100"/>
+              <a:t>'?</a:t>
+            </a:r>
+            <a:r>
+              <a:rPr lang="ko-KR" altLang="en-US" sz="1100"/>
+              <a:t>가 없을 때 </a:t>
+            </a:r>
+            <a:r>
+              <a:rPr lang="en-US" altLang="ko-KR" sz="1100"/>
+              <a:t>(</a:t>
+            </a:r>
+            <a:r>
+              <a:rPr lang="ko-KR" altLang="en-US" sz="1100"/>
+              <a:t>차고를 언제 지었는가 </a:t>
+            </a:r>
+            <a:r>
+              <a:rPr lang="en-US" altLang="ko-KR" sz="1100"/>
+              <a:t>- </a:t>
+            </a:r>
+            <a:r>
+              <a:rPr lang="ko-KR" altLang="en-US" sz="1100"/>
+              <a:t>집값</a:t>
+            </a:r>
+            <a:r>
+              <a:rPr lang="en-US" altLang="ko-KR" sz="1100"/>
+              <a:t>) omit </a:t>
+            </a:r>
+            <a:r>
+              <a:rPr lang="ko-KR" altLang="en-US" sz="1100"/>
+              <a:t>하는게 더 성능을 올릴 수 있다</a:t>
+            </a:r>
+            <a:r>
+              <a:rPr lang="en-US" altLang="ko-KR" sz="1100"/>
+              <a:t>.</a:t>
+            </a:r>
+          </a:p>
+          <a:p>
+            <a:pPr>
+              <a:buNone/>
+            </a:pPr>
+            <a:r>
+              <a:rPr lang="en-US" altLang="ko-KR" sz="1100"/>
+              <a:t>2. ML</a:t>
+            </a:r>
+            <a:r>
+              <a:rPr lang="ko-KR" altLang="en-US" sz="1100"/>
+              <a:t>에서 </a:t>
+            </a:r>
+            <a:r>
+              <a:rPr lang="en-US" altLang="ko-KR" sz="1100"/>
+              <a:t>domain knowledge</a:t>
+            </a:r>
+            <a:r>
+              <a:rPr lang="ko-KR" altLang="en-US" sz="1100"/>
+              <a:t>는 매우 </a:t>
+            </a:r>
+            <a:r>
+              <a:rPr lang="en-US" altLang="ko-KR" sz="1100"/>
+              <a:t>powerful</a:t>
+            </a:r>
+            <a:r>
+              <a:rPr lang="ko-KR" altLang="en-US" sz="1100"/>
+              <a:t>하다</a:t>
+            </a:r>
+            <a:r>
+              <a:rPr lang="en-US" altLang="ko-KR" sz="1100"/>
+              <a:t>.</a:t>
+            </a:r>
+          </a:p>
+          <a:p>
+            <a:pPr>
+              <a:buNone/>
+            </a:pPr>
+            <a:r>
+              <a:rPr lang="en-US" altLang="ko-KR" sz="1100"/>
+              <a:t>domain knowledge</a:t>
+            </a:r>
+            <a:r>
+              <a:rPr lang="ko-KR" altLang="en-US" sz="1100"/>
+              <a:t>를 깊이 알수록 입력과 출력 데이터 사이에 존재하는 관계를 더 잘 알 수 있다</a:t>
+            </a:r>
+            <a:r>
+              <a:rPr lang="en-US" altLang="ko-KR" sz="1100"/>
+              <a:t>.</a:t>
+            </a:r>
+          </a:p>
+          <a:p>
+            <a:pPr>
+              <a:buNone/>
+            </a:pPr>
+            <a:r>
+              <a:rPr lang="en-US" altLang="ko-KR" sz="1100"/>
+              <a:t>3. domain knowledge </a:t>
+            </a:r>
+            <a:r>
+              <a:rPr lang="ko-KR" altLang="en-US" sz="1100"/>
+              <a:t>를 잘 모르면 직관성 </a:t>
+            </a:r>
+            <a:r>
+              <a:rPr lang="en-US" altLang="ko-KR" sz="1100"/>
+              <a:t>(e.g. </a:t>
+            </a:r>
+            <a:r>
+              <a:rPr lang="ko-KR" altLang="en-US" sz="1100"/>
+              <a:t>차고 만든 년도가 집값이랑 별 상관이 없을 것 같다</a:t>
+            </a:r>
+            <a:r>
+              <a:rPr lang="en-US" altLang="ko-KR" sz="1100"/>
+              <a:t>) </a:t>
+            </a:r>
+            <a:r>
+              <a:rPr lang="ko-KR" altLang="en-US" sz="1100"/>
+              <a:t>과 </a:t>
+            </a:r>
+            <a:r>
+              <a:rPr lang="en-US" altLang="ko-KR" sz="1100"/>
+              <a:t>low-level </a:t>
+            </a:r>
+            <a:r>
+              <a:rPr lang="ko-KR" altLang="en-US" sz="1100"/>
+              <a:t>데이터 분석력 </a:t>
+            </a:r>
+            <a:r>
+              <a:rPr lang="en-US" altLang="ko-KR" sz="1100"/>
+              <a:t>(e.g. </a:t>
+            </a:r>
+            <a:r>
+              <a:rPr lang="ko-KR" altLang="en-US" sz="1100"/>
+              <a:t>상관관계 </a:t>
+            </a:r>
+            <a:r>
+              <a:rPr lang="en-US" altLang="ko-KR" sz="1100"/>
+              <a:t>/ </a:t>
+            </a:r>
+            <a:r>
+              <a:rPr lang="ko-KR" altLang="en-US" sz="1100"/>
+              <a:t>단일 </a:t>
+            </a:r>
+            <a:r>
+              <a:rPr lang="en-US" altLang="ko-KR" sz="1100"/>
+              <a:t>column </a:t>
+            </a:r>
+            <a:r>
+              <a:rPr lang="ko-KR" altLang="en-US" sz="1100"/>
+              <a:t>통계 등</a:t>
+            </a:r>
+            <a:r>
+              <a:rPr lang="en-US" altLang="ko-KR" sz="1100"/>
+              <a:t>)</a:t>
+            </a:r>
+            <a:r>
+              <a:rPr lang="ko-KR" altLang="en-US" sz="1100"/>
+              <a:t>이 뒷받침되어야 한다</a:t>
+            </a:r>
+            <a:r>
+              <a:rPr lang="en-US" altLang="ko-KR" sz="1100"/>
+              <a:t>.</a:t>
+            </a:r>
+          </a:p>
+          <a:p>
+            <a:pPr>
+              <a:buNone/>
+            </a:pPr>
+            <a:r>
+              <a:rPr lang="en-US" altLang="ko-KR" sz="1100"/>
+              <a:t>- '</a:t>
+            </a:r>
+            <a:r>
+              <a:rPr lang="ko-KR" altLang="en-US" sz="1100"/>
+              <a:t>관계</a:t>
+            </a:r>
+            <a:r>
+              <a:rPr lang="en-US" altLang="ko-KR" sz="1100"/>
+              <a:t>'</a:t>
+            </a:r>
+            <a:r>
+              <a:rPr lang="ko-KR" altLang="en-US" sz="1100"/>
+              <a:t>를 찾을 때는 먼저 각 </a:t>
+            </a:r>
+            <a:r>
+              <a:rPr lang="en-US" altLang="ko-KR" sz="1100"/>
+              <a:t>column</a:t>
+            </a:r>
+            <a:r>
+              <a:rPr lang="ko-KR" altLang="en-US" sz="1100"/>
+              <a:t>이 무엇을 의미하는지 명세서를 꼼꼼이 확인하고 그 다음에 </a:t>
+            </a:r>
+            <a:r>
+              <a:rPr lang="en-US" altLang="ko-KR" sz="1100"/>
+              <a:t>'</a:t>
+            </a:r>
+            <a:r>
+              <a:rPr lang="ko-KR" altLang="en-US" sz="1100"/>
+              <a:t>직관력</a:t>
+            </a:r>
+            <a:r>
+              <a:rPr lang="en-US" altLang="ko-KR" sz="1100"/>
+              <a:t>'</a:t>
+            </a:r>
+            <a:r>
+              <a:rPr lang="ko-KR" altLang="en-US" sz="1100"/>
+              <a:t>을 사용하자</a:t>
+            </a:r>
+            <a:r>
+              <a:rPr lang="en-US" altLang="ko-KR" sz="1100"/>
+              <a:t>.</a:t>
+            </a:r>
+          </a:p>
+          <a:p>
+            <a:pPr>
+              <a:buNone/>
+            </a:pPr>
+            <a:r>
+              <a:rPr lang="en-US" altLang="ko-KR" sz="1100"/>
+              <a:t>- </a:t>
+            </a:r>
+            <a:r>
+              <a:rPr lang="ko-KR" altLang="en-US" sz="1100"/>
+              <a:t>잘 모를 때는 데이터를 먼저 분석하거나 전체적으로 훑어봐서 그 관계를 간접적으로나마 알 수 있다</a:t>
+            </a:r>
+            <a:r>
+              <a:rPr lang="en-US" altLang="ko-KR" sz="1100"/>
+              <a:t>.</a:t>
+            </a:r>
+          </a:p>
+          <a:p>
+            <a:pPr>
+              <a:buNone/>
+            </a:pPr>
+            <a:r>
+              <a:rPr lang="en-US" altLang="ko-KR" sz="1100"/>
+              <a:t>4. </a:t>
+            </a:r>
+            <a:r>
+              <a:rPr lang="ko-KR" altLang="en-US" sz="1100"/>
+              <a:t>성공적으로 </a:t>
+            </a:r>
+            <a:r>
+              <a:rPr lang="en-US" altLang="ko-KR" sz="1100"/>
+              <a:t>ML </a:t>
+            </a:r>
+            <a:r>
+              <a:rPr lang="ko-KR" altLang="en-US" sz="1100"/>
+              <a:t>점수를 받는 행동을 반복하다 보면 직관성이 길러질 것 같다</a:t>
+            </a:r>
+            <a:r>
+              <a:rPr lang="en-US" altLang="ko-KR" sz="1100"/>
+              <a:t>.</a:t>
+            </a:r>
+          </a:p>
+          <a:p>
+            <a:pPr>
+              <a:buNone/>
+            </a:pPr>
+            <a:r>
+              <a:rPr lang="en-US" altLang="ko-KR" sz="1100"/>
+              <a:t>- </a:t>
+            </a:r>
+            <a:r>
+              <a:rPr lang="ko-KR" altLang="en-US" sz="1100"/>
+              <a:t>실제 세계에서 특정 개념들 사이에 연관이 잘 되어있으니 </a:t>
+            </a:r>
+            <a:r>
+              <a:rPr lang="en-US" altLang="ko-KR" sz="1100"/>
+              <a:t>~~</a:t>
+            </a:r>
+            <a:r>
+              <a:rPr lang="ko-KR" altLang="en-US" sz="1100"/>
+              <a:t>하면 되겠다 하는 시뮬레이션 능력을 더 키울 수 있을 것 같다</a:t>
+            </a:r>
+            <a:r>
+              <a:rPr lang="en-US" altLang="ko-KR" sz="1100"/>
+              <a:t>.</a:t>
+            </a:r>
+          </a:p>
+          <a:p>
+            <a:pPr>
+              <a:buNone/>
+            </a:pPr>
+            <a:r>
+              <a:rPr lang="ko-KR" altLang="en-US" sz="1100"/>
+              <a:t>그리고 분석 방법에 따라 데이터를 어떻게 정제</a:t>
+            </a:r>
+            <a:r>
+              <a:rPr lang="en-US" altLang="ko-KR" sz="1100"/>
+              <a:t>/</a:t>
+            </a:r>
+            <a:r>
+              <a:rPr lang="ko-KR" altLang="en-US" sz="1100"/>
+              <a:t>처리할지가 다 다르다고 생각했는데</a:t>
+            </a:r>
+            <a:r>
+              <a:rPr lang="en-US" altLang="ko-KR" sz="1100"/>
+              <a:t>, '</a:t>
+            </a:r>
+            <a:r>
+              <a:rPr lang="ko-KR" altLang="en-US" sz="1100"/>
+              <a:t>빈 데이터 처리</a:t>
+            </a:r>
+            <a:r>
+              <a:rPr lang="en-US" altLang="ko-KR" sz="1100"/>
+              <a:t>' </a:t>
+            </a:r>
+            <a:r>
+              <a:rPr lang="ko-KR" altLang="en-US" sz="1100"/>
+              <a:t>부분을 수강한 이후에는 이와 무관하게 </a:t>
+            </a:r>
+            <a:r>
+              <a:rPr lang="en-US" altLang="ko-KR" sz="1100"/>
+              <a:t>null </a:t>
+            </a:r>
+            <a:r>
+              <a:rPr lang="ko-KR" altLang="en-US" sz="1100"/>
+              <a:t>값을 어떻게 채울지와</a:t>
+            </a:r>
+            <a:r>
+              <a:rPr lang="en-US" altLang="ko-KR" sz="1100"/>
+              <a:t>, feature</a:t>
+            </a:r>
+            <a:r>
+              <a:rPr lang="ko-KR" altLang="en-US" sz="1100"/>
+              <a:t>에서 제외되는 </a:t>
+            </a:r>
+            <a:r>
+              <a:rPr lang="en-US" altLang="ko-KR" sz="1100"/>
+              <a:t>column</a:t>
+            </a:r>
+            <a:r>
+              <a:rPr lang="ko-KR" altLang="en-US" sz="1100"/>
+              <a:t>이 무엇인지를 결정할 수 있겠다는 생각이 들더라고</a:t>
+            </a:r>
+          </a:p>
+        </p:txBody>
+      </p:sp>
+      <p:sp>
+        <p:nvSpPr>
+          <p:cNvPr id="6" name="Title 5">
+            <a:extLst>
+              <a:ext uri="{FF2B5EF4-FFF2-40B4-BE49-F238E27FC236}">
+                <a16:creationId xmlns:a16="http://schemas.microsoft.com/office/drawing/2014/main" id="{957C2209-279B-B078-00B4-7597A58928DD}"/>
               </a:ext>
             </a:extLst>
           </p:cNvPr>
@@ -7635,32 +8200,18 @@
           <a:bodyPr/>
           <a:lstStyle/>
           <a:p>
-            <a:endParaRPr lang="en-US"/>
-          </a:p>
-        </p:txBody>
-      </p:sp>
-      <p:sp>
-        <p:nvSpPr>
-          <p:cNvPr id="3" name="Content Placeholder 2">
-            <a:extLst>
-              <a:ext uri="{FF2B5EF4-FFF2-40B4-BE49-F238E27FC236}">
-                <a16:creationId xmlns:a16="http://schemas.microsoft.com/office/drawing/2014/main" id="{E31AE387-B473-B95A-3B24-BDD25049364D}"/>
-              </a:ext>
-            </a:extLst>
-          </p:cNvPr>
-          <p:cNvSpPr>
-            <a:spLocks noGrp="1"/>
-          </p:cNvSpPr>
-          <p:nvPr>
-            <p:ph idx="1"/>
-          </p:nvPr>
-        </p:nvSpPr>
-        <p:spPr/>
-        <p:txBody>
-          <a:bodyPr/>
-          <a:lstStyle/>
-          <a:p>
-            <a:endParaRPr lang="en-US"/>
+            <a:r>
+              <a:rPr lang="en-US"/>
+              <a:t>5-260227 - Upday Project</a:t>
+            </a:r>
+            <a:r>
+              <a:rPr lang="ko-KR" altLang="en-US"/>
+              <a:t>의 방향성 고민</a:t>
+            </a:r>
+            <a:r>
+              <a:rPr lang="en-US"/>
+              <a:t> </a:t>
+            </a:r>
           </a:p>
         </p:txBody>
       </p:sp>

</xml_diff>

<commit_message>
Day 6 complete - struggling with categorical variable and join handling
</commit_message>
<xml_diff>
--- a/Kaggle!.pptx
+++ b/Kaggle!.pptx
@@ -5,7 +5,7 @@
     <p:sldMasterId id="2147483648" r:id="rId1"/>
   </p:sldMasterIdLst>
   <p:notesMasterIdLst>
-    <p:notesMasterId r:id="rId29"/>
+    <p:notesMasterId r:id="rId36"/>
   </p:notesMasterIdLst>
   <p:sldIdLst>
     <p:sldId id="256" r:id="rId2"/>
@@ -35,6 +35,13 @@
     <p:sldId id="283" r:id="rId26"/>
     <p:sldId id="281" r:id="rId27"/>
     <p:sldId id="282" r:id="rId28"/>
+    <p:sldId id="284" r:id="rId29"/>
+    <p:sldId id="285" r:id="rId30"/>
+    <p:sldId id="286" r:id="rId31"/>
+    <p:sldId id="287" r:id="rId32"/>
+    <p:sldId id="288" r:id="rId33"/>
+    <p:sldId id="289" r:id="rId34"/>
+    <p:sldId id="290" r:id="rId35"/>
   </p:sldIdLst>
   <p:sldSz cx="12192000" cy="6858000"/>
   <p:notesSz cx="6858000" cy="9144000"/>
@@ -223,7 +230,7 @@
           <a:p>
             <a:fld id="{696CDF9F-ADA0-4C49-A263-B2AE48107B92}" type="datetimeFigureOut">
               <a:rPr lang="en-US" smtClean="0"/>
-              <a:t>2/27/2026</a:t>
+              <a:t>3/6/2026</a:t>
             </a:fld>
             <a:endParaRPr lang="en-US"/>
           </a:p>
@@ -805,7 +812,7 @@
           <a:p>
             <a:fld id="{8B8BF7D9-AC52-4AC2-BEDB-A5D1257FD4A4}" type="datetimeFigureOut">
               <a:rPr lang="en-US" smtClean="0"/>
-              <a:t>2/27/2026</a:t>
+              <a:t>3/6/2026</a:t>
             </a:fld>
             <a:endParaRPr lang="en-US"/>
           </a:p>
@@ -1003,7 +1010,7 @@
           <a:p>
             <a:fld id="{8B8BF7D9-AC52-4AC2-BEDB-A5D1257FD4A4}" type="datetimeFigureOut">
               <a:rPr lang="en-US" smtClean="0"/>
-              <a:t>2/27/2026</a:t>
+              <a:t>3/6/2026</a:t>
             </a:fld>
             <a:endParaRPr lang="en-US"/>
           </a:p>
@@ -1211,7 +1218,7 @@
           <a:p>
             <a:fld id="{8B8BF7D9-AC52-4AC2-BEDB-A5D1257FD4A4}" type="datetimeFigureOut">
               <a:rPr lang="en-US" smtClean="0"/>
-              <a:t>2/27/2026</a:t>
+              <a:t>3/6/2026</a:t>
             </a:fld>
             <a:endParaRPr lang="en-US"/>
           </a:p>
@@ -1409,7 +1416,7 @@
           <a:p>
             <a:fld id="{8B8BF7D9-AC52-4AC2-BEDB-A5D1257FD4A4}" type="datetimeFigureOut">
               <a:rPr lang="en-US" smtClean="0"/>
-              <a:t>2/27/2026</a:t>
+              <a:t>3/6/2026</a:t>
             </a:fld>
             <a:endParaRPr lang="en-US"/>
           </a:p>
@@ -1684,7 +1691,7 @@
           <a:p>
             <a:fld id="{8B8BF7D9-AC52-4AC2-BEDB-A5D1257FD4A4}" type="datetimeFigureOut">
               <a:rPr lang="en-US" smtClean="0"/>
-              <a:t>2/27/2026</a:t>
+              <a:t>3/6/2026</a:t>
             </a:fld>
             <a:endParaRPr lang="en-US"/>
           </a:p>
@@ -1949,7 +1956,7 @@
           <a:p>
             <a:fld id="{8B8BF7D9-AC52-4AC2-BEDB-A5D1257FD4A4}" type="datetimeFigureOut">
               <a:rPr lang="en-US" smtClean="0"/>
-              <a:t>2/27/2026</a:t>
+              <a:t>3/6/2026</a:t>
             </a:fld>
             <a:endParaRPr lang="en-US"/>
           </a:p>
@@ -2361,7 +2368,7 @@
           <a:p>
             <a:fld id="{8B8BF7D9-AC52-4AC2-BEDB-A5D1257FD4A4}" type="datetimeFigureOut">
               <a:rPr lang="en-US" smtClean="0"/>
-              <a:t>2/27/2026</a:t>
+              <a:t>3/6/2026</a:t>
             </a:fld>
             <a:endParaRPr lang="en-US"/>
           </a:p>
@@ -2502,7 +2509,7 @@
           <a:p>
             <a:fld id="{8B8BF7D9-AC52-4AC2-BEDB-A5D1257FD4A4}" type="datetimeFigureOut">
               <a:rPr lang="en-US" smtClean="0"/>
-              <a:t>2/27/2026</a:t>
+              <a:t>3/6/2026</a:t>
             </a:fld>
             <a:endParaRPr lang="en-US"/>
           </a:p>
@@ -2615,7 +2622,7 @@
           <a:p>
             <a:fld id="{8B8BF7D9-AC52-4AC2-BEDB-A5D1257FD4A4}" type="datetimeFigureOut">
               <a:rPr lang="en-US" smtClean="0"/>
-              <a:t>2/27/2026</a:t>
+              <a:t>3/6/2026</a:t>
             </a:fld>
             <a:endParaRPr lang="en-US"/>
           </a:p>
@@ -2926,7 +2933,7 @@
           <a:p>
             <a:fld id="{8B8BF7D9-AC52-4AC2-BEDB-A5D1257FD4A4}" type="datetimeFigureOut">
               <a:rPr lang="en-US" smtClean="0"/>
-              <a:t>2/27/2026</a:t>
+              <a:t>3/6/2026</a:t>
             </a:fld>
             <a:endParaRPr lang="en-US"/>
           </a:p>
@@ -3214,7 +3221,7 @@
           <a:p>
             <a:fld id="{8B8BF7D9-AC52-4AC2-BEDB-A5D1257FD4A4}" type="datetimeFigureOut">
               <a:rPr lang="en-US" smtClean="0"/>
-              <a:t>2/27/2026</a:t>
+              <a:t>3/6/2026</a:t>
             </a:fld>
             <a:endParaRPr lang="en-US"/>
           </a:p>
@@ -3455,7 +3462,7 @@
           <a:p>
             <a:fld id="{8B8BF7D9-AC52-4AC2-BEDB-A5D1257FD4A4}" type="datetimeFigureOut">
               <a:rPr lang="en-US" smtClean="0"/>
-              <a:t>2/27/2026</a:t>
+              <a:t>3/6/2026</a:t>
             </a:fld>
             <a:endParaRPr lang="en-US"/>
           </a:p>
@@ -8266,7 +8273,10 @@
           <a:bodyPr/>
           <a:lstStyle/>
           <a:p>
-            <a:endParaRPr lang="en-US"/>
+            <a:r>
+              <a:rPr lang="en-US"/>
+              <a:t>6-260306 ML Intermediate 3/7~</a:t>
+            </a:r>
           </a:p>
         </p:txBody>
       </p:sp>
@@ -8327,10 +8337,10 @@
       </p:grpSpPr>
       <p:sp>
         <p:nvSpPr>
-          <p:cNvPr id="2" name="Title 1">
-            <a:extLst>
-              <a:ext uri="{FF2B5EF4-FFF2-40B4-BE49-F238E27FC236}">
-                <a16:creationId xmlns:a16="http://schemas.microsoft.com/office/drawing/2014/main" id="{97AB947F-5543-C04A-7C00-FC25D49E9DE0}"/>
+          <p:cNvPr id="4" name="Title 3">
+            <a:extLst>
+              <a:ext uri="{FF2B5EF4-FFF2-40B4-BE49-F238E27FC236}">
+                <a16:creationId xmlns:a16="http://schemas.microsoft.com/office/drawing/2014/main" id="{384EDF35-44AF-EF02-C485-DCEB49FA34BA}"/>
               </a:ext>
             </a:extLst>
           </p:cNvPr>
@@ -8346,7 +8356,38 @@
           <a:bodyPr/>
           <a:lstStyle/>
           <a:p>
-            <a:endParaRPr lang="en-US"/>
+            <a:r>
+              <a:rPr lang="en-US"/>
+              <a:t>Categorical Variables</a:t>
+            </a:r>
+          </a:p>
+        </p:txBody>
+      </p:sp>
+      <p:sp>
+        <p:nvSpPr>
+          <p:cNvPr id="6" name="Text Placeholder 5">
+            <a:extLst>
+              <a:ext uri="{FF2B5EF4-FFF2-40B4-BE49-F238E27FC236}">
+                <a16:creationId xmlns:a16="http://schemas.microsoft.com/office/drawing/2014/main" id="{D19260AD-4263-1602-3052-E4DB269CCFB8}"/>
+              </a:ext>
+            </a:extLst>
+          </p:cNvPr>
+          <p:cNvSpPr>
+            <a:spLocks noGrp="1"/>
+          </p:cNvSpPr>
+          <p:nvPr>
+            <p:ph type="body" idx="1"/>
+          </p:nvPr>
+        </p:nvSpPr>
+        <p:spPr/>
+        <p:txBody>
+          <a:bodyPr/>
+          <a:lstStyle/>
+          <a:p>
+            <a:r>
+              <a:rPr lang="en-US"/>
+              <a:t>Concepts</a:t>
+            </a:r>
           </a:p>
         </p:txBody>
       </p:sp>
@@ -8363,7 +8404,84 @@
             <a:spLocks noGrp="1"/>
           </p:cNvSpPr>
           <p:nvPr>
-            <p:ph idx="1"/>
+            <p:ph sz="half" idx="2"/>
+          </p:nvPr>
+        </p:nvSpPr>
+        <p:spPr/>
+        <p:txBody>
+          <a:bodyPr>
+            <a:normAutofit fontScale="77500" lnSpcReduction="20000"/>
+          </a:bodyPr>
+          <a:lstStyle/>
+          <a:p>
+            <a:r>
+              <a:rPr lang="en-US"/>
+              <a:t>Non-numeric variables with finite(limited) domain.</a:t>
+            </a:r>
+          </a:p>
+          <a:p>
+            <a:pPr lvl="1"/>
+            <a:r>
+              <a:rPr lang="en-US"/>
+              <a:t>[Every day, Never, Rarely, Most days]</a:t>
+            </a:r>
+          </a:p>
+          <a:p>
+            <a:pPr lvl="1"/>
+            <a:r>
+              <a:rPr lang="en-US"/>
+              <a:t>[Honda, Toyota, Ford]</a:t>
+            </a:r>
+          </a:p>
+          <a:p>
+            <a:r>
+              <a:rPr lang="en-US"/>
+              <a:t>Ordinality</a:t>
+            </a:r>
+          </a:p>
+          <a:p>
+            <a:pPr lvl="1"/>
+            <a:r>
+              <a:rPr lang="en-US"/>
+              <a:t>Attribute of a column having an indisputable ranking in the domain.</a:t>
+            </a:r>
+          </a:p>
+          <a:p>
+            <a:r>
+              <a:rPr lang="en-US"/>
+              <a:t>Non-ordinal Categorical variables == </a:t>
+            </a:r>
+            <a:r>
+              <a:rPr lang="en-US" b="1"/>
+              <a:t>nominal</a:t>
+            </a:r>
+            <a:r>
+              <a:rPr lang="en-US"/>
+              <a:t> variables</a:t>
+            </a:r>
+          </a:p>
+          <a:p>
+            <a:r>
+              <a:rPr lang="en-US"/>
+              <a:t>“Cardinality”: size of the domain of the nominal variable</a:t>
+            </a:r>
+          </a:p>
+        </p:txBody>
+      </p:sp>
+      <p:sp>
+        <p:nvSpPr>
+          <p:cNvPr id="7" name="Text Placeholder 6">
+            <a:extLst>
+              <a:ext uri="{FF2B5EF4-FFF2-40B4-BE49-F238E27FC236}">
+                <a16:creationId xmlns:a16="http://schemas.microsoft.com/office/drawing/2014/main" id="{791F9060-CE0A-4520-488A-457FB8881C50}"/>
+              </a:ext>
+            </a:extLst>
+          </p:cNvPr>
+          <p:cNvSpPr>
+            <a:spLocks noGrp="1"/>
+          </p:cNvSpPr>
+          <p:nvPr>
+            <p:ph type="body" sz="quarter" idx="3"/>
           </p:nvPr>
         </p:nvSpPr>
         <p:spPr/>
@@ -8371,7 +8489,311 @@
           <a:bodyPr/>
           <a:lstStyle/>
           <a:p>
-            <a:endParaRPr lang="en-US"/>
+            <a:r>
+              <a:rPr lang="en-US"/>
+              <a:t>Dealing them</a:t>
+            </a:r>
+          </a:p>
+        </p:txBody>
+      </p:sp>
+      <p:sp>
+        <p:nvSpPr>
+          <p:cNvPr id="5" name="Content Placeholder 4">
+            <a:extLst>
+              <a:ext uri="{FF2B5EF4-FFF2-40B4-BE49-F238E27FC236}">
+                <a16:creationId xmlns:a16="http://schemas.microsoft.com/office/drawing/2014/main" id="{5B606220-06BB-9E70-3FCA-F1CCC3636A52}"/>
+              </a:ext>
+            </a:extLst>
+          </p:cNvPr>
+          <p:cNvSpPr>
+            <a:spLocks noGrp="1"/>
+          </p:cNvSpPr>
+          <p:nvPr>
+            <p:ph sz="quarter" idx="4"/>
+          </p:nvPr>
+        </p:nvSpPr>
+        <p:spPr/>
+        <p:txBody>
+          <a:bodyPr>
+            <a:normAutofit fontScale="77500" lnSpcReduction="20000"/>
+          </a:bodyPr>
+          <a:lstStyle/>
+          <a:p>
+            <a:r>
+              <a:rPr lang="en-US"/>
+              <a:t>Drop Categorical Variables</a:t>
+            </a:r>
+          </a:p>
+          <a:p>
+            <a:pPr lvl="1"/>
+            <a:r>
+              <a:rPr lang="en-US"/>
+              <a:t>If not useful, remove from the dataset</a:t>
+            </a:r>
+          </a:p>
+          <a:p>
+            <a:r>
+              <a:rPr lang="en-US"/>
+              <a:t>Ordinal Encoding</a:t>
+            </a:r>
+          </a:p>
+          <a:p>
+            <a:pPr lvl="1"/>
+            <a:r>
+              <a:rPr lang="en-US"/>
+              <a:t>Assigns a number to the ordinal variable domain.</a:t>
+            </a:r>
+          </a:p>
+          <a:p>
+            <a:pPr lvl="2"/>
+            <a:r>
+              <a:rPr lang="en-US"/>
+              <a:t>Never(0)&lt;Rarely(1)&lt;Most days(2)&lt;Every day(3)</a:t>
+            </a:r>
+          </a:p>
+          <a:p>
+            <a:pPr lvl="1"/>
+            <a:r>
+              <a:rPr lang="en-US"/>
+              <a:t>Works well in </a:t>
+            </a:r>
+            <a:r>
+              <a:rPr lang="en-US" b="1"/>
+              <a:t>tree-based</a:t>
+            </a:r>
+            <a:r>
+              <a:rPr lang="en-US"/>
+              <a:t> models (e.g. decision trees and random forests)</a:t>
+            </a:r>
+          </a:p>
+          <a:p>
+            <a:r>
+              <a:rPr lang="en-US"/>
+              <a:t>One-Hot Encoding</a:t>
+            </a:r>
+          </a:p>
+          <a:p>
+            <a:pPr lvl="1"/>
+            <a:r>
+              <a:rPr lang="en-US"/>
+              <a:t>Assign the presence of each value.</a:t>
+            </a:r>
+          </a:p>
+          <a:p>
+            <a:pPr lvl="1"/>
+            <a:r>
+              <a:rPr lang="en-US"/>
+              <a:t>Apply for nominal values.</a:t>
+            </a:r>
+          </a:p>
+          <a:p>
+            <a:pPr lvl="1"/>
+            <a:r>
+              <a:rPr lang="en-US"/>
+              <a:t>Does not perform well if the </a:t>
+            </a:r>
+            <a:r>
+              <a:rPr lang="en-US" i="1"/>
+              <a:t>cardinality</a:t>
+            </a:r>
+            <a:r>
+              <a:rPr lang="en-US"/>
+              <a:t> is large. (cardinality&gt;=15 </a:t>
+            </a:r>
+            <a:r>
+              <a:rPr lang="en-US">
+                <a:sym typeface="Wingdings" panose="05000000000000000000" pitchFamily="2" charset="2"/>
+              </a:rPr>
+              <a:t></a:t>
+            </a:r>
+            <a:r>
+              <a:rPr lang="en-US"/>
+              <a:t> OUT)</a:t>
+            </a:r>
+          </a:p>
+        </p:txBody>
+      </p:sp>
+      <p:pic>
+        <p:nvPicPr>
+          <p:cNvPr id="11" name="Picture 10">
+            <a:extLst>
+              <a:ext uri="{FF2B5EF4-FFF2-40B4-BE49-F238E27FC236}">
+                <a16:creationId xmlns:a16="http://schemas.microsoft.com/office/drawing/2014/main" id="{CB5435F4-9D3A-C8D5-80A0-2E4D177773C7}"/>
+              </a:ext>
+            </a:extLst>
+          </p:cNvPr>
+          <p:cNvPicPr>
+            <a:picLocks noChangeAspect="1"/>
+          </p:cNvPicPr>
+          <p:nvPr/>
+        </p:nvPicPr>
+        <p:blipFill>
+          <a:blip r:embed="rId2">
+            <a:extLst>
+              <a:ext uri="{BEBA8EAE-BF5A-486C-A8C5-ECC9F3942E4B}">
+                <a14:imgProps xmlns:a14="http://schemas.microsoft.com/office/drawing/2010/main">
+                  <a14:imgLayer r:embed="rId3">
+                    <a14:imgEffect>
+                      <a14:backgroundRemoval t="0" b="99371" l="875" r="99213">
+                        <a14:foregroundMark x1="12336" y1="9434" x2="12336" y2="9434"/>
+                        <a14:foregroundMark x1="16710" y1="2935" x2="9886" y2="9853"/>
+                        <a14:foregroundMark x1="9886" y1="9853" x2="8749" y2="83229"/>
+                        <a14:foregroundMark x1="8749" y1="83229" x2="11374" y2="95597"/>
+                        <a14:foregroundMark x1="11374" y1="95597" x2="17148" y2="83229"/>
+                        <a14:foregroundMark x1="17148" y1="83229" x2="18373" y2="12579"/>
+                        <a14:foregroundMark x1="18373" y1="12579" x2="15748" y2="1887"/>
+                        <a14:foregroundMark x1="22310" y1="99790" x2="525" y2="98742"/>
+                        <a14:foregroundMark x1="525" y1="98742" x2="612" y2="7547"/>
+                        <a14:foregroundMark x1="612" y1="7547" x2="6737" y2="1048"/>
+                        <a14:foregroundMark x1="6737" y1="1048" x2="19335" y2="839"/>
+                        <a14:foregroundMark x1="19335" y1="839" x2="21222" y2="17142"/>
+                        <a14:foregroundMark x1="22605" y1="72956" x2="22572" y2="99161"/>
+                        <a14:foregroundMark x1="22614" y1="66083" x2="22613" y2="67086"/>
+                        <a14:foregroundMark x1="21171" y1="99142" x2="350" y2="98742"/>
+                        <a14:foregroundMark x1="350" y1="98742" x2="262" y2="7547"/>
+                        <a14:foregroundMark x1="262" y1="7547" x2="8136" y2="419"/>
+                        <a14:foregroundMark x1="8136" y1="419" x2="20910" y2="1468"/>
+                        <a14:foregroundMark x1="20910" y1="1468" x2="21973" y2="7338"/>
+                        <a14:foregroundMark x1="22650" y1="17228" x2="20472" y2="54507"/>
+                        <a14:foregroundMark x1="9449" y1="4822" x2="6824" y2="6709"/>
+                        <a14:foregroundMark x1="6737" y1="7757" x2="6737" y2="7757"/>
+                        <a14:foregroundMark x1="5337" y1="12369" x2="5162" y2="13208"/>
+                        <a14:foregroundMark x1="4637" y1="19078" x2="4637" y2="19078"/>
+                        <a14:foregroundMark x1="4287" y1="27883" x2="4199" y2="28721"/>
+                        <a14:foregroundMark x1="3937" y1="35010" x2="3937" y2="36478"/>
+                        <a14:foregroundMark x1="4549" y1="43187" x2="4549" y2="45073"/>
+                        <a14:foregroundMark x1="4899" y1="60797" x2="4899" y2="64570"/>
+                        <a14:foregroundMark x1="4637" y1="76939" x2="4637" y2="76939"/>
+                        <a14:foregroundMark x1="1487" y1="79665" x2="1487" y2="79665"/>
+                        <a14:foregroundMark x1="875" y1="75891" x2="962" y2="69811"/>
+                        <a14:foregroundMark x1="15311" y1="82390" x2="6212" y2="73585"/>
+                        <a14:foregroundMark x1="6212" y1="73585" x2="12336" y2="66876"/>
+                        <a14:foregroundMark x1="12336" y1="66876" x2="14436" y2="83019"/>
+                        <a14:foregroundMark x1="14436" y1="83019" x2="12686" y2="84067"/>
+                        <a14:foregroundMark x1="47944" y1="1048" x2="48381" y2="90985"/>
+                        <a14:foregroundMark x1="48381" y1="90985" x2="51619" y2="99581"/>
+                        <a14:foregroundMark x1="51619" y1="99581" x2="69204" y2="99790"/>
+                        <a14:foregroundMark x1="69204" y1="99790" x2="99913" y2="99161"/>
+                        <a14:foregroundMark x1="99913" y1="99161" x2="99300" y2="2306"/>
+                        <a14:foregroundMark x1="99300" y1="2306" x2="47157" y2="0"/>
+                        <a14:foregroundMark x1="14086" y1="22432" x2="14086" y2="22432"/>
+                        <a14:foregroundMark x1="13561" y1="36688" x2="13561" y2="36688"/>
+                        <a14:foregroundMark x1="14698" y1="24948" x2="14786" y2="24528"/>
+                        <a14:foregroundMark x1="16360" y1="19497" x2="13036" y2="35849"/>
+                        <a14:foregroundMark x1="13036" y1="35849" x2="12598" y2="49686"/>
+                        <a14:foregroundMark x1="12598" y1="49686" x2="12598" y2="49686"/>
+                        <a14:foregroundMark x1="17235" y1="20755" x2="2100" y2="43606"/>
+                        <a14:foregroundMark x1="2100" y1="43606" x2="2187" y2="45283"/>
+                        <a14:foregroundMark x1="14086" y1="22222" x2="11811" y2="53040"/>
+                        <a14:foregroundMark x1="11811" y1="53040" x2="12511" y2="58281"/>
+                        <a14:foregroundMark x1="12773" y1="58700" x2="7787" y2="47170"/>
+                        <a14:foregroundMark x1="10936" y1="44025" x2="2275" y2="74633"/>
+                        <a14:foregroundMark x1="9449" y1="65618" x2="9361" y2="88679"/>
+                        <a14:foregroundMark x1="99213" y1="99371" x2="55556" y2="97275"/>
+                        <a14:foregroundMark x1="55556" y1="97275" x2="49781" y2="79665"/>
+                        <a14:foregroundMark x1="49781" y1="79665" x2="51619" y2="51363"/>
+                        <a14:foregroundMark x1="51619" y1="51363" x2="57743" y2="32704"/>
+                        <a14:foregroundMark x1="57743" y1="32704" x2="80752" y2="30398"/>
+                        <a14:foregroundMark x1="80752" y1="30398" x2="90026" y2="51153"/>
+                        <a14:foregroundMark x1="90026" y1="51153" x2="90114" y2="88889"/>
+                        <a14:foregroundMark x1="94051" y1="88889" x2="84777" y2="91195"/>
+                        <a14:foregroundMark x1="84777" y1="91195" x2="60630" y2="65409"/>
+                        <a14:foregroundMark x1="60630" y1="65409" x2="76465" y2="52621"/>
+                        <a14:foregroundMark x1="76465" y1="52621" x2="83115" y2="56394"/>
+                        <a14:foregroundMark x1="84514" y1="83857" x2="69816" y2="75262"/>
+                        <a14:foregroundMark x1="69816" y1="75262" x2="59230" y2="45073"/>
+                        <a14:foregroundMark x1="74716" y1="51153" x2="74016" y2="52201"/>
+                        <a14:foregroundMark x1="63255" y1="51153" x2="60630" y2="46122"/>
+                        <a14:foregroundMark x1="53893" y1="37107" x2="53018" y2="35220"/>
+                        <a14:foregroundMark x1="52843" y1="32704" x2="53106" y2="27883"/>
+                        <a14:foregroundMark x1="57218" y1="21384" x2="57218" y2="21384"/>
+                        <a14:foregroundMark x1="61155" y1="21803" x2="61155" y2="21803"/>
+                        <a14:foregroundMark x1="54243" y1="21803" x2="52843" y2="20964"/>
+                        <a14:foregroundMark x1="51444" y1="20545" x2="50656" y2="20126"/>
+                        <a14:foregroundMark x1="55293" y1="27254" x2="55906" y2="27463"/>
+                        <a14:foregroundMark x1="37358" y1="50314" x2="37358" y2="50314"/>
+                        <a14:foregroundMark x1="21365" y1="15094" x2="21371" y2="17122"/>
+                        <a14:foregroundMark x1="21360" y1="13208" x2="21365" y2="15094"/>
+                        <a14:foregroundMark x1="21358" y1="12579" x2="21360" y2="13208"/>
+                        <a14:foregroundMark x1="74803" y1="77358" x2="59143" y2="77358"/>
+                        <a14:foregroundMark x1="59143" y1="77358" x2="56168" y2="66876"/>
+                        <a14:foregroundMark x1="56168" y1="66876" x2="58268" y2="45912"/>
+                        <a14:foregroundMark x1="58268" y1="45912" x2="80402" y2="21174"/>
+                        <a14:foregroundMark x1="80402" y1="21174" x2="86877" y2="20126"/>
+                        <a14:foregroundMark x1="86877" y1="20126" x2="92563" y2="34801"/>
+                        <a14:foregroundMark x1="92563" y1="34801" x2="92126" y2="70440"/>
+                        <a14:foregroundMark x1="92126" y1="70440" x2="91426" y2="75262"/>
+                        <a14:foregroundMark x1="62992" y1="80084" x2="59055" y2="72117"/>
+                        <a14:foregroundMark x1="59055" y1="72117" x2="54943" y2="49895"/>
+                        <a14:foregroundMark x1="54943" y1="49895" x2="54856" y2="45283"/>
+                        <a14:foregroundMark x1="21785" y1="5031" x2="21610" y2="20126"/>
+                        <a14:foregroundMark x1="21785" y1="29350" x2="21435" y2="54507"/>
+                        <a14:foregroundMark x1="22135" y1="45912" x2="22135" y2="45912"/>
+                        <a14:foregroundMark x1="22135" y1="42767" x2="22135" y2="42767"/>
+                        <a14:foregroundMark x1="21960" y1="38574" x2="21435" y2="32495"/>
+                        <a14:foregroundMark x1="21960" y1="29979" x2="22397" y2="79874"/>
+                        <a14:foregroundMark x1="21960" y1="27463" x2="21872" y2="34172"/>
+                        <a14:foregroundMark x1="21960" y1="80713" x2="21960" y2="85115"/>
+                        <a14:foregroundMark x1="22047" y1="85535" x2="22047" y2="85535"/>
+                        <a14:foregroundMark x1="21785" y1="85115" x2="22047" y2="87421"/>
+                        <a14:backgroundMark x1="23187" y1="12448" x2="24322" y2="16981"/>
+                        <a14:backgroundMark x1="22474" y1="20184" x2="22649" y2="27515"/>
+                        <a14:backgroundMark x1="22616" y1="87058" x2="22660" y2="99371"/>
+                        <a14:backgroundMark x1="22592" y1="79864" x2="22595" y2="80713"/>
+                        <a14:backgroundMark x1="47507" y1="839" x2="47507" y2="839"/>
+                      </a14:backgroundRemoval>
+                    </a14:imgEffect>
+                  </a14:imgLayer>
+                </a14:imgProps>
+              </a:ext>
+            </a:extLst>
+          </a:blip>
+          <a:stretch>
+            <a:fillRect/>
+          </a:stretch>
+        </p:blipFill>
+        <p:spPr>
+          <a:xfrm>
+            <a:off x="6398073" y="216437"/>
+            <a:ext cx="3888927" cy="1622938"/>
+          </a:xfrm>
+          <a:prstGeom prst="rect">
+            <a:avLst/>
+          </a:prstGeom>
+        </p:spPr>
+      </p:pic>
+      <p:sp>
+        <p:nvSpPr>
+          <p:cNvPr id="13" name="TextBox 12">
+            <a:extLst>
+              <a:ext uri="{FF2B5EF4-FFF2-40B4-BE49-F238E27FC236}">
+                <a16:creationId xmlns:a16="http://schemas.microsoft.com/office/drawing/2014/main" id="{AA2EDEE9-D5D1-AD43-7CBB-20BD5892962D}"/>
+              </a:ext>
+            </a:extLst>
+          </p:cNvPr>
+          <p:cNvSpPr txBox="1"/>
+          <p:nvPr/>
+        </p:nvSpPr>
+        <p:spPr>
+          <a:xfrm>
+            <a:off x="1524" y="6492875"/>
+            <a:ext cx="6094476" cy="369332"/>
+          </a:xfrm>
+          <a:prstGeom prst="rect">
+            <a:avLst/>
+          </a:prstGeom>
+          <a:noFill/>
+        </p:spPr>
+        <p:txBody>
+          <a:bodyPr wrap="square">
+            <a:spAutoFit/>
+          </a:bodyPr>
+          <a:lstStyle/>
+          <a:p>
+            <a:r>
+              <a:rPr lang="en-US"/>
+              <a:t>kaggle.com/code/alexisbcook/categorical-variables</a:t>
+            </a:r>
           </a:p>
         </p:txBody>
       </p:sp>
@@ -8426,7 +8848,10 @@
           <a:bodyPr/>
           <a:lstStyle/>
           <a:p>
-            <a:endParaRPr lang="en-US"/>
+            <a:r>
+              <a:rPr lang="en-US"/>
+              <a:t>“Problematic” Categorical Variables</a:t>
+            </a:r>
           </a:p>
         </p:txBody>
       </p:sp>
@@ -8443,22 +8868,421 @@
             <a:spLocks noGrp="1"/>
           </p:cNvSpPr>
           <p:nvPr>
-            <p:ph idx="1"/>
-          </p:nvPr>
-        </p:nvSpPr>
-        <p:spPr/>
-        <p:txBody>
-          <a:bodyPr/>
-          <a:lstStyle/>
-          <a:p>
-            <a:endParaRPr lang="en-US"/>
-          </a:p>
-        </p:txBody>
-      </p:sp>
+            <p:ph sz="half" idx="1"/>
+          </p:nvPr>
+        </p:nvSpPr>
+        <p:spPr/>
+        <p:txBody>
+          <a:bodyPr>
+            <a:normAutofit fontScale="92500" lnSpcReduction="20000"/>
+          </a:bodyPr>
+          <a:lstStyle/>
+          <a:p>
+            <a:r>
+              <a:rPr lang="en-US"/>
+              <a:t>Probably during EDA, we first have to specify the domain.</a:t>
+            </a:r>
+          </a:p>
+          <a:p>
+            <a:r>
+              <a:rPr lang="en-US"/>
+              <a:t>We could do something like this with</a:t>
+            </a:r>
+          </a:p>
+          <a:p>
+            <a:pPr lvl="1"/>
+            <a:r>
+              <a:rPr lang="en-US"/>
+              <a:t>X['Condition2'].unique(), X_test[‘Condition2’].unique()</a:t>
+            </a:r>
+          </a:p>
+          <a:p>
+            <a:r>
+              <a:rPr lang="en-US"/>
+              <a:t>BUT…</a:t>
+            </a:r>
+          </a:p>
+          <a:p>
+            <a:pPr lvl="1"/>
+            <a:r>
+              <a:rPr lang="en-US"/>
+              <a:t>X may NOT contain some values in X_test.</a:t>
+            </a:r>
+          </a:p>
+          <a:p>
+            <a:pPr lvl="1"/>
+            <a:r>
+              <a:rPr lang="en-US"/>
+              <a:t>X_train may NOT contain some values in X_valid.</a:t>
+            </a:r>
+          </a:p>
+          <a:p>
+            <a:r>
+              <a:rPr lang="en-US"/>
+              <a:t>This could be troublesome… (NO ‘auto-ordinal encoder’ works here)</a:t>
+            </a:r>
+          </a:p>
+        </p:txBody>
+      </p:sp>
+      <p:sp>
+        <p:nvSpPr>
+          <p:cNvPr id="6" name="Content Placeholder 5">
+            <a:extLst>
+              <a:ext uri="{FF2B5EF4-FFF2-40B4-BE49-F238E27FC236}">
+                <a16:creationId xmlns:a16="http://schemas.microsoft.com/office/drawing/2014/main" id="{5E310421-5B2D-51F6-2AEF-7C89EC4BB0B5}"/>
+              </a:ext>
+            </a:extLst>
+          </p:cNvPr>
+          <p:cNvSpPr>
+            <a:spLocks noGrp="1"/>
+          </p:cNvSpPr>
+          <p:nvPr>
+            <p:ph sz="half" idx="2"/>
+          </p:nvPr>
+        </p:nvSpPr>
+        <p:spPr/>
+        <p:txBody>
+          <a:bodyPr>
+            <a:normAutofit fontScale="92500" lnSpcReduction="20000"/>
+          </a:bodyPr>
+          <a:lstStyle/>
+          <a:p>
+            <a:r>
+              <a:rPr lang="ko-KR" altLang="en-US"/>
+              <a:t>뭐</a:t>
+            </a:r>
+            <a:r>
+              <a:rPr lang="en-US" altLang="ko-KR"/>
+              <a:t>, manual encoding </a:t>
+            </a:r>
+            <a:r>
+              <a:rPr lang="ko-KR" altLang="en-US"/>
+              <a:t>하면 사실 되긴 할텐데 음</a:t>
+            </a:r>
+            <a:r>
+              <a:rPr lang="en-US" altLang="ko-KR"/>
+              <a:t>… </a:t>
+            </a:r>
+            <a:r>
+              <a:rPr lang="ko-KR" altLang="en-US"/>
+              <a:t>난 </a:t>
+            </a:r>
+            <a:r>
+              <a:rPr lang="en-US" altLang="ko-KR"/>
+              <a:t>manual </a:t>
+            </a:r>
+            <a:r>
+              <a:rPr lang="ko-KR" altLang="en-US"/>
+              <a:t>하고싶긴 한데 흠</a:t>
+            </a:r>
+            <a:r>
+              <a:rPr lang="en-US" altLang="ko-KR"/>
+              <a:t>…</a:t>
+            </a:r>
+          </a:p>
+          <a:p>
+            <a:r>
+              <a:rPr lang="ko-KR" altLang="en-US"/>
+              <a:t>대충 알아보기 위해 </a:t>
+            </a:r>
+            <a:r>
+              <a:rPr lang="en-US" altLang="ko-KR"/>
+              <a:t>OrdinalEncoder</a:t>
+            </a:r>
+            <a:r>
+              <a:rPr lang="ko-KR" altLang="en-US"/>
+              <a:t>를 쓴다면</a:t>
+            </a:r>
+            <a:r>
+              <a:rPr lang="en-US" altLang="ko-KR"/>
+              <a:t>… fit</a:t>
+            </a:r>
+            <a:r>
+              <a:rPr lang="ko-KR" altLang="en-US"/>
+              <a:t>할 때 많은 </a:t>
+            </a:r>
+            <a:r>
+              <a:rPr lang="en-US" altLang="ko-KR"/>
+              <a:t>X~ </a:t>
+            </a:r>
+            <a:r>
+              <a:rPr lang="ko-KR" altLang="en-US"/>
+              <a:t>데이터를 놓도록 해보자</a:t>
+            </a:r>
+            <a:endParaRPr lang="en-US" altLang="ko-KR"/>
+          </a:p>
+        </p:txBody>
+      </p:sp>
+      <p:sp>
+        <p:nvSpPr>
+          <p:cNvPr id="5" name="TextBox 4">
+            <a:extLst>
+              <a:ext uri="{FF2B5EF4-FFF2-40B4-BE49-F238E27FC236}">
+                <a16:creationId xmlns:a16="http://schemas.microsoft.com/office/drawing/2014/main" id="{10AC5038-0599-AD69-4513-BA62164B3B6B}"/>
+              </a:ext>
+            </a:extLst>
+          </p:cNvPr>
+          <p:cNvSpPr txBox="1"/>
+          <p:nvPr/>
+        </p:nvSpPr>
+        <p:spPr>
+          <a:xfrm>
+            <a:off x="6096000" y="5288340"/>
+            <a:ext cx="6096000" cy="1569660"/>
+          </a:xfrm>
+          <a:prstGeom prst="rect">
+            <a:avLst/>
+          </a:prstGeom>
+          <a:noFill/>
+        </p:spPr>
+        <p:txBody>
+          <a:bodyPr wrap="square">
+            <a:spAutoFit/>
+          </a:bodyPr>
+          <a:lstStyle/>
+          <a:p>
+            <a:r>
+              <a:rPr lang="en-US" sz="1200"/>
+              <a:t>from sklearn.preprocessing import OrdinalEncoder</a:t>
+            </a:r>
+          </a:p>
+          <a:p>
+            <a:endParaRPr lang="en-US" sz="1200"/>
+          </a:p>
+          <a:p>
+            <a:r>
+              <a:rPr lang="en-US" sz="1200"/>
+              <a:t>ordinal_encoder = OrdinalEncoder()# Make copy to avoid changing original data</a:t>
+            </a:r>
+          </a:p>
+          <a:p>
+            <a:r>
+              <a:rPr lang="en-US" sz="1200"/>
+              <a:t>label_X_train = X_train.copy()</a:t>
+            </a:r>
+          </a:p>
+          <a:p>
+            <a:r>
+              <a:rPr lang="en-US" sz="1200"/>
+              <a:t>label_X_valid = X_valid.copy()</a:t>
+            </a:r>
+          </a:p>
+          <a:p>
+            <a:r>
+              <a:rPr lang="en-US" sz="1200"/>
+              <a:t>label_X_train[object_cols] = ordinal_encoder.fit_transform(X_train[object_cols])label_X_valid[object_cols] = ordinal_encoder.transform(X_valid[object_cols])</a:t>
+            </a:r>
+          </a:p>
+        </p:txBody>
+      </p:sp>
+      <p:pic>
+        <p:nvPicPr>
+          <p:cNvPr id="8" name="Picture 7">
+            <a:extLst>
+              <a:ext uri="{FF2B5EF4-FFF2-40B4-BE49-F238E27FC236}">
+                <a16:creationId xmlns:a16="http://schemas.microsoft.com/office/drawing/2014/main" id="{B0614E39-779B-2436-CF4D-AED5248A3A0F}"/>
+              </a:ext>
+            </a:extLst>
+          </p:cNvPr>
+          <p:cNvPicPr>
+            <a:picLocks noChangeAspect="1"/>
+          </p:cNvPicPr>
+          <p:nvPr/>
+        </p:nvPicPr>
+        <p:blipFill>
+          <a:blip r:embed="rId2"/>
+          <a:stretch>
+            <a:fillRect/>
+          </a:stretch>
+        </p:blipFill>
+        <p:spPr>
+          <a:xfrm>
+            <a:off x="9031027" y="3687566"/>
+            <a:ext cx="3017040" cy="1719307"/>
+          </a:xfrm>
+          <a:prstGeom prst="rect">
+            <a:avLst/>
+          </a:prstGeom>
+        </p:spPr>
+      </p:pic>
     </p:spTree>
     <p:extLst>
       <p:ext uri="{BB962C8B-B14F-4D97-AF65-F5344CB8AC3E}">
         <p14:creationId xmlns:p14="http://schemas.microsoft.com/office/powerpoint/2010/main" val="3427583918"/>
+      </p:ext>
+    </p:extLst>
+  </p:cSld>
+  <p:clrMapOvr>
+    <a:masterClrMapping/>
+  </p:clrMapOvr>
+</p:sld>
+</file>
+
+<file path=ppt/slides/slide28.xml><?xml version="1.0" encoding="utf-8"?>
+<p:sld xmlns:a="http://schemas.openxmlformats.org/drawingml/2006/main" xmlns:r="http://schemas.openxmlformats.org/officeDocument/2006/relationships" xmlns:p="http://schemas.openxmlformats.org/presentationml/2006/main">
+  <p:cSld>
+    <p:spTree>
+      <p:nvGrpSpPr>
+        <p:cNvPr id="1" name=""/>
+        <p:cNvGrpSpPr/>
+        <p:nvPr/>
+      </p:nvGrpSpPr>
+      <p:grpSpPr>
+        <a:xfrm>
+          <a:off x="0" y="0"/>
+          <a:ext cx="0" cy="0"/>
+          <a:chOff x="0" y="0"/>
+          <a:chExt cx="0" cy="0"/>
+        </a:xfrm>
+      </p:grpSpPr>
+      <p:sp>
+        <p:nvSpPr>
+          <p:cNvPr id="2" name="Title 1">
+            <a:extLst>
+              <a:ext uri="{FF2B5EF4-FFF2-40B4-BE49-F238E27FC236}">
+                <a16:creationId xmlns:a16="http://schemas.microsoft.com/office/drawing/2014/main" id="{32F388B2-A949-3D54-C846-B6ACFBAA1787}"/>
+              </a:ext>
+            </a:extLst>
+          </p:cNvPr>
+          <p:cNvSpPr>
+            <a:spLocks noGrp="1"/>
+          </p:cNvSpPr>
+          <p:nvPr>
+            <p:ph type="title"/>
+          </p:nvPr>
+        </p:nvSpPr>
+        <p:spPr/>
+        <p:txBody>
+          <a:bodyPr/>
+          <a:lstStyle/>
+          <a:p>
+            <a:endParaRPr lang="en-US"/>
+          </a:p>
+        </p:txBody>
+      </p:sp>
+      <p:pic>
+        <p:nvPicPr>
+          <p:cNvPr id="7" name="Content Placeholder 6">
+            <a:extLst>
+              <a:ext uri="{FF2B5EF4-FFF2-40B4-BE49-F238E27FC236}">
+                <a16:creationId xmlns:a16="http://schemas.microsoft.com/office/drawing/2014/main" id="{1A855448-1023-074D-DB4C-B84B9C9C53FE}"/>
+              </a:ext>
+            </a:extLst>
+          </p:cNvPr>
+          <p:cNvPicPr>
+            <a:picLocks noGrp="1" noChangeAspect="1"/>
+          </p:cNvPicPr>
+          <p:nvPr>
+            <p:ph idx="1"/>
+          </p:nvPr>
+        </p:nvPicPr>
+        <p:blipFill>
+          <a:blip r:embed="rId2"/>
+          <a:stretch>
+            <a:fillRect/>
+          </a:stretch>
+        </p:blipFill>
+        <p:spPr>
+          <a:xfrm>
+            <a:off x="3108742" y="1825625"/>
+            <a:ext cx="5974516" cy="4351338"/>
+          </a:xfrm>
+          <a:prstGeom prst="rect">
+            <a:avLst/>
+          </a:prstGeom>
+        </p:spPr>
+      </p:pic>
+    </p:spTree>
+    <p:extLst>
+      <p:ext uri="{BB962C8B-B14F-4D97-AF65-F5344CB8AC3E}">
+        <p14:creationId xmlns:p14="http://schemas.microsoft.com/office/powerpoint/2010/main" val="316764743"/>
+      </p:ext>
+    </p:extLst>
+  </p:cSld>
+  <p:clrMapOvr>
+    <a:masterClrMapping/>
+  </p:clrMapOvr>
+</p:sld>
+</file>
+
+<file path=ppt/slides/slide29.xml><?xml version="1.0" encoding="utf-8"?>
+<p:sld xmlns:a="http://schemas.openxmlformats.org/drawingml/2006/main" xmlns:r="http://schemas.openxmlformats.org/officeDocument/2006/relationships" xmlns:p="http://schemas.openxmlformats.org/presentationml/2006/main">
+  <p:cSld>
+    <p:spTree>
+      <p:nvGrpSpPr>
+        <p:cNvPr id="1" name=""/>
+        <p:cNvGrpSpPr/>
+        <p:nvPr/>
+      </p:nvGrpSpPr>
+      <p:grpSpPr>
+        <a:xfrm>
+          <a:off x="0" y="0"/>
+          <a:ext cx="0" cy="0"/>
+          <a:chOff x="0" y="0"/>
+          <a:chExt cx="0" cy="0"/>
+        </a:xfrm>
+      </p:grpSpPr>
+      <p:sp>
+        <p:nvSpPr>
+          <p:cNvPr id="2" name="Title 1">
+            <a:extLst>
+              <a:ext uri="{FF2B5EF4-FFF2-40B4-BE49-F238E27FC236}">
+                <a16:creationId xmlns:a16="http://schemas.microsoft.com/office/drawing/2014/main" id="{847F3223-B417-1860-327B-841C3DD1A7EA}"/>
+              </a:ext>
+            </a:extLst>
+          </p:cNvPr>
+          <p:cNvSpPr>
+            <a:spLocks noGrp="1"/>
+          </p:cNvSpPr>
+          <p:nvPr>
+            <p:ph type="title"/>
+          </p:nvPr>
+        </p:nvSpPr>
+        <p:spPr/>
+        <p:txBody>
+          <a:bodyPr/>
+          <a:lstStyle/>
+          <a:p>
+            <a:endParaRPr lang="en-US"/>
+          </a:p>
+        </p:txBody>
+      </p:sp>
+      <p:pic>
+        <p:nvPicPr>
+          <p:cNvPr id="5" name="Content Placeholder 4">
+            <a:extLst>
+              <a:ext uri="{FF2B5EF4-FFF2-40B4-BE49-F238E27FC236}">
+                <a16:creationId xmlns:a16="http://schemas.microsoft.com/office/drawing/2014/main" id="{BD89D8DA-1F6D-8422-E3F1-03055EC1E8F2}"/>
+              </a:ext>
+            </a:extLst>
+          </p:cNvPr>
+          <p:cNvPicPr>
+            <a:picLocks noGrp="1" noChangeAspect="1"/>
+          </p:cNvPicPr>
+          <p:nvPr>
+            <p:ph idx="1"/>
+          </p:nvPr>
+        </p:nvPicPr>
+        <p:blipFill>
+          <a:blip r:embed="rId2"/>
+          <a:stretch>
+            <a:fillRect/>
+          </a:stretch>
+        </p:blipFill>
+        <p:spPr>
+          <a:xfrm>
+            <a:off x="2494417" y="1825625"/>
+            <a:ext cx="7203166" cy="4351338"/>
+          </a:xfrm>
+          <a:prstGeom prst="rect">
+            <a:avLst/>
+          </a:prstGeom>
+        </p:spPr>
+      </p:pic>
+    </p:spTree>
+    <p:extLst>
+      <p:ext uri="{BB962C8B-B14F-4D97-AF65-F5344CB8AC3E}">
+        <p14:creationId xmlns:p14="http://schemas.microsoft.com/office/powerpoint/2010/main" val="3987659921"/>
       </p:ext>
     </p:extLst>
   </p:cSld>
@@ -8583,6 +9407,467 @@
     <p:extLst>
       <p:ext uri="{BB962C8B-B14F-4D97-AF65-F5344CB8AC3E}">
         <p14:creationId xmlns:p14="http://schemas.microsoft.com/office/powerpoint/2010/main" val="2638628424"/>
+      </p:ext>
+    </p:extLst>
+  </p:cSld>
+  <p:clrMapOvr>
+    <a:masterClrMapping/>
+  </p:clrMapOvr>
+</p:sld>
+</file>
+
+<file path=ppt/slides/slide30.xml><?xml version="1.0" encoding="utf-8"?>
+<p:sld xmlns:a="http://schemas.openxmlformats.org/drawingml/2006/main" xmlns:r="http://schemas.openxmlformats.org/officeDocument/2006/relationships" xmlns:p="http://schemas.openxmlformats.org/presentationml/2006/main">
+  <p:cSld>
+    <p:spTree>
+      <p:nvGrpSpPr>
+        <p:cNvPr id="1" name=""/>
+        <p:cNvGrpSpPr/>
+        <p:nvPr/>
+      </p:nvGrpSpPr>
+      <p:grpSpPr>
+        <a:xfrm>
+          <a:off x="0" y="0"/>
+          <a:ext cx="0" cy="0"/>
+          <a:chOff x="0" y="0"/>
+          <a:chExt cx="0" cy="0"/>
+        </a:xfrm>
+      </p:grpSpPr>
+      <p:sp>
+        <p:nvSpPr>
+          <p:cNvPr id="2" name="Title 1">
+            <a:extLst>
+              <a:ext uri="{FF2B5EF4-FFF2-40B4-BE49-F238E27FC236}">
+                <a16:creationId xmlns:a16="http://schemas.microsoft.com/office/drawing/2014/main" id="{47F24514-8CD4-099C-FDFC-6218E5B7492A}"/>
+              </a:ext>
+            </a:extLst>
+          </p:cNvPr>
+          <p:cNvSpPr>
+            <a:spLocks noGrp="1"/>
+          </p:cNvSpPr>
+          <p:nvPr>
+            <p:ph type="title"/>
+          </p:nvPr>
+        </p:nvSpPr>
+        <p:spPr/>
+        <p:txBody>
+          <a:bodyPr/>
+          <a:lstStyle/>
+          <a:p>
+            <a:endParaRPr lang="en-US"/>
+          </a:p>
+        </p:txBody>
+      </p:sp>
+      <p:pic>
+        <p:nvPicPr>
+          <p:cNvPr id="5" name="Content Placeholder 4">
+            <a:extLst>
+              <a:ext uri="{FF2B5EF4-FFF2-40B4-BE49-F238E27FC236}">
+                <a16:creationId xmlns:a16="http://schemas.microsoft.com/office/drawing/2014/main" id="{E6BA1224-4BAB-74BC-2E5D-BC71401471DD}"/>
+              </a:ext>
+            </a:extLst>
+          </p:cNvPr>
+          <p:cNvPicPr>
+            <a:picLocks noGrp="1" noChangeAspect="1"/>
+          </p:cNvPicPr>
+          <p:nvPr>
+            <p:ph idx="1"/>
+          </p:nvPr>
+        </p:nvPicPr>
+        <p:blipFill>
+          <a:blip r:embed="rId2"/>
+          <a:stretch>
+            <a:fillRect/>
+          </a:stretch>
+        </p:blipFill>
+        <p:spPr>
+          <a:xfrm>
+            <a:off x="2437889" y="2186528"/>
+            <a:ext cx="7316221" cy="3629532"/>
+          </a:xfrm>
+          <a:prstGeom prst="rect">
+            <a:avLst/>
+          </a:prstGeom>
+        </p:spPr>
+      </p:pic>
+    </p:spTree>
+    <p:extLst>
+      <p:ext uri="{BB962C8B-B14F-4D97-AF65-F5344CB8AC3E}">
+        <p14:creationId xmlns:p14="http://schemas.microsoft.com/office/powerpoint/2010/main" val="3859614508"/>
+      </p:ext>
+    </p:extLst>
+  </p:cSld>
+  <p:clrMapOvr>
+    <a:masterClrMapping/>
+  </p:clrMapOvr>
+</p:sld>
+</file>
+
+<file path=ppt/slides/slide31.xml><?xml version="1.0" encoding="utf-8"?>
+<p:sld xmlns:a="http://schemas.openxmlformats.org/drawingml/2006/main" xmlns:r="http://schemas.openxmlformats.org/officeDocument/2006/relationships" xmlns:p="http://schemas.openxmlformats.org/presentationml/2006/main">
+  <p:cSld>
+    <p:spTree>
+      <p:nvGrpSpPr>
+        <p:cNvPr id="1" name=""/>
+        <p:cNvGrpSpPr/>
+        <p:nvPr/>
+      </p:nvGrpSpPr>
+      <p:grpSpPr>
+        <a:xfrm>
+          <a:off x="0" y="0"/>
+          <a:ext cx="0" cy="0"/>
+          <a:chOff x="0" y="0"/>
+          <a:chExt cx="0" cy="0"/>
+        </a:xfrm>
+      </p:grpSpPr>
+      <p:sp>
+        <p:nvSpPr>
+          <p:cNvPr id="2" name="Title 1">
+            <a:extLst>
+              <a:ext uri="{FF2B5EF4-FFF2-40B4-BE49-F238E27FC236}">
+                <a16:creationId xmlns:a16="http://schemas.microsoft.com/office/drawing/2014/main" id="{644D3759-935A-3200-6AD2-E4B14A7C2E7D}"/>
+              </a:ext>
+            </a:extLst>
+          </p:cNvPr>
+          <p:cNvSpPr>
+            <a:spLocks noGrp="1"/>
+          </p:cNvSpPr>
+          <p:nvPr>
+            <p:ph type="title"/>
+          </p:nvPr>
+        </p:nvSpPr>
+        <p:spPr/>
+        <p:txBody>
+          <a:bodyPr/>
+          <a:lstStyle/>
+          <a:p>
+            <a:endParaRPr lang="en-US"/>
+          </a:p>
+        </p:txBody>
+      </p:sp>
+      <p:pic>
+        <p:nvPicPr>
+          <p:cNvPr id="5" name="Content Placeholder 4">
+            <a:extLst>
+              <a:ext uri="{FF2B5EF4-FFF2-40B4-BE49-F238E27FC236}">
+                <a16:creationId xmlns:a16="http://schemas.microsoft.com/office/drawing/2014/main" id="{CCC96942-8A6D-A43F-C738-6ABFD69A28BD}"/>
+              </a:ext>
+            </a:extLst>
+          </p:cNvPr>
+          <p:cNvPicPr>
+            <a:picLocks noGrp="1" noChangeAspect="1"/>
+          </p:cNvPicPr>
+          <p:nvPr>
+            <p:ph idx="1"/>
+          </p:nvPr>
+        </p:nvPicPr>
+        <p:blipFill>
+          <a:blip r:embed="rId2"/>
+          <a:stretch>
+            <a:fillRect/>
+          </a:stretch>
+        </p:blipFill>
+        <p:spPr>
+          <a:xfrm>
+            <a:off x="2466468" y="2424686"/>
+            <a:ext cx="7259063" cy="3153215"/>
+          </a:xfrm>
+          <a:prstGeom prst="rect">
+            <a:avLst/>
+          </a:prstGeom>
+        </p:spPr>
+      </p:pic>
+    </p:spTree>
+    <p:extLst>
+      <p:ext uri="{BB962C8B-B14F-4D97-AF65-F5344CB8AC3E}">
+        <p14:creationId xmlns:p14="http://schemas.microsoft.com/office/powerpoint/2010/main" val="2903907358"/>
+      </p:ext>
+    </p:extLst>
+  </p:cSld>
+  <p:clrMapOvr>
+    <a:masterClrMapping/>
+  </p:clrMapOvr>
+</p:sld>
+</file>
+
+<file path=ppt/slides/slide32.xml><?xml version="1.0" encoding="utf-8"?>
+<p:sld xmlns:a="http://schemas.openxmlformats.org/drawingml/2006/main" xmlns:r="http://schemas.openxmlformats.org/officeDocument/2006/relationships" xmlns:p="http://schemas.openxmlformats.org/presentationml/2006/main">
+  <p:cSld>
+    <p:spTree>
+      <p:nvGrpSpPr>
+        <p:cNvPr id="1" name=""/>
+        <p:cNvGrpSpPr/>
+        <p:nvPr/>
+      </p:nvGrpSpPr>
+      <p:grpSpPr>
+        <a:xfrm>
+          <a:off x="0" y="0"/>
+          <a:ext cx="0" cy="0"/>
+          <a:chOff x="0" y="0"/>
+          <a:chExt cx="0" cy="0"/>
+        </a:xfrm>
+      </p:grpSpPr>
+      <p:sp>
+        <p:nvSpPr>
+          <p:cNvPr id="2" name="Title 1">
+            <a:extLst>
+              <a:ext uri="{FF2B5EF4-FFF2-40B4-BE49-F238E27FC236}">
+                <a16:creationId xmlns:a16="http://schemas.microsoft.com/office/drawing/2014/main" id="{E9660E28-2CB3-4021-38E6-FD2DC1CC2AFB}"/>
+              </a:ext>
+            </a:extLst>
+          </p:cNvPr>
+          <p:cNvSpPr>
+            <a:spLocks noGrp="1"/>
+          </p:cNvSpPr>
+          <p:nvPr>
+            <p:ph type="title"/>
+          </p:nvPr>
+        </p:nvSpPr>
+        <p:spPr/>
+        <p:txBody>
+          <a:bodyPr/>
+          <a:lstStyle/>
+          <a:p>
+            <a:endParaRPr lang="en-US"/>
+          </a:p>
+        </p:txBody>
+      </p:sp>
+      <p:pic>
+        <p:nvPicPr>
+          <p:cNvPr id="7" name="Content Placeholder 6">
+            <a:extLst>
+              <a:ext uri="{FF2B5EF4-FFF2-40B4-BE49-F238E27FC236}">
+                <a16:creationId xmlns:a16="http://schemas.microsoft.com/office/drawing/2014/main" id="{B3B3B59D-2DF0-3E0F-AE34-66D95299973A}"/>
+              </a:ext>
+            </a:extLst>
+          </p:cNvPr>
+          <p:cNvPicPr>
+            <a:picLocks noGrp="1" noChangeAspect="1"/>
+          </p:cNvPicPr>
+          <p:nvPr>
+            <p:ph idx="1"/>
+          </p:nvPr>
+        </p:nvPicPr>
+        <p:blipFill>
+          <a:blip r:embed="rId2"/>
+          <a:stretch>
+            <a:fillRect/>
+          </a:stretch>
+        </p:blipFill>
+        <p:spPr>
+          <a:xfrm>
+            <a:off x="2361679" y="3224898"/>
+            <a:ext cx="7468642" cy="1552792"/>
+          </a:xfrm>
+          <a:prstGeom prst="rect">
+            <a:avLst/>
+          </a:prstGeom>
+        </p:spPr>
+      </p:pic>
+    </p:spTree>
+    <p:extLst>
+      <p:ext uri="{BB962C8B-B14F-4D97-AF65-F5344CB8AC3E}">
+        <p14:creationId xmlns:p14="http://schemas.microsoft.com/office/powerpoint/2010/main" val="2992969454"/>
+      </p:ext>
+    </p:extLst>
+  </p:cSld>
+  <p:clrMapOvr>
+    <a:masterClrMapping/>
+  </p:clrMapOvr>
+</p:sld>
+</file>
+
+<file path=ppt/slides/slide33.xml><?xml version="1.0" encoding="utf-8"?>
+<p:sld xmlns:a="http://schemas.openxmlformats.org/drawingml/2006/main" xmlns:r="http://schemas.openxmlformats.org/officeDocument/2006/relationships" xmlns:p="http://schemas.openxmlformats.org/presentationml/2006/main">
+  <p:cSld>
+    <p:spTree>
+      <p:nvGrpSpPr>
+        <p:cNvPr id="1" name=""/>
+        <p:cNvGrpSpPr/>
+        <p:nvPr/>
+      </p:nvGrpSpPr>
+      <p:grpSpPr>
+        <a:xfrm>
+          <a:off x="0" y="0"/>
+          <a:ext cx="0" cy="0"/>
+          <a:chOff x="0" y="0"/>
+          <a:chExt cx="0" cy="0"/>
+        </a:xfrm>
+      </p:grpSpPr>
+      <p:sp>
+        <p:nvSpPr>
+          <p:cNvPr id="2" name="Title 1">
+            <a:extLst>
+              <a:ext uri="{FF2B5EF4-FFF2-40B4-BE49-F238E27FC236}">
+                <a16:creationId xmlns:a16="http://schemas.microsoft.com/office/drawing/2014/main" id="{ED81622B-0D3F-89B7-0737-2C75B80E4C1B}"/>
+              </a:ext>
+            </a:extLst>
+          </p:cNvPr>
+          <p:cNvSpPr>
+            <a:spLocks noGrp="1"/>
+          </p:cNvSpPr>
+          <p:nvPr>
+            <p:ph type="title"/>
+          </p:nvPr>
+        </p:nvSpPr>
+        <p:spPr/>
+        <p:txBody>
+          <a:bodyPr/>
+          <a:lstStyle/>
+          <a:p>
+            <a:r>
+              <a:rPr lang="en-US"/>
+              <a:t>Feature Importance…!</a:t>
+            </a:r>
+          </a:p>
+        </p:txBody>
+      </p:sp>
+      <p:pic>
+        <p:nvPicPr>
+          <p:cNvPr id="5" name="Content Placeholder 4">
+            <a:extLst>
+              <a:ext uri="{FF2B5EF4-FFF2-40B4-BE49-F238E27FC236}">
+                <a16:creationId xmlns:a16="http://schemas.microsoft.com/office/drawing/2014/main" id="{FF25AF81-3C4F-36E6-87CC-57F698E8DDB3}"/>
+              </a:ext>
+            </a:extLst>
+          </p:cNvPr>
+          <p:cNvPicPr>
+            <a:picLocks noGrp="1" noChangeAspect="1"/>
+          </p:cNvPicPr>
+          <p:nvPr>
+            <p:ph idx="1"/>
+          </p:nvPr>
+        </p:nvPicPr>
+        <p:blipFill>
+          <a:blip r:embed="rId2"/>
+          <a:stretch>
+            <a:fillRect/>
+          </a:stretch>
+        </p:blipFill>
+        <p:spPr>
+          <a:xfrm>
+            <a:off x="1" y="1690688"/>
+            <a:ext cx="4910328" cy="2552616"/>
+          </a:xfrm>
+          <a:prstGeom prst="rect">
+            <a:avLst/>
+          </a:prstGeom>
+        </p:spPr>
+      </p:pic>
+      <p:pic>
+        <p:nvPicPr>
+          <p:cNvPr id="7" name="Picture 6">
+            <a:extLst>
+              <a:ext uri="{FF2B5EF4-FFF2-40B4-BE49-F238E27FC236}">
+                <a16:creationId xmlns:a16="http://schemas.microsoft.com/office/drawing/2014/main" id="{CF03ABE7-27EF-27D4-1CDD-FAC8DF12867F}"/>
+              </a:ext>
+            </a:extLst>
+          </p:cNvPr>
+          <p:cNvPicPr>
+            <a:picLocks noChangeAspect="1"/>
+          </p:cNvPicPr>
+          <p:nvPr/>
+        </p:nvPicPr>
+        <p:blipFill>
+          <a:blip r:embed="rId3"/>
+          <a:stretch>
+            <a:fillRect/>
+          </a:stretch>
+        </p:blipFill>
+        <p:spPr>
+          <a:xfrm>
+            <a:off x="4742410" y="4924155"/>
+            <a:ext cx="7449590" cy="1933845"/>
+          </a:xfrm>
+          <a:prstGeom prst="rect">
+            <a:avLst/>
+          </a:prstGeom>
+        </p:spPr>
+      </p:pic>
+    </p:spTree>
+    <p:extLst>
+      <p:ext uri="{BB962C8B-B14F-4D97-AF65-F5344CB8AC3E}">
+        <p14:creationId xmlns:p14="http://schemas.microsoft.com/office/powerpoint/2010/main" val="3406510311"/>
+      </p:ext>
+    </p:extLst>
+  </p:cSld>
+  <p:clrMapOvr>
+    <a:masterClrMapping/>
+  </p:clrMapOvr>
+</p:sld>
+</file>
+
+<file path=ppt/slides/slide34.xml><?xml version="1.0" encoding="utf-8"?>
+<p:sld xmlns:a="http://schemas.openxmlformats.org/drawingml/2006/main" xmlns:r="http://schemas.openxmlformats.org/officeDocument/2006/relationships" xmlns:p="http://schemas.openxmlformats.org/presentationml/2006/main">
+  <p:cSld>
+    <p:spTree>
+      <p:nvGrpSpPr>
+        <p:cNvPr id="1" name=""/>
+        <p:cNvGrpSpPr/>
+        <p:nvPr/>
+      </p:nvGrpSpPr>
+      <p:grpSpPr>
+        <a:xfrm>
+          <a:off x="0" y="0"/>
+          <a:ext cx="0" cy="0"/>
+          <a:chOff x="0" y="0"/>
+          <a:chExt cx="0" cy="0"/>
+        </a:xfrm>
+      </p:grpSpPr>
+      <p:sp>
+        <p:nvSpPr>
+          <p:cNvPr id="2" name="Title 1">
+            <a:extLst>
+              <a:ext uri="{FF2B5EF4-FFF2-40B4-BE49-F238E27FC236}">
+                <a16:creationId xmlns:a16="http://schemas.microsoft.com/office/drawing/2014/main" id="{29356E04-5589-CD8F-1492-66866A9DF230}"/>
+              </a:ext>
+            </a:extLst>
+          </p:cNvPr>
+          <p:cNvSpPr>
+            <a:spLocks noGrp="1"/>
+          </p:cNvSpPr>
+          <p:nvPr>
+            <p:ph type="title"/>
+          </p:nvPr>
+        </p:nvSpPr>
+        <p:spPr/>
+        <p:txBody>
+          <a:bodyPr/>
+          <a:lstStyle/>
+          <a:p>
+            <a:endParaRPr lang="en-US"/>
+          </a:p>
+        </p:txBody>
+      </p:sp>
+      <p:sp>
+        <p:nvSpPr>
+          <p:cNvPr id="3" name="Content Placeholder 2">
+            <a:extLst>
+              <a:ext uri="{FF2B5EF4-FFF2-40B4-BE49-F238E27FC236}">
+                <a16:creationId xmlns:a16="http://schemas.microsoft.com/office/drawing/2014/main" id="{321E09D6-52AD-68A5-9BC1-E2BF3A65F909}"/>
+              </a:ext>
+            </a:extLst>
+          </p:cNvPr>
+          <p:cNvSpPr>
+            <a:spLocks noGrp="1"/>
+          </p:cNvSpPr>
+          <p:nvPr>
+            <p:ph idx="1"/>
+          </p:nvPr>
+        </p:nvSpPr>
+        <p:spPr/>
+        <p:txBody>
+          <a:bodyPr/>
+          <a:lstStyle/>
+          <a:p>
+            <a:endParaRPr lang="en-US"/>
+          </a:p>
+        </p:txBody>
+      </p:sp>
+    </p:spTree>
+    <p:extLst>
+      <p:ext uri="{BB962C8B-B14F-4D97-AF65-F5344CB8AC3E}">
+        <p14:creationId xmlns:p14="http://schemas.microsoft.com/office/powerpoint/2010/main" val="193481010"/>
       </p:ext>
     </p:extLst>
   </p:cSld>

</xml_diff>

<commit_message>
Day 7 complete - Pipelines, CV, XGBoost complete, DataLeakage to do
</commit_message>
<xml_diff>
--- a/Kaggle!.pptx
+++ b/Kaggle!.pptx
@@ -5,7 +5,7 @@
     <p:sldMasterId id="2147483648" r:id="rId1"/>
   </p:sldMasterIdLst>
   <p:notesMasterIdLst>
-    <p:notesMasterId r:id="rId36"/>
+    <p:notesMasterId r:id="rId39"/>
   </p:notesMasterIdLst>
   <p:sldIdLst>
     <p:sldId id="256" r:id="rId2"/>
@@ -42,6 +42,9 @@
     <p:sldId id="288" r:id="rId33"/>
     <p:sldId id="289" r:id="rId34"/>
     <p:sldId id="290" r:id="rId35"/>
+    <p:sldId id="291" r:id="rId36"/>
+    <p:sldId id="292" r:id="rId37"/>
+    <p:sldId id="293" r:id="rId38"/>
   </p:sldIdLst>
   <p:sldSz cx="12192000" cy="6858000"/>
   <p:notesSz cx="6858000" cy="9144000"/>
@@ -230,7 +233,7 @@
           <a:p>
             <a:fld id="{696CDF9F-ADA0-4C49-A263-B2AE48107B92}" type="datetimeFigureOut">
               <a:rPr lang="en-US" smtClean="0"/>
-              <a:t>3/6/2026</a:t>
+              <a:t>3/20/2026</a:t>
             </a:fld>
             <a:endParaRPr lang="en-US"/>
           </a:p>
@@ -812,7 +815,7 @@
           <a:p>
             <a:fld id="{8B8BF7D9-AC52-4AC2-BEDB-A5D1257FD4A4}" type="datetimeFigureOut">
               <a:rPr lang="en-US" smtClean="0"/>
-              <a:t>3/6/2026</a:t>
+              <a:t>3/20/2026</a:t>
             </a:fld>
             <a:endParaRPr lang="en-US"/>
           </a:p>
@@ -1010,7 +1013,7 @@
           <a:p>
             <a:fld id="{8B8BF7D9-AC52-4AC2-BEDB-A5D1257FD4A4}" type="datetimeFigureOut">
               <a:rPr lang="en-US" smtClean="0"/>
-              <a:t>3/6/2026</a:t>
+              <a:t>3/20/2026</a:t>
             </a:fld>
             <a:endParaRPr lang="en-US"/>
           </a:p>
@@ -1218,7 +1221,7 @@
           <a:p>
             <a:fld id="{8B8BF7D9-AC52-4AC2-BEDB-A5D1257FD4A4}" type="datetimeFigureOut">
               <a:rPr lang="en-US" smtClean="0"/>
-              <a:t>3/6/2026</a:t>
+              <a:t>3/20/2026</a:t>
             </a:fld>
             <a:endParaRPr lang="en-US"/>
           </a:p>
@@ -1416,7 +1419,7 @@
           <a:p>
             <a:fld id="{8B8BF7D9-AC52-4AC2-BEDB-A5D1257FD4A4}" type="datetimeFigureOut">
               <a:rPr lang="en-US" smtClean="0"/>
-              <a:t>3/6/2026</a:t>
+              <a:t>3/20/2026</a:t>
             </a:fld>
             <a:endParaRPr lang="en-US"/>
           </a:p>
@@ -1691,7 +1694,7 @@
           <a:p>
             <a:fld id="{8B8BF7D9-AC52-4AC2-BEDB-A5D1257FD4A4}" type="datetimeFigureOut">
               <a:rPr lang="en-US" smtClean="0"/>
-              <a:t>3/6/2026</a:t>
+              <a:t>3/20/2026</a:t>
             </a:fld>
             <a:endParaRPr lang="en-US"/>
           </a:p>
@@ -1956,7 +1959,7 @@
           <a:p>
             <a:fld id="{8B8BF7D9-AC52-4AC2-BEDB-A5D1257FD4A4}" type="datetimeFigureOut">
               <a:rPr lang="en-US" smtClean="0"/>
-              <a:t>3/6/2026</a:t>
+              <a:t>3/20/2026</a:t>
             </a:fld>
             <a:endParaRPr lang="en-US"/>
           </a:p>
@@ -2368,7 +2371,7 @@
           <a:p>
             <a:fld id="{8B8BF7D9-AC52-4AC2-BEDB-A5D1257FD4A4}" type="datetimeFigureOut">
               <a:rPr lang="en-US" smtClean="0"/>
-              <a:t>3/6/2026</a:t>
+              <a:t>3/20/2026</a:t>
             </a:fld>
             <a:endParaRPr lang="en-US"/>
           </a:p>
@@ -2509,7 +2512,7 @@
           <a:p>
             <a:fld id="{8B8BF7D9-AC52-4AC2-BEDB-A5D1257FD4A4}" type="datetimeFigureOut">
               <a:rPr lang="en-US" smtClean="0"/>
-              <a:t>3/6/2026</a:t>
+              <a:t>3/20/2026</a:t>
             </a:fld>
             <a:endParaRPr lang="en-US"/>
           </a:p>
@@ -2622,7 +2625,7 @@
           <a:p>
             <a:fld id="{8B8BF7D9-AC52-4AC2-BEDB-A5D1257FD4A4}" type="datetimeFigureOut">
               <a:rPr lang="en-US" smtClean="0"/>
-              <a:t>3/6/2026</a:t>
+              <a:t>3/20/2026</a:t>
             </a:fld>
             <a:endParaRPr lang="en-US"/>
           </a:p>
@@ -2933,7 +2936,7 @@
           <a:p>
             <a:fld id="{8B8BF7D9-AC52-4AC2-BEDB-A5D1257FD4A4}" type="datetimeFigureOut">
               <a:rPr lang="en-US" smtClean="0"/>
-              <a:t>3/6/2026</a:t>
+              <a:t>3/20/2026</a:t>
             </a:fld>
             <a:endParaRPr lang="en-US"/>
           </a:p>
@@ -3221,7 +3224,7 @@
           <a:p>
             <a:fld id="{8B8BF7D9-AC52-4AC2-BEDB-A5D1257FD4A4}" type="datetimeFigureOut">
               <a:rPr lang="en-US" smtClean="0"/>
-              <a:t>3/6/2026</a:t>
+              <a:t>3/20/2026</a:t>
             </a:fld>
             <a:endParaRPr lang="en-US"/>
           </a:p>
@@ -3462,7 +3465,7 @@
           <a:p>
             <a:fld id="{8B8BF7D9-AC52-4AC2-BEDB-A5D1257FD4A4}" type="datetimeFigureOut">
               <a:rPr lang="en-US" smtClean="0"/>
-              <a:t>3/6/2026</a:t>
+              <a:t>3/20/2026</a:t>
             </a:fld>
             <a:endParaRPr lang="en-US"/>
           </a:p>
@@ -9868,6 +9871,246 @@
     <p:extLst>
       <p:ext uri="{BB962C8B-B14F-4D97-AF65-F5344CB8AC3E}">
         <p14:creationId xmlns:p14="http://schemas.microsoft.com/office/powerpoint/2010/main" val="193481010"/>
+      </p:ext>
+    </p:extLst>
+  </p:cSld>
+  <p:clrMapOvr>
+    <a:masterClrMapping/>
+  </p:clrMapOvr>
+</p:sld>
+</file>
+
+<file path=ppt/slides/slide35.xml><?xml version="1.0" encoding="utf-8"?>
+<p:sld xmlns:a="http://schemas.openxmlformats.org/drawingml/2006/main" xmlns:r="http://schemas.openxmlformats.org/officeDocument/2006/relationships" xmlns:p="http://schemas.openxmlformats.org/presentationml/2006/main">
+  <p:cSld>
+    <p:spTree>
+      <p:nvGrpSpPr>
+        <p:cNvPr id="1" name=""/>
+        <p:cNvGrpSpPr/>
+        <p:nvPr/>
+      </p:nvGrpSpPr>
+      <p:grpSpPr>
+        <a:xfrm>
+          <a:off x="0" y="0"/>
+          <a:ext cx="0" cy="0"/>
+          <a:chOff x="0" y="0"/>
+          <a:chExt cx="0" cy="0"/>
+        </a:xfrm>
+      </p:grpSpPr>
+      <p:sp>
+        <p:nvSpPr>
+          <p:cNvPr id="2" name="Title 1">
+            <a:extLst>
+              <a:ext uri="{FF2B5EF4-FFF2-40B4-BE49-F238E27FC236}">
+                <a16:creationId xmlns:a16="http://schemas.microsoft.com/office/drawing/2014/main" id="{29840059-728D-5D93-A4E7-ED5CD43ED372}"/>
+              </a:ext>
+            </a:extLst>
+          </p:cNvPr>
+          <p:cNvSpPr>
+            <a:spLocks noGrp="1"/>
+          </p:cNvSpPr>
+          <p:nvPr>
+            <p:ph type="title"/>
+          </p:nvPr>
+        </p:nvSpPr>
+        <p:spPr/>
+        <p:txBody>
+          <a:bodyPr/>
+          <a:lstStyle/>
+          <a:p>
+            <a:endParaRPr lang="en-US"/>
+          </a:p>
+        </p:txBody>
+      </p:sp>
+      <p:sp>
+        <p:nvSpPr>
+          <p:cNvPr id="3" name="Content Placeholder 2">
+            <a:extLst>
+              <a:ext uri="{FF2B5EF4-FFF2-40B4-BE49-F238E27FC236}">
+                <a16:creationId xmlns:a16="http://schemas.microsoft.com/office/drawing/2014/main" id="{9FC3EA3E-0636-4EA5-0792-3926E48243F1}"/>
+              </a:ext>
+            </a:extLst>
+          </p:cNvPr>
+          <p:cNvSpPr>
+            <a:spLocks noGrp="1"/>
+          </p:cNvSpPr>
+          <p:nvPr>
+            <p:ph idx="1"/>
+          </p:nvPr>
+        </p:nvSpPr>
+        <p:spPr/>
+        <p:txBody>
+          <a:bodyPr/>
+          <a:lstStyle/>
+          <a:p>
+            <a:endParaRPr lang="en-US"/>
+          </a:p>
+        </p:txBody>
+      </p:sp>
+    </p:spTree>
+    <p:extLst>
+      <p:ext uri="{BB962C8B-B14F-4D97-AF65-F5344CB8AC3E}">
+        <p14:creationId xmlns:p14="http://schemas.microsoft.com/office/powerpoint/2010/main" val="2343121556"/>
+      </p:ext>
+    </p:extLst>
+  </p:cSld>
+  <p:clrMapOvr>
+    <a:masterClrMapping/>
+  </p:clrMapOvr>
+</p:sld>
+</file>
+
+<file path=ppt/slides/slide36.xml><?xml version="1.0" encoding="utf-8"?>
+<p:sld xmlns:a="http://schemas.openxmlformats.org/drawingml/2006/main" xmlns:r="http://schemas.openxmlformats.org/officeDocument/2006/relationships" xmlns:p="http://schemas.openxmlformats.org/presentationml/2006/main">
+  <p:cSld>
+    <p:spTree>
+      <p:nvGrpSpPr>
+        <p:cNvPr id="1" name=""/>
+        <p:cNvGrpSpPr/>
+        <p:nvPr/>
+      </p:nvGrpSpPr>
+      <p:grpSpPr>
+        <a:xfrm>
+          <a:off x="0" y="0"/>
+          <a:ext cx="0" cy="0"/>
+          <a:chOff x="0" y="0"/>
+          <a:chExt cx="0" cy="0"/>
+        </a:xfrm>
+      </p:grpSpPr>
+      <p:sp>
+        <p:nvSpPr>
+          <p:cNvPr id="2" name="Title 1">
+            <a:extLst>
+              <a:ext uri="{FF2B5EF4-FFF2-40B4-BE49-F238E27FC236}">
+                <a16:creationId xmlns:a16="http://schemas.microsoft.com/office/drawing/2014/main" id="{5A6AA7DC-B489-84B7-7337-D4ED0529C812}"/>
+              </a:ext>
+            </a:extLst>
+          </p:cNvPr>
+          <p:cNvSpPr>
+            <a:spLocks noGrp="1"/>
+          </p:cNvSpPr>
+          <p:nvPr>
+            <p:ph type="title"/>
+          </p:nvPr>
+        </p:nvSpPr>
+        <p:spPr/>
+        <p:txBody>
+          <a:bodyPr/>
+          <a:lstStyle/>
+          <a:p>
+            <a:endParaRPr lang="en-US"/>
+          </a:p>
+        </p:txBody>
+      </p:sp>
+      <p:sp>
+        <p:nvSpPr>
+          <p:cNvPr id="3" name="Content Placeholder 2">
+            <a:extLst>
+              <a:ext uri="{FF2B5EF4-FFF2-40B4-BE49-F238E27FC236}">
+                <a16:creationId xmlns:a16="http://schemas.microsoft.com/office/drawing/2014/main" id="{A42CD2B0-1547-FB00-06CB-51DDE0693038}"/>
+              </a:ext>
+            </a:extLst>
+          </p:cNvPr>
+          <p:cNvSpPr>
+            <a:spLocks noGrp="1"/>
+          </p:cNvSpPr>
+          <p:nvPr>
+            <p:ph idx="1"/>
+          </p:nvPr>
+        </p:nvSpPr>
+        <p:spPr/>
+        <p:txBody>
+          <a:bodyPr/>
+          <a:lstStyle/>
+          <a:p>
+            <a:endParaRPr lang="en-US"/>
+          </a:p>
+        </p:txBody>
+      </p:sp>
+    </p:spTree>
+    <p:extLst>
+      <p:ext uri="{BB962C8B-B14F-4D97-AF65-F5344CB8AC3E}">
+        <p14:creationId xmlns:p14="http://schemas.microsoft.com/office/powerpoint/2010/main" val="1514563577"/>
+      </p:ext>
+    </p:extLst>
+  </p:cSld>
+  <p:clrMapOvr>
+    <a:masterClrMapping/>
+  </p:clrMapOvr>
+</p:sld>
+</file>
+
+<file path=ppt/slides/slide37.xml><?xml version="1.0" encoding="utf-8"?>
+<p:sld xmlns:a="http://schemas.openxmlformats.org/drawingml/2006/main" xmlns:r="http://schemas.openxmlformats.org/officeDocument/2006/relationships" xmlns:p="http://schemas.openxmlformats.org/presentationml/2006/main">
+  <p:cSld>
+    <p:spTree>
+      <p:nvGrpSpPr>
+        <p:cNvPr id="1" name=""/>
+        <p:cNvGrpSpPr/>
+        <p:nvPr/>
+      </p:nvGrpSpPr>
+      <p:grpSpPr>
+        <a:xfrm>
+          <a:off x="0" y="0"/>
+          <a:ext cx="0" cy="0"/>
+          <a:chOff x="0" y="0"/>
+          <a:chExt cx="0" cy="0"/>
+        </a:xfrm>
+      </p:grpSpPr>
+      <p:sp>
+        <p:nvSpPr>
+          <p:cNvPr id="2" name="Title 1">
+            <a:extLst>
+              <a:ext uri="{FF2B5EF4-FFF2-40B4-BE49-F238E27FC236}">
+                <a16:creationId xmlns:a16="http://schemas.microsoft.com/office/drawing/2014/main" id="{BC1CB053-E0FF-3E62-DC20-8E1C9B03CB7C}"/>
+              </a:ext>
+            </a:extLst>
+          </p:cNvPr>
+          <p:cNvSpPr>
+            <a:spLocks noGrp="1"/>
+          </p:cNvSpPr>
+          <p:nvPr>
+            <p:ph type="title"/>
+          </p:nvPr>
+        </p:nvSpPr>
+        <p:spPr/>
+        <p:txBody>
+          <a:bodyPr/>
+          <a:lstStyle/>
+          <a:p>
+            <a:endParaRPr lang="en-US"/>
+          </a:p>
+        </p:txBody>
+      </p:sp>
+      <p:sp>
+        <p:nvSpPr>
+          <p:cNvPr id="3" name="Content Placeholder 2">
+            <a:extLst>
+              <a:ext uri="{FF2B5EF4-FFF2-40B4-BE49-F238E27FC236}">
+                <a16:creationId xmlns:a16="http://schemas.microsoft.com/office/drawing/2014/main" id="{8919AE7D-5C6A-87D8-D503-452CD3D27426}"/>
+              </a:ext>
+            </a:extLst>
+          </p:cNvPr>
+          <p:cNvSpPr>
+            <a:spLocks noGrp="1"/>
+          </p:cNvSpPr>
+          <p:nvPr>
+            <p:ph idx="1"/>
+          </p:nvPr>
+        </p:nvSpPr>
+        <p:spPr/>
+        <p:txBody>
+          <a:bodyPr/>
+          <a:lstStyle/>
+          <a:p>
+            <a:endParaRPr lang="en-US"/>
+          </a:p>
+        </p:txBody>
+      </p:sp>
+    </p:spTree>
+    <p:extLst>
+      <p:ext uri="{BB962C8B-B14F-4D97-AF65-F5344CB8AC3E}">
+        <p14:creationId xmlns:p14="http://schemas.microsoft.com/office/powerpoint/2010/main" val="572697046"/>
       </p:ext>
     </p:extLst>
   </p:cSld>

</xml_diff>